<commit_message>
docs: roteiro de falas em PDF e nomes dos integrantes na apresentação
</commit_message>
<xml_diff>
--- a/docs/entrega-1/apresentacao/apresentacao-entrega-1.pptx
+++ b/docs/entrega-1/apresentacao/apresentacao-entrega-1.pptx
@@ -513,7 +513,7 @@
           <a:p>
             <a:r>
               <a:rPr lang="en-US" dirty="0"/>
-              <a:t>Abertura. O sistema é o Code Burguer's, uma lanchonete online em Java com Servlets e JDBC, baseado no projeto APS-04. Dividimos em cinco áreas, uma por integrante: cada um apresenta a classe que testou, a estratégia, o resultado e o que encontrou. [Completar o nome do quinto integrante antes de apresentar.]</a:t>
+              <a:t>Abertura. O sistema é o Code Burguer's, uma lanchonete online em Java com Servlets e JDBC, baseado no projeto APS-04. Dividimos em cinco áreas, uma por integrante: cada um apresenta a classe que testou, a estratégia, o resultado e o que encontrou.</a:t>
             </a:r>
             <a:endParaRPr lang="en-US" dirty="0"/>
           </a:p>
@@ -2044,7 +2044,7 @@
                 <a:ea typeface="Calibri" pitchFamily="34" charset="-122"/>
                 <a:cs typeface="Calibri" pitchFamily="34" charset="-120"/>
               </a:rPr>
-              <a:t>Yuri Mascarenhas · Vinicius Rocha Pinheiro · Thiago Ferreira Teixeira · Vinicius Fonseca de Freitas · Integrante 5</a:t>
+              <a:t>Yuri Mascarenhas · Vinicius Rocha Pinheiro · Felipe Paixão · Vinicius Fonseca de Freitas · Thiago Ferreira</a:t>
             </a:r>
             <a:endParaRPr lang="en-US" sz="1200" dirty="0"/>
           </a:p>
@@ -2174,7 +2174,7 @@
                 <a:ea typeface="Calibri" pitchFamily="34" charset="-122"/>
                 <a:cs typeface="Calibri" pitchFamily="34" charset="-120"/>
               </a:rPr>
-              <a:t>INSUMOS E ESTOQUE  ·  Integrante 5</a:t>
+              <a:t>INSUMOS E ESTOQUE  ·  Thiago Ferreira</a:t>
             </a:r>
             <a:endParaRPr lang="en-US" sz="1100" dirty="0"/>
           </a:p>
@@ -2818,7 +2818,7 @@
                 <a:ea typeface="Calibri" pitchFamily="34" charset="-122"/>
                 <a:cs typeface="Calibri" pitchFamily="34" charset="-120"/>
               </a:rPr>
-              <a:t>INSUMOS E ESTOQUE  ·  Integrante 5</a:t>
+              <a:t>INSUMOS E ESTOQUE  ·  Thiago Ferreira</a:t>
             </a:r>
             <a:endParaRPr lang="en-US" sz="1100" dirty="0"/>
           </a:p>
@@ -6864,7 +6864,7 @@
                 <a:ea typeface="Calibri" pitchFamily="34" charset="-122"/>
                 <a:cs typeface="Calibri" pitchFamily="34" charset="-120"/>
               </a:rPr>
-              <a:t>CADASTRO DE CLIENTES  ·  Thiago Ferreira Teixeira</a:t>
+              <a:t>CADASTRO DE CLIENTES  ·  Felipe Paixão</a:t>
             </a:r>
             <a:endParaRPr lang="en-US" sz="1100" dirty="0"/>
           </a:p>
@@ -7502,7 +7502,7 @@
                 <a:ea typeface="Calibri" pitchFamily="34" charset="-122"/>
                 <a:cs typeface="Calibri" pitchFamily="34" charset="-120"/>
               </a:rPr>
-              <a:t>CADASTRO DE CLIENTES  ·  Thiago Ferreira Teixeira</a:t>
+              <a:t>CADASTRO DE CLIENTES  ·  Felipe Paixão</a:t>
             </a:r>
             <a:endParaRPr lang="en-US" sz="1100" dirty="0"/>
           </a:p>

</xml_diff>

<commit_message>
docs: roteiro em formato teleprompter e ajustes na apresentação
- falas reescritas em linguagem falada, uma ideia por linha, com marcações de pausa
- cartões de situação e de defeito passam a nomear o responsável e a issue
- Thiago Ferreira em clientes e Felipe Paixão em estoque
- roteiro em PDF paisagem, fonte grande, com cabeçalho de quem fala em cada página
</commit_message>
<xml_diff>
--- a/docs/entrega-1/apresentacao/apresentacao-entrega-1.pptx
+++ b/docs/entrega-1/apresentacao/apresentacao-entrega-1.pptx
@@ -513,7 +513,19 @@
           <a:p>
             <a:r>
               <a:rPr lang="en-US" dirty="0"/>
-              <a:t>Abertura. O sistema é o Code Burguer's, uma lanchonete online em Java com Servlets e JDBC, baseado no projeto APS-04. Dividimos em cinco áreas, uma por integrante: cada um apresenta a classe que testou, a estratégia, o resultado e o que encontrou.</a:t>
+              <a:t>Boa noite, pessoal.
+A gente é o grupo do Code Burguer's.
+É um sistema de lanchonete online, feito em Java, com Servlet e JDBC.
+[PAUSA]
+Só que não fomos nós que escrevemos esse sistema.
+Ele veio pronto, de um projeto antigo.
+O nosso trabalho foi outro: testar ele.
+E achar o que está quebrado.
+[PAUSA]
+A gente dividiu em cinco áreas, uma pra cada um.
+Cada pessoa tem dois slides:
+o que testou, e o que encontrou.
+Adianto que encontramos bastante coisa.</a:t>
             </a:r>
             <a:endParaRPr lang="en-US" dirty="0"/>
           </a:p>
@@ -601,7 +613,25 @@
           <a:p>
             <a:r>
               <a:rPr lang="en-US" dirty="0"/>
-              <a:t>Minha parte é insumos e estoque. Aqui somos transparentes: o DaoIngrediente é CRUD e o sistema não tem regra de estoque, a compra nem dá baixa. Então cobrimos o DAO, que era a issue 5, e escolhemos como classe não CRUD os servlets de insumo, que verificam se quem chama é funcionário e convertem o JSON. Mostramos que um token de cliente não entra no painel.</a:t>
+              <a:t>Minha parte é estoque e insumos.
+E eu vou ser honesto com vocês sobre uma coisa.
+[PAUSA]
+O requisito pedia uma classe que não fosse CRUD,
+com uma complexidade razoável.
+Na minha área, essa classe não existe.
+[PAUSA]
+O DaoIngrediente é CRUD do começo ao fim.
+E o sistema não tem regra de estoque nenhuma:
+quando alguém compra, o estoque não baixa.
+[PAUSA]
+Então a gente fez duas coisas.
+Cobriu o DAO, que era o que a issue cinco pedia.
+E pegou como classe não CRUD os servlets do painel,
+que pelo menos decidem quem pode entrar e quem não pode.
+[PAUSA]
+Essa é a limitação do nosso trabalho, e ela está escrita no slide.
+A gente preferiu deixar visível
+a inventar uma classe só pra fechar cinco nomes.</a:t>
             </a:r>
             <a:endParaRPr lang="en-US" dirty="0"/>
           </a:p>
@@ -689,7 +719,24 @@
           <a:p>
             <a:r>
               <a:rPr lang="en-US" dirty="0"/>
-              <a:t>São 16 testes passando e os 6 ramos do DAO cobertos. O defeito: quantidade e valores negativos são aceitos e gravados, sem validação no servlet nem restrição no banco. Não afirmamos que o preço de venda precisa ser maior que o de compra, porque nada no sistema sustenta essa regra. O CT-05 manual ainda está pendente, issue 10.</a:t>
+              <a:t>16 testes passando.
+[PAUSA]
+O defeito daqui: o painel aceita número negativo.
+[PAUSA]
+Cadastra um insumo com quantidade menos cinco, ele aceita.
+Preço de compra negativo, aceita também.
+E responde Ingrediente salvo.
+[PAUSA]
+Não tem validação no servlet,
+e o banco também não tem restrição nenhuma.
+Issue vinte e cinco.
+[PAUSA]
+E tem uma coisa que a gente decidiu não fazer.
+[PAUSA]
+Não escrevemos teste dizendo
+que preço de venda tem que ser maior que o de compra.
+Parece óbvio, mas não existe nada no sistema que diga isso.
+A gente testa o que está escrito, não o que a gente acha.</a:t>
             </a:r>
             <a:endParaRPr lang="en-US" dirty="0"/>
           </a:p>
@@ -777,7 +824,30 @@
           <a:p>
             <a:r>
               <a:rPr lang="en-US" dirty="0"/>
-              <a:t>Fechamento. A suíte tem 115 testes unitários passando. Separamos 5 testes que descrevem o comportamento correto e ficam vermelhos enquanto os defeitos existirem; eles rodam com mvn test -Pdefeitos. No total documentamos 6 defeitos. Sendo honestos sobre os limites: dois testes manuais ainda não foram executados, a área de estoque não tem uma classe de regra de negócio porque o sistema não tem essa regra, e não corrigimos nenhum defeito, porque o objetivo da entrega era testar e reportar.</a:t>
+              <a:t>Fechando.
+[PAUSA]
+115 testes rodando, todos passando.
+[PAUSA]
+Mais cinco testes que ficam vermelhos de propósito.
+Eles descrevem como deveria funcionar,
+e falham enquanto o defeito existir.
+[PAUSA]
+E seis defeitos abertos no GitHub, da issue vinte até a vinte e cinco.
+[PAUSA]
+O que ficou faltando, e a gente não vai esconder:
+dois testes manuais ainda não rodaram, o CT-03 e o CT-05.
+A área de estoque ficou sem classe de regra de negócio,
+como eu mostrei ali atrás.
+E a gente não corrigiu nenhum defeito,
+porque o objetivo dessa entrega era encontrar e registrar.
+[PAUSA]
+Uma última coisa, porque é fácil confundir:
+cobertura alta não quer dizer que não tem defeito.
+Quer dizer só que aquele trecho foi executado.
+[PAUSA]
+Tanto é que a gente tem cobertura alta e seis defeitos.
+[PAUSA]
+É isso. Obrigado, e a gente está aberto pra perguntas.</a:t>
             </a:r>
             <a:endParaRPr lang="en-US" dirty="0"/>
           </a:p>
@@ -865,7 +935,25 @@
           <a:p>
             <a:r>
               <a:rPr lang="en-US" dirty="0"/>
-              <a:t>Minha parte é autenticação e sessão. A classe é o ValidadorCookie: ela não é CRUD, só recebe os cookies da requisição, procura o cookie certo pelo nome e pergunta ao DaoToken se o token existe. Nos testes o DaoToken é um mock, então nada depende de banco. Além dos casos básicos, testamos as fronteiras: requisição sem cookie, token de cliente tentando passar por funcionário, cookie duplicado e valor malformado. Para demonstrar: abrir ValidadorCookieLimitesTest e rodar mvn test -Dtest=ValidadorCookie*.</a:t>
+              <a:t>Minha parte é login e sessão.
+A classe chama ValidadorCookie.
+[PAUSA]
+O que ela faz dá pra explicar em uma frase:
+chega uma requisição, ela olha os cookies,
+procura o cookie chamado token,
+e pergunta pro banco se aquele token existe.
+[PAUSA]
+Por que ela não é CRUD?
+Porque ela não salva e não lê tabela nenhuma.
+Ela decide. Ela olha o nome do cookie e escolhe o caminho.
+[PAUSA]
+Nos testes o banco é falso, a gente usa Mockito.
+Então roda em menos de um segundo, sem subir nada.
+[PAUSA]
+E não testamos só o caminho feliz.
+Testamos requisição sem cookie nenhum,
+token de cliente tentando entrar como funcionário,
+e esse aí do slide: cookie repetido.</a:t>
             </a:r>
             <a:endParaRPr lang="en-US" dirty="0"/>
           </a:p>
@@ -953,7 +1041,21 @@
           <a:p>
             <a:r>
               <a:rPr lang="en-US" dirty="0"/>
-              <a:t>São 26 testes passando e todos os 22 ramos da classe cobertos. O achado mais interessante: procuramos a regra de expiração de token e ela não existe no servidor. A tabela só guarda o texto do token; quem expira é o cookie no navegador, em 30 minutos. Registramos como observação de segurança, não inventamos um resultado. O teste manual é o CT-01, issue 6.</a:t>
+              <a:t>26 testes passando.
+E os 22 ramos da classe cobertos.
+Ou seja: todo if e todo else foi executado pelo menos uma vez.
+[PAUSA]
+Agora a parte interessante.
+A gente foi procurar onde o token expira.
+[PAUSA]
+E descobriu que ele não expira.
+[PAUSA]
+No servidor, a tabela guarda só o texto do token. Nada mais.
+Quem expira é o cookie no navegador, em 30 minutos.
+Só que se alguém copiar aquele token, ele funciona pra sempre.
+[PAUSA]
+A gente não inventou uma regra que não existe.
+Registrou como observação de segurança, e está no slide.</a:t>
             </a:r>
             <a:endParaRPr lang="en-US" dirty="0"/>
           </a:p>
@@ -1041,7 +1143,23 @@
           <a:p>
             <a:r>
               <a:rPr lang="en-US" dirty="0"/>
-              <a:t>Minha parte é o carrinho. A classe é o servlet comprar, que tem regra de verdade: valida o cookie, lê o JSON que o carrinho.js monta, separa lanche de bebida, soma o total e grava os vínculos. Mockamos o validador e os quatro DAOs e usamos ArgumentCaptor para olhar o Pedido que chega no DAO. O valor esperado não sai do próprio código: usamos a conta que a tela do carrinho faz, preço vezes quantidade.</a:t>
+              <a:t>Minha parte é o carrinho e o fechamento do pedido.
+A classe é o servlet comprar.
+[PAUSA]
+Ele tem regra de verdade:
+valida o cookie, lê o JSON que o carrinho manda,
+separa o que é lanche e o que é bebida,
+soma o total, e grava o pedido com os itens.
+[PAUSA]
+O detalhe importante do meu teste é esse:
+eu não acredito na mensagem que o sistema responde.
+[PAUSA]
+Eu pego o Pedido que ele manda pro banco e abro pra conferir.
+O total, o cliente, a quantidade de cada item.
+[PAUSA]
+Porque dá pra um teste passar só olhando
+a mensagem Pedido salvo com sucesso,
+e o pedido estar todo errado por dentro.</a:t>
             </a:r>
             <a:endParaRPr lang="en-US" dirty="0"/>
           </a:p>
@@ -1129,7 +1247,25 @@
           <a:p>
             <a:r>
               <a:rPr lang="en-US" dirty="0"/>
-              <a:t>São 22 testes passando na suíte normal e dois testes que ficam vermelhos de propósito na suíte de defeitos. O primeiro: com 2 lanches de 15 e 1 refrigerante de 5 a tela mostra 35, mas o servlet grava 20, porque soma o preço uma vez por item. O segundo: o id do cliente vem do JSON e nunca é comparado com o cookie. Para demonstrar: mvn test -Pdefeitos -Dtest=ComprarRegrasTest.</a:t>
+              <a:t>22 testes passando.
+E dois vermelhos de propósito. Já explico o porquê.
+[PAUSA]
+Põe no carrinho dois lanches de quinze reais
+e um refrigerante de cinco.
+A tela mostra trinta e cinco.
+[PAUSA]
+O que o sistema grava no banco? Vinte.
+[PAUSA]
+Ele soma o preço uma vez por item e ignora a quantidade.
+Na prática: quanto mais você compra, mais barato fica.
+Essa é a issue vinte e um.
+[PAUSA]
+E tem outra, a vinte e dois, que é pior.
+O id do cliente vem do JSON que o navegador manda.
+O sistema nunca compara com o cookie de quem está logado.
+[PAUSA]
+Então eu, logado na minha conta,
+consigo fazer um pedido no nome de qualquer um de vocês.</a:t>
             </a:r>
             <a:endParaRPr lang="en-US" dirty="0"/>
           </a:p>
@@ -1217,7 +1353,25 @@
           <a:p>
             <a:r>
               <a:rPr lang="en-US" dirty="0"/>
-              <a:t>Minha parte é o cadastro de clientes. O DaoCliente é um DAO, mas o login tem uma decisão: só entra se o hash MD5 bater e o cliente estiver ativo. E o salvar reaproveita um endereço que já existe. Completamos com duas classes que não são CRUD: o servlet cadastro e o EncryptadorMD5. Simplificamos o teste antigo, que usava Objenesis e reflexão, para injeção por construtor. O hash esperado vem dos vetores da RFC, inclusive o MD5 de 'a', que começa com zero e testa o preenchimento.</a:t>
+              <a:t>Minha parte é o cadastro e o login do cliente.
+São três classes: o DaoCliente, o servlet de cadastro e o EncryptadorMD5.
+[PAUSA]
+O DaoCliente é um DAO, então tem bastante CRUD nele.
+Mas o método login tem uma decisão de verdade:
+só entra se o hash da senha bater
+e se o cliente estiver ativo.
+[PAUSA]
+Uma coisa que a gente mudou e que vale comentar:
+o teste que já existia usava Objenesis e reflexão
+pra conseguir enfiar um banco falso dentro da classe.
+Funcionava, mas ninguém entendia ao ler.
+[PAUSA]
+A gente trocou por um construtor normal, que recebe a conexão.
+Ficou bem mais simples.
+[PAUSA]
+E o hash esperado a gente não tirou do próprio sistema.
+Se o sistema estiver errado, o teste erraria junto.
+Pegamos da tabela oficial do MD5.</a:t>
             </a:r>
             <a:endParaRPr lang="en-US" dirty="0"/>
           </a:p>
@@ -1305,7 +1459,28 @@
           <a:p>
             <a:r>
               <a:rPr lang="en-US" dirty="0"/>
-              <a:t>São 29 testes passando. Defeitos: o servidor grava cliente com nome, usuário e senha vazios, e a validação da tela também não funciona por causa de uma condição sempre falsa no JavaScript. Outro: a busca por usuário concatena texto no SQL, então um apóstrofo quebra o login. O MD5 foi tratado como comportamento legado, só caracterizamos. O CT-03 manual ainda está pendente, issue 8.</a:t>
+              <a:t>29 testes passando.
+E aqui aparecem dois problemas.
+[PAUSA]
+O primeiro: o cadastro aceita campo vazio.
+Nome vazio, usuário vazio, senha vazia.
+O servidor grava e responde Usuário cadastrado.
+[PAUSA]
+Aí vocês perguntam: mas a tela não valida?
+Não valida.
+[PAUSA]
+Tem um if no JavaScript escrito errado,
+que nunca é verdadeiro.
+Então aquele alerta de campo obrigatório nunca aparece.
+Essa é a issue vinte e quatro.
+[PAUSA]
+O segundo é a busca por usuário.
+Ela monta o SQL colando texto.
+[PAUSA]
+Então se a pessoa se chama O'Brien, com apóstrofo, o login quebra.
+E se ela for esperta, digita SQL no campo de usuário
+e o banco executa.
+Issue vinte e três.</a:t>
             </a:r>
             <a:endParaRPr lang="en-US" dirty="0"/>
           </a:p>
@@ -1393,7 +1568,23 @@
           <a:p>
             <a:r>
               <a:rPr lang="en-US" dirty="0"/>
-              <a:t>Minha parte é a montagem de lanches. O DaoLanche é CRUD, então a regra que escolhemos está no servlet salvarLancheCliente: ele calcula o preço somando valor de venda vezes quantidade de cada ingrediente, grava o lanche como inativo e deveria vincular os ingredientes. O teste calcula o preço esperado à mão: 2 queijos, 3 bacons e 1 pão dá 18,50.</a:t>
+              <a:t>Minha parte é a montagem do lanche personalizado.
+Aquela tela onde o cliente escolhe pão, carne, queijo, bacon.
+[PAUSA]
+O DaoLanche é CRUD puro,
+então a regra que eu testei está no servlet.
+[PAUSA]
+Ele faz três coisas:
+calcula o preço somando ingrediente por ingrediente,
+salva o lanche como inativo, porque não é do cardápio,
+e liga cada ingrediente ao lanche.
+[PAUSA]
+No teste eu faço a conta na mão:
+dois queijos, três bacons e um pão dá dezoito e cinquenta.
+[PAUSA]
+Se eu deixasse o teste usar a conta do próprio código,
+o código poderia mudar e o teste mudaria junto, sem reclamar.
+Fazendo na mão, ele reclama.</a:t>
             </a:r>
             <a:endParaRPr lang="en-US" dirty="0"/>
           </a:p>
@@ -1481,7 +1672,29 @@
           <a:p>
             <a:r>
               <a:rPr lang="en-US" dirty="0"/>
-              <a:t>Tínhamos uma suspeita de que os ingredientes não eram salvos. Investigamos: o DaoLanche faz o INSERT normalmente. O problema é no servlet, que usa o mesmo Iterator em dois laços; o primeiro consome tudo e o segundo nunca executa. O teste espera 3 vínculos e recebe zero. No teste manual CT-04, feito em 20 de setembro, o botão Adicionar não respondeu, e isso virou a issue 17. Demonstração: mvn test -Pdefeitos -Dtest=SalvarLancheClienteTest.</a:t>
+              <a:t>Esse slide é o meu favorito.
+[PAUSA]
+A gente já desconfiava que os ingredientes não estavam sendo salvos.
+E a suspeita era do DaoLanche.
+[PAUSA]
+Fomos olhar: o DaoLanche está certo.
+Ele executa o INSERT normalmente.
+[PAUSA]
+O problema está no servlet.
+Tem dois laços lá, um embaixo do outro, usando o mesmo Iterator.
+[PAUSA]
+O primeiro laço, o do preço, consome tudo.
+Quando chega no segundo, o que liga os ingredientes,
+não sobrou nada. Ele simplesmente não roda.
+[PAUSA]
+O teste esperava três ingredientes ligados ao lanche.
+Recebeu zero.
+[PAUSA]
+E olha que interessante: isso bate com o teste manual.
+Dia vinte eu montei um lanche na mão,
+cliquei em Adicionar, e não aconteceu nada.
+Virou a issue dezessete.
+Agora a gente sabe o motivo, que é a issue vinte.</a:t>
             </a:r>
             <a:endParaRPr lang="en-US" dirty="0"/>
           </a:p>
@@ -2044,7 +2257,7 @@
                 <a:ea typeface="Calibri" pitchFamily="34" charset="-122"/>
                 <a:cs typeface="Calibri" pitchFamily="34" charset="-120"/>
               </a:rPr>
-              <a:t>Yuri Mascarenhas · Vinicius Rocha Pinheiro · Felipe Paixão · Vinicius Fonseca de Freitas · Thiago Ferreira</a:t>
+              <a:t>Yuri Mascarenhas · Vinicius Rocha Pinheiro · Thiago Ferreira · Vinicius Fonseca de Freitas · Felipe Paixão</a:t>
             </a:r>
             <a:endParaRPr lang="en-US" sz="1200" dirty="0"/>
           </a:p>
@@ -2174,7 +2387,7 @@
                 <a:ea typeface="Calibri" pitchFamily="34" charset="-122"/>
                 <a:cs typeface="Calibri" pitchFamily="34" charset="-120"/>
               </a:rPr>
-              <a:t>INSUMOS E ESTOQUE  ·  Thiago Ferreira</a:t>
+              <a:t>INSUMOS E ESTOQUE  ·  Felipe Paixão</a:t>
             </a:r>
             <a:endParaRPr lang="en-US" sz="1100" dirty="0"/>
           </a:p>
@@ -2818,7 +3031,7 @@
                 <a:ea typeface="Calibri" pitchFamily="34" charset="-122"/>
                 <a:cs typeface="Calibri" pitchFamily="34" charset="-120"/>
               </a:rPr>
-              <a:t>INSUMOS E ESTOQUE  ·  Thiago Ferreira</a:t>
+              <a:t>INSUMOS E ESTOQUE  ·  Felipe Paixão</a:t>
             </a:r>
             <a:endParaRPr lang="en-US" sz="1100" dirty="0"/>
           </a:p>
@@ -3210,7 +3423,7 @@
         </p:nvSpPr>
         <p:spPr>
           <a:xfrm>
-            <a:off x="2926080" y="2743200"/>
+            <a:off x="2926080" y="2651760"/>
             <a:ext cx="2468880" cy="201168"/>
           </a:xfrm>
           <a:prstGeom prst="rect">
@@ -3249,8 +3462,8 @@
         </p:nvSpPr>
         <p:spPr>
           <a:xfrm>
-            <a:off x="2926080" y="2962656"/>
-            <a:ext cx="2468880" cy="1645920"/>
+            <a:off x="2926080" y="2871216"/>
+            <a:ext cx="2468880" cy="1600200"/>
           </a:xfrm>
           <a:prstGeom prst="rect">
             <a:avLst/>
@@ -3274,7 +3487,7 @@
                 <a:ea typeface="Calibri" pitchFamily="34" charset="-122"/>
                 <a:cs typeface="Calibri" pitchFamily="34" charset="-120"/>
               </a:rPr>
-              <a:t>Issue #10 aberta: execução manual pendente.</a:t>
+              <a:t>Responsável: Felipe Paixão. Não executado — issue #10 aberta. Roteiro pronto: cadastrar insumo com quantidade -5 e zerar o estoque pelo painel.</a:t>
             </a:r>
             <a:endParaRPr lang="en-US" sz="1300" dirty="0"/>
           </a:p>
@@ -3316,23 +3529,23 @@
         <p:spPr>
           <a:xfrm>
             <a:off x="6035040" y="1371600"/>
-            <a:ext cx="2468880" cy="228600"/>
-          </a:xfrm>
-          <a:prstGeom prst="rect">
-            <a:avLst/>
-          </a:prstGeom>
-          <a:noFill/>
-          <a:ln/>
-        </p:spPr>
-        <p:txBody>
-          <a:bodyPr wrap="square" lIns="0" tIns="0" rIns="0" bIns="0" rtlCol="0" anchor="t"/>
-          <a:lstStyle/>
-          <a:p>
-            <a:pPr indent="0" marL="0">
-              <a:buNone/>
-            </a:pPr>
-            <a:r>
-              <a:rPr lang="en-US" sz="1000" b="1" spc="100" kern="0" dirty="0">
+            <a:ext cx="2468880" cy="457200"/>
+          </a:xfrm>
+          <a:prstGeom prst="rect">
+            <a:avLst/>
+          </a:prstGeom>
+          <a:noFill/>
+          <a:ln/>
+        </p:spPr>
+        <p:txBody>
+          <a:bodyPr wrap="square" lIns="0" tIns="0" rIns="0" bIns="0" rtlCol="0" anchor="t"/>
+          <a:lstStyle/>
+          <a:p>
+            <a:pPr indent="0" marL="0">
+              <a:buNone/>
+            </a:pPr>
+            <a:r>
+              <a:rPr lang="en-US" sz="950" b="1" spc="100" kern="0" dirty="0">
                 <a:solidFill>
                   <a:srgbClr val="F2A900"/>
                 </a:solidFill>
@@ -3340,7 +3553,46 @@
                 <a:ea typeface="Calibri" pitchFamily="34" charset="-122"/>
                 <a:cs typeface="Calibri" pitchFamily="34" charset="-120"/>
               </a:rPr>
-              <a:t>DEFEITO DEF-07</a:t>
+              <a:t>ISSUE #25 · DEF-07</a:t>
+            </a:r>
+            <a:endParaRPr lang="en-US" sz="950" dirty="0"/>
+          </a:p>
+        </p:txBody>
+      </p:sp>
+      <p:sp>
+        <p:nvSpPr>
+          <p:cNvPr id="19" name="Text 17"/>
+          <p:cNvSpPr txBox="1"/>
+          <p:nvPr/>
+        </p:nvSpPr>
+        <p:spPr>
+          <a:xfrm>
+            <a:off x="6035040" y="1874520"/>
+            <a:ext cx="2468880" cy="274320"/>
+          </a:xfrm>
+          <a:prstGeom prst="rect">
+            <a:avLst/>
+          </a:prstGeom>
+          <a:noFill/>
+          <a:ln/>
+        </p:spPr>
+        <p:txBody>
+          <a:bodyPr wrap="square" lIns="0" tIns="0" rIns="0" bIns="0" rtlCol="0" anchor="t"/>
+          <a:lstStyle/>
+          <a:p>
+            <a:pPr indent="0" marL="0">
+              <a:buNone/>
+            </a:pPr>
+            <a:r>
+              <a:rPr lang="en-US" sz="1000" i="1" dirty="0">
+                <a:solidFill>
+                  <a:srgbClr val="E8DFDB"/>
+                </a:solidFill>
+                <a:latin typeface="Calibri" pitchFamily="34" charset="0"/>
+                <a:ea typeface="Calibri" pitchFamily="34" charset="-122"/>
+                <a:cs typeface="Calibri" pitchFamily="34" charset="-120"/>
+              </a:rPr>
+              <a:t>Área de Felipe Paixão</a:t>
             </a:r>
             <a:endParaRPr lang="en-US" sz="1000" dirty="0"/>
           </a:p>
@@ -3348,30 +3600,30 @@
       </p:sp>
       <p:sp>
         <p:nvSpPr>
-          <p:cNvPr id="19" name="Text 17"/>
-          <p:cNvSpPr txBox="1"/>
-          <p:nvPr/>
-        </p:nvSpPr>
-        <p:spPr>
-          <a:xfrm>
-            <a:off x="6035040" y="1691640"/>
-            <a:ext cx="2468880" cy="2743200"/>
-          </a:xfrm>
-          <a:prstGeom prst="rect">
-            <a:avLst/>
-          </a:prstGeom>
-          <a:noFill/>
-          <a:ln/>
-        </p:spPr>
-        <p:txBody>
-          <a:bodyPr wrap="square" lIns="0" tIns="0" rIns="0" bIns="0" rtlCol="0" anchor="t"/>
-          <a:lstStyle/>
-          <a:p>
-            <a:pPr indent="0" marL="0">
-              <a:buNone/>
-            </a:pPr>
-            <a:r>
-              <a:rPr lang="en-US" sz="1300" dirty="0">
+          <p:cNvPr id="20" name="Text 18"/>
+          <p:cNvSpPr txBox="1"/>
+          <p:nvPr/>
+        </p:nvSpPr>
+        <p:spPr>
+          <a:xfrm>
+            <a:off x="6035040" y="2240280"/>
+            <a:ext cx="2468880" cy="2194560"/>
+          </a:xfrm>
+          <a:prstGeom prst="rect">
+            <a:avLst/>
+          </a:prstGeom>
+          <a:noFill/>
+          <a:ln/>
+        </p:spPr>
+        <p:txBody>
+          <a:bodyPr wrap="square" lIns="0" tIns="0" rIns="0" bIns="0" rtlCol="0" anchor="t"/>
+          <a:lstStyle/>
+          <a:p>
+            <a:pPr indent="0" marL="0">
+              <a:buNone/>
+            </a:pPr>
+            <a:r>
+              <a:rPr lang="en-US" sz="1250" dirty="0">
                 <a:solidFill>
                   <a:srgbClr val="FFFFFF"/>
                 </a:solidFill>
@@ -3381,13 +3633,13 @@
               </a:rPr>
               <a:t>Quantidade -5 e valores negativos são aceitos: 'Ingrediente Salvo!'. Não há validação no servlet nem CHECK no banco. Não assumimos regra de 'venda maior que compra'.</a:t>
             </a:r>
-            <a:endParaRPr lang="en-US" sz="1300" dirty="0"/>
-          </a:p>
-        </p:txBody>
-      </p:sp>
-      <p:sp>
-        <p:nvSpPr>
-          <p:cNvPr id="20" name="Text 18"/>
+            <a:endParaRPr lang="en-US" sz="1250" dirty="0"/>
+          </a:p>
+        </p:txBody>
+      </p:sp>
+      <p:sp>
+        <p:nvSpPr>
+          <p:cNvPr id="21" name="Text 19"/>
           <p:cNvSpPr txBox="1"/>
           <p:nvPr/>
         </p:nvSpPr>
@@ -3774,7 +4026,7 @@
                 <a:ea typeface="Calibri" pitchFamily="34" charset="-122"/>
                 <a:cs typeface="Calibri" pitchFamily="34" charset="-120"/>
               </a:rPr>
-              <a:t>DEF-01 a 05 e DEF-07</a:t>
+              <a:t>issues #20 a #25 no GitHub</a:t>
             </a:r>
             <a:endParaRPr lang="en-US" sz="1200" dirty="0"/>
           </a:p>
@@ -3856,7 +4108,7 @@
                 <a:ea typeface="Calibri" pitchFamily="34" charset="-122"/>
                 <a:cs typeface="Calibri" pitchFamily="34" charset="-120"/>
               </a:rPr>
-              <a:t>Testes manuais CT-03 e CT-05 ainda não executados; CT-04 executado com falha (issue #17).</a:t>
+              <a:t>CT-03 (Thiago Ferreira) e CT-05 (Felipe Paixão) ainda não executados; CT-04 executado por Vinicius Fonseca com falha.</a:t>
             </a:r>
             <a:endParaRPr lang="en-US" sz="1300" dirty="0"/>
           </a:p>
@@ -5135,7 +5387,7 @@
         </p:nvSpPr>
         <p:spPr>
           <a:xfrm>
-            <a:off x="2926080" y="2743200"/>
+            <a:off x="2926080" y="2651760"/>
             <a:ext cx="2468880" cy="201168"/>
           </a:xfrm>
           <a:prstGeom prst="rect">
@@ -5174,8 +5426,8 @@
         </p:nvSpPr>
         <p:spPr>
           <a:xfrm>
-            <a:off x="2926080" y="2962656"/>
-            <a:ext cx="2468880" cy="1645920"/>
+            <a:off x="2926080" y="2871216"/>
+            <a:ext cx="2468880" cy="1600200"/>
           </a:xfrm>
           <a:prstGeom prst="rect">
             <a:avLst/>
@@ -5199,7 +5451,7 @@
                 <a:ea typeface="Calibri" pitchFamily="34" charset="-122"/>
                 <a:cs typeface="Calibri" pitchFamily="34" charset="-120"/>
               </a:rPr>
-              <a:t>Issue #6 fechada pelo grupo. Registro da execução no documento do grupo.</a:t>
+              <a:t>Responsável: Yuri Mascarenhas. Issue #6 fechada pelo grupo. O documento do caso, no formato do CT-04, não está no repositório.</a:t>
             </a:r>
             <a:endParaRPr lang="en-US" sz="1300" dirty="0"/>
           </a:p>
@@ -5241,23 +5493,23 @@
         <p:spPr>
           <a:xfrm>
             <a:off x="6035040" y="1371600"/>
-            <a:ext cx="2468880" cy="228600"/>
-          </a:xfrm>
-          <a:prstGeom prst="rect">
-            <a:avLst/>
-          </a:prstGeom>
-          <a:noFill/>
-          <a:ln/>
-        </p:spPr>
-        <p:txBody>
-          <a:bodyPr wrap="square" lIns="0" tIns="0" rIns="0" bIns="0" rtlCol="0" anchor="t"/>
-          <a:lstStyle/>
-          <a:p>
-            <a:pPr indent="0" marL="0">
-              <a:buNone/>
-            </a:pPr>
-            <a:r>
-              <a:rPr lang="en-US" sz="1000" b="1" spc="100" kern="0" dirty="0">
+            <a:ext cx="2468880" cy="457200"/>
+          </a:xfrm>
+          <a:prstGeom prst="rect">
+            <a:avLst/>
+          </a:prstGeom>
+          <a:noFill/>
+          <a:ln/>
+        </p:spPr>
+        <p:txBody>
+          <a:bodyPr wrap="square" lIns="0" tIns="0" rIns="0" bIns="0" rtlCol="0" anchor="t"/>
+          <a:lstStyle/>
+          <a:p>
+            <a:pPr indent="0" marL="0">
+              <a:buNone/>
+            </a:pPr>
+            <a:r>
+              <a:rPr lang="en-US" sz="950" b="1" spc="100" kern="0" dirty="0">
                 <a:solidFill>
                   <a:srgbClr val="F2A900"/>
                 </a:solidFill>
@@ -5265,7 +5517,46 @@
                 <a:ea typeface="Calibri" pitchFamily="34" charset="-122"/>
                 <a:cs typeface="Calibri" pitchFamily="34" charset="-120"/>
               </a:rPr>
-              <a:t>OBSERVAÇÃO</a:t>
+              <a:t>OBSERVAÇÃO DE SEGURANÇA</a:t>
+            </a:r>
+            <a:endParaRPr lang="en-US" sz="950" dirty="0"/>
+          </a:p>
+        </p:txBody>
+      </p:sp>
+      <p:sp>
+        <p:nvSpPr>
+          <p:cNvPr id="19" name="Text 17"/>
+          <p:cNvSpPr txBox="1"/>
+          <p:nvPr/>
+        </p:nvSpPr>
+        <p:spPr>
+          <a:xfrm>
+            <a:off x="6035040" y="1874520"/>
+            <a:ext cx="2468880" cy="274320"/>
+          </a:xfrm>
+          <a:prstGeom prst="rect">
+            <a:avLst/>
+          </a:prstGeom>
+          <a:noFill/>
+          <a:ln/>
+        </p:spPr>
+        <p:txBody>
+          <a:bodyPr wrap="square" lIns="0" tIns="0" rIns="0" bIns="0" rtlCol="0" anchor="t"/>
+          <a:lstStyle/>
+          <a:p>
+            <a:pPr indent="0" marL="0">
+              <a:buNone/>
+            </a:pPr>
+            <a:r>
+              <a:rPr lang="en-US" sz="1000" i="1" dirty="0">
+                <a:solidFill>
+                  <a:srgbClr val="E8DFDB"/>
+                </a:solidFill>
+                <a:latin typeface="Calibri" pitchFamily="34" charset="0"/>
+                <a:ea typeface="Calibri" pitchFamily="34" charset="-122"/>
+                <a:cs typeface="Calibri" pitchFamily="34" charset="-120"/>
+              </a:rPr>
+              <a:t>Área de Yuri Mascarenhas</a:t>
             </a:r>
             <a:endParaRPr lang="en-US" sz="1000" dirty="0"/>
           </a:p>
@@ -5273,30 +5564,30 @@
       </p:sp>
       <p:sp>
         <p:nvSpPr>
-          <p:cNvPr id="19" name="Text 17"/>
-          <p:cNvSpPr txBox="1"/>
-          <p:nvPr/>
-        </p:nvSpPr>
-        <p:spPr>
-          <a:xfrm>
-            <a:off x="6035040" y="1691640"/>
-            <a:ext cx="2468880" cy="2743200"/>
-          </a:xfrm>
-          <a:prstGeom prst="rect">
-            <a:avLst/>
-          </a:prstGeom>
-          <a:noFill/>
-          <a:ln/>
-        </p:spPr>
-        <p:txBody>
-          <a:bodyPr wrap="square" lIns="0" tIns="0" rIns="0" bIns="0" rtlCol="0" anchor="t"/>
-          <a:lstStyle/>
-          <a:p>
-            <a:pPr indent="0" marL="0">
-              <a:buNone/>
-            </a:pPr>
-            <a:r>
-              <a:rPr lang="en-US" sz="1300" dirty="0">
+          <p:cNvPr id="20" name="Text 18"/>
+          <p:cNvSpPr txBox="1"/>
+          <p:nvPr/>
+        </p:nvSpPr>
+        <p:spPr>
+          <a:xfrm>
+            <a:off x="6035040" y="2240280"/>
+            <a:ext cx="2468880" cy="2194560"/>
+          </a:xfrm>
+          <a:prstGeom prst="rect">
+            <a:avLst/>
+          </a:prstGeom>
+          <a:noFill/>
+          <a:ln/>
+        </p:spPr>
+        <p:txBody>
+          <a:bodyPr wrap="square" lIns="0" tIns="0" rIns="0" bIns="0" rtlCol="0" anchor="t"/>
+          <a:lstStyle/>
+          <a:p>
+            <a:pPr indent="0" marL="0">
+              <a:buNone/>
+            </a:pPr>
+            <a:r>
+              <a:rPr lang="en-US" sz="1250" dirty="0">
                 <a:solidFill>
                   <a:srgbClr val="FFFFFF"/>
                 </a:solidFill>
@@ -5306,13 +5597,13 @@
               </a:rPr>
               <a:t>Não existe expiração de token no servidor: tb_tokens guarda só o texto. O único prazo é o MaxAge de 30 min do cookie no navegador.</a:t>
             </a:r>
-            <a:endParaRPr lang="en-US" sz="1300" dirty="0"/>
-          </a:p>
-        </p:txBody>
-      </p:sp>
-      <p:sp>
-        <p:nvSpPr>
-          <p:cNvPr id="20" name="Text 18"/>
+            <a:endParaRPr lang="en-US" sz="1250" dirty="0"/>
+          </a:p>
+        </p:txBody>
+      </p:sp>
+      <p:sp>
+        <p:nvSpPr>
+          <p:cNvPr id="21" name="Text 19"/>
           <p:cNvSpPr txBox="1"/>
           <p:nvPr/>
         </p:nvSpPr>
@@ -6526,7 +6817,7 @@
         </p:nvSpPr>
         <p:spPr>
           <a:xfrm>
-            <a:off x="2926080" y="2743200"/>
+            <a:off x="2926080" y="2651760"/>
             <a:ext cx="2468880" cy="201168"/>
           </a:xfrm>
           <a:prstGeom prst="rect">
@@ -6565,8 +6856,8 @@
         </p:nvSpPr>
         <p:spPr>
           <a:xfrm>
-            <a:off x="2926080" y="2962656"/>
-            <a:ext cx="2468880" cy="1645920"/>
+            <a:off x="2926080" y="2871216"/>
+            <a:ext cx="2468880" cy="1600200"/>
           </a:xfrm>
           <a:prstGeom prst="rect">
             <a:avLst/>
@@ -6590,7 +6881,7 @@
                 <a:ea typeface="Calibri" pitchFamily="34" charset="-122"/>
                 <a:cs typeface="Calibri" pitchFamily="34" charset="-120"/>
               </a:rPr>
-              <a:t>Issue #7 fechada pelo grupo. Registro da execução no documento do grupo.</a:t>
+              <a:t>Responsável: Vinicius Rocha Pinheiro. Issue #7 fechada pelo grupo. O documento do caso, no formato do CT-04, não está no repositório.</a:t>
             </a:r>
             <a:endParaRPr lang="en-US" sz="1300" dirty="0"/>
           </a:p>
@@ -6632,23 +6923,23 @@
         <p:spPr>
           <a:xfrm>
             <a:off x="6035040" y="1371600"/>
-            <a:ext cx="2468880" cy="228600"/>
-          </a:xfrm>
-          <a:prstGeom prst="rect">
-            <a:avLst/>
-          </a:prstGeom>
-          <a:noFill/>
-          <a:ln/>
-        </p:spPr>
-        <p:txBody>
-          <a:bodyPr wrap="square" lIns="0" tIns="0" rIns="0" bIns="0" rtlCol="0" anchor="t"/>
-          <a:lstStyle/>
-          <a:p>
-            <a:pPr indent="0" marL="0">
-              <a:buNone/>
-            </a:pPr>
-            <a:r>
-              <a:rPr lang="en-US" sz="1000" b="1" spc="100" kern="0" dirty="0">
+            <a:ext cx="2468880" cy="457200"/>
+          </a:xfrm>
+          <a:prstGeom prst="rect">
+            <a:avLst/>
+          </a:prstGeom>
+          <a:noFill/>
+          <a:ln/>
+        </p:spPr>
+        <p:txBody>
+          <a:bodyPr wrap="square" lIns="0" tIns="0" rIns="0" bIns="0" rtlCol="0" anchor="t"/>
+          <a:lstStyle/>
+          <a:p>
+            <a:pPr indent="0" marL="0">
+              <a:buNone/>
+            </a:pPr>
+            <a:r>
+              <a:rPr lang="en-US" sz="950" b="1" spc="100" kern="0" dirty="0">
                 <a:solidFill>
                   <a:srgbClr val="F2A900"/>
                 </a:solidFill>
@@ -6656,7 +6947,46 @@
                 <a:ea typeface="Calibri" pitchFamily="34" charset="-122"/>
                 <a:cs typeface="Calibri" pitchFamily="34" charset="-120"/>
               </a:rPr>
-              <a:t>DEFEITOS DEF-02 E DEF-03</a:t>
+              <a:t>ISSUES #21 E #22 · DEF-02 E DEF-03</a:t>
+            </a:r>
+            <a:endParaRPr lang="en-US" sz="950" dirty="0"/>
+          </a:p>
+        </p:txBody>
+      </p:sp>
+      <p:sp>
+        <p:nvSpPr>
+          <p:cNvPr id="19" name="Text 17"/>
+          <p:cNvSpPr txBox="1"/>
+          <p:nvPr/>
+        </p:nvSpPr>
+        <p:spPr>
+          <a:xfrm>
+            <a:off x="6035040" y="1874520"/>
+            <a:ext cx="2468880" cy="274320"/>
+          </a:xfrm>
+          <a:prstGeom prst="rect">
+            <a:avLst/>
+          </a:prstGeom>
+          <a:noFill/>
+          <a:ln/>
+        </p:spPr>
+        <p:txBody>
+          <a:bodyPr wrap="square" lIns="0" tIns="0" rIns="0" bIns="0" rtlCol="0" anchor="t"/>
+          <a:lstStyle/>
+          <a:p>
+            <a:pPr indent="0" marL="0">
+              <a:buNone/>
+            </a:pPr>
+            <a:r>
+              <a:rPr lang="en-US" sz="1000" i="1" dirty="0">
+                <a:solidFill>
+                  <a:srgbClr val="E8DFDB"/>
+                </a:solidFill>
+                <a:latin typeface="Calibri" pitchFamily="34" charset="0"/>
+                <a:ea typeface="Calibri" pitchFamily="34" charset="-122"/>
+                <a:cs typeface="Calibri" pitchFamily="34" charset="-120"/>
+              </a:rPr>
+              <a:t>Área de Vinicius Rocha Pinheiro</a:t>
             </a:r>
             <a:endParaRPr lang="en-US" sz="1000" dirty="0"/>
           </a:p>
@@ -6664,30 +6994,30 @@
       </p:sp>
       <p:sp>
         <p:nvSpPr>
-          <p:cNvPr id="19" name="Text 17"/>
-          <p:cNvSpPr txBox="1"/>
-          <p:nvPr/>
-        </p:nvSpPr>
-        <p:spPr>
-          <a:xfrm>
-            <a:off x="6035040" y="1691640"/>
-            <a:ext cx="2468880" cy="2743200"/>
-          </a:xfrm>
-          <a:prstGeom prst="rect">
-            <a:avLst/>
-          </a:prstGeom>
-          <a:noFill/>
-          <a:ln/>
-        </p:spPr>
-        <p:txBody>
-          <a:bodyPr wrap="square" lIns="0" tIns="0" rIns="0" bIns="0" rtlCol="0" anchor="t"/>
-          <a:lstStyle/>
-          <a:p>
-            <a:pPr indent="0" marL="0">
-              <a:buNone/>
-            </a:pPr>
-            <a:r>
-              <a:rPr lang="en-US" sz="1300" dirty="0">
+          <p:cNvPr id="20" name="Text 18"/>
+          <p:cNvSpPr txBox="1"/>
+          <p:nvPr/>
+        </p:nvSpPr>
+        <p:spPr>
+          <a:xfrm>
+            <a:off x="6035040" y="2240280"/>
+            <a:ext cx="2468880" cy="2194560"/>
+          </a:xfrm>
+          <a:prstGeom prst="rect">
+            <a:avLst/>
+          </a:prstGeom>
+          <a:noFill/>
+          <a:ln/>
+        </p:spPr>
+        <p:txBody>
+          <a:bodyPr wrap="square" lIns="0" tIns="0" rIns="0" bIns="0" rtlCol="0" anchor="t"/>
+          <a:lstStyle/>
+          <a:p>
+            <a:pPr indent="0" marL="0">
+              <a:buNone/>
+            </a:pPr>
+            <a:r>
+              <a:rPr lang="en-US" sz="1250" dirty="0">
                 <a:solidFill>
                   <a:srgbClr val="FFFFFF"/>
                 </a:solidFill>
@@ -6697,13 +7027,13 @@
               </a:rPr>
               <a:t>O total ignora a quantidade (35,00 na tela, 20,00 gravado). E o cliente do pedido vem do id do JSON, sem conferir com o cookie: dá para gravar pedido em nome de outro cliente.</a:t>
             </a:r>
-            <a:endParaRPr lang="en-US" sz="1300" dirty="0"/>
-          </a:p>
-        </p:txBody>
-      </p:sp>
-      <p:sp>
-        <p:nvSpPr>
-          <p:cNvPr id="20" name="Text 18"/>
+            <a:endParaRPr lang="en-US" sz="1250" dirty="0"/>
+          </a:p>
+        </p:txBody>
+      </p:sp>
+      <p:sp>
+        <p:nvSpPr>
+          <p:cNvPr id="21" name="Text 19"/>
           <p:cNvSpPr txBox="1"/>
           <p:nvPr/>
         </p:nvSpPr>
@@ -6864,7 +7194,7 @@
                 <a:ea typeface="Calibri" pitchFamily="34" charset="-122"/>
                 <a:cs typeface="Calibri" pitchFamily="34" charset="-120"/>
               </a:rPr>
-              <a:t>CADASTRO DE CLIENTES  ·  Felipe Paixão</a:t>
+              <a:t>CADASTRO DE CLIENTES  ·  Thiago Ferreira</a:t>
             </a:r>
             <a:endParaRPr lang="en-US" sz="1100" dirty="0"/>
           </a:p>
@@ -7502,7 +7832,7 @@
                 <a:ea typeface="Calibri" pitchFamily="34" charset="-122"/>
                 <a:cs typeface="Calibri" pitchFamily="34" charset="-120"/>
               </a:rPr>
-              <a:t>CADASTRO DE CLIENTES  ·  Felipe Paixão</a:t>
+              <a:t>CADASTRO DE CLIENTES  ·  Thiago Ferreira</a:t>
             </a:r>
             <a:endParaRPr lang="en-US" sz="1100" dirty="0"/>
           </a:p>
@@ -7894,7 +8224,7 @@
         </p:nvSpPr>
         <p:spPr>
           <a:xfrm>
-            <a:off x="2926080" y="2743200"/>
+            <a:off x="2926080" y="2651760"/>
             <a:ext cx="2468880" cy="201168"/>
           </a:xfrm>
           <a:prstGeom prst="rect">
@@ -7933,8 +8263,8 @@
         </p:nvSpPr>
         <p:spPr>
           <a:xfrm>
-            <a:off x="2926080" y="2962656"/>
-            <a:ext cx="2468880" cy="1645920"/>
+            <a:off x="2926080" y="2871216"/>
+            <a:ext cx="2468880" cy="1600200"/>
           </a:xfrm>
           <a:prstGeom prst="rect">
             <a:avLst/>
@@ -7958,7 +8288,7 @@
                 <a:ea typeface="Calibri" pitchFamily="34" charset="-122"/>
                 <a:cs typeface="Calibri" pitchFamily="34" charset="-120"/>
               </a:rPr>
-              <a:t>Issue #8 aberta: execução manual pendente.</a:t>
+              <a:t>Responsável: Thiago Ferreira. Não executado — issue #8 aberta. Roteiro pronto: campos obrigatórios vazios e usuário duplicado, cenários que os testes já reprovam.</a:t>
             </a:r>
             <a:endParaRPr lang="en-US" sz="1300" dirty="0"/>
           </a:p>
@@ -8000,23 +8330,23 @@
         <p:spPr>
           <a:xfrm>
             <a:off x="6035040" y="1371600"/>
-            <a:ext cx="2468880" cy="228600"/>
-          </a:xfrm>
-          <a:prstGeom prst="rect">
-            <a:avLst/>
-          </a:prstGeom>
-          <a:noFill/>
-          <a:ln/>
-        </p:spPr>
-        <p:txBody>
-          <a:bodyPr wrap="square" lIns="0" tIns="0" rIns="0" bIns="0" rtlCol="0" anchor="t"/>
-          <a:lstStyle/>
-          <a:p>
-            <a:pPr indent="0" marL="0">
-              <a:buNone/>
-            </a:pPr>
-            <a:r>
-              <a:rPr lang="en-US" sz="1000" b="1" spc="100" kern="0" dirty="0">
+            <a:ext cx="2468880" cy="457200"/>
+          </a:xfrm>
+          <a:prstGeom prst="rect">
+            <a:avLst/>
+          </a:prstGeom>
+          <a:noFill/>
+          <a:ln/>
+        </p:spPr>
+        <p:txBody>
+          <a:bodyPr wrap="square" lIns="0" tIns="0" rIns="0" bIns="0" rtlCol="0" anchor="t"/>
+          <a:lstStyle/>
+          <a:p>
+            <a:pPr indent="0" marL="0">
+              <a:buNone/>
+            </a:pPr>
+            <a:r>
+              <a:rPr lang="en-US" sz="950" b="1" spc="100" kern="0" dirty="0">
                 <a:solidFill>
                   <a:srgbClr val="F2A900"/>
                 </a:solidFill>
@@ -8024,7 +8354,46 @@
                 <a:ea typeface="Calibri" pitchFamily="34" charset="-122"/>
                 <a:cs typeface="Calibri" pitchFamily="34" charset="-120"/>
               </a:rPr>
-              <a:t>DEFEITOS DEF-05 E DEF-04</a:t>
+              <a:t>ISSUES #24 E #23 · DEF-05 E DEF-04</a:t>
+            </a:r>
+            <a:endParaRPr lang="en-US" sz="950" dirty="0"/>
+          </a:p>
+        </p:txBody>
+      </p:sp>
+      <p:sp>
+        <p:nvSpPr>
+          <p:cNvPr id="19" name="Text 17"/>
+          <p:cNvSpPr txBox="1"/>
+          <p:nvPr/>
+        </p:nvSpPr>
+        <p:spPr>
+          <a:xfrm>
+            <a:off x="6035040" y="1874520"/>
+            <a:ext cx="2468880" cy="274320"/>
+          </a:xfrm>
+          <a:prstGeom prst="rect">
+            <a:avLst/>
+          </a:prstGeom>
+          <a:noFill/>
+          <a:ln/>
+        </p:spPr>
+        <p:txBody>
+          <a:bodyPr wrap="square" lIns="0" tIns="0" rIns="0" bIns="0" rtlCol="0" anchor="t"/>
+          <a:lstStyle/>
+          <a:p>
+            <a:pPr indent="0" marL="0">
+              <a:buNone/>
+            </a:pPr>
+            <a:r>
+              <a:rPr lang="en-US" sz="1000" i="1" dirty="0">
+                <a:solidFill>
+                  <a:srgbClr val="E8DFDB"/>
+                </a:solidFill>
+                <a:latin typeface="Calibri" pitchFamily="34" charset="0"/>
+                <a:ea typeface="Calibri" pitchFamily="34" charset="-122"/>
+                <a:cs typeface="Calibri" pitchFamily="34" charset="-120"/>
+              </a:rPr>
+              <a:t>Área de Thiago Ferreira</a:t>
             </a:r>
             <a:endParaRPr lang="en-US" sz="1000" dirty="0"/>
           </a:p>
@@ -8032,30 +8401,30 @@
       </p:sp>
       <p:sp>
         <p:nvSpPr>
-          <p:cNvPr id="19" name="Text 17"/>
-          <p:cNvSpPr txBox="1"/>
-          <p:nvPr/>
-        </p:nvSpPr>
-        <p:spPr>
-          <a:xfrm>
-            <a:off x="6035040" y="1691640"/>
-            <a:ext cx="2468880" cy="2743200"/>
-          </a:xfrm>
-          <a:prstGeom prst="rect">
-            <a:avLst/>
-          </a:prstGeom>
-          <a:noFill/>
-          <a:ln/>
-        </p:spPr>
-        <p:txBody>
-          <a:bodyPr wrap="square" lIns="0" tIns="0" rIns="0" bIns="0" rtlCol="0" anchor="t"/>
-          <a:lstStyle/>
-          <a:p>
-            <a:pPr indent="0" marL="0">
-              <a:buNone/>
-            </a:pPr>
-            <a:r>
-              <a:rPr lang="en-US" sz="1300" dirty="0">
+          <p:cNvPr id="20" name="Text 18"/>
+          <p:cNvSpPr txBox="1"/>
+          <p:nvPr/>
+        </p:nvSpPr>
+        <p:spPr>
+          <a:xfrm>
+            <a:off x="6035040" y="2240280"/>
+            <a:ext cx="2468880" cy="2194560"/>
+          </a:xfrm>
+          <a:prstGeom prst="rect">
+            <a:avLst/>
+          </a:prstGeom>
+          <a:noFill/>
+          <a:ln/>
+        </p:spPr>
+        <p:txBody>
+          <a:bodyPr wrap="square" lIns="0" tIns="0" rIns="0" bIns="0" rtlCol="0" anchor="t"/>
+          <a:lstStyle/>
+          <a:p>
+            <a:pPr indent="0" marL="0">
+              <a:buNone/>
+            </a:pPr>
+            <a:r>
+              <a:rPr lang="en-US" sz="1250" dirty="0">
                 <a:solidFill>
                   <a:srgbClr val="FFFFFF"/>
                 </a:solidFill>
@@ -8065,13 +8434,13 @@
               </a:rPr>
               <a:t>Servidor aceita nome, usuário e senha vazios; em cadastro.js a condição !field.name == 'complemento' é sempre falsa. E pesquisaPorUsuario concatena SQL: usuário com apóstrofo quebra o comando.</a:t>
             </a:r>
-            <a:endParaRPr lang="en-US" sz="1300" dirty="0"/>
-          </a:p>
-        </p:txBody>
-      </p:sp>
-      <p:sp>
-        <p:nvSpPr>
-          <p:cNvPr id="20" name="Text 18"/>
+            <a:endParaRPr lang="en-US" sz="1250" dirty="0"/>
+          </a:p>
+        </p:txBody>
+      </p:sp>
+      <p:sp>
+        <p:nvSpPr>
+          <p:cNvPr id="21" name="Text 19"/>
           <p:cNvSpPr txBox="1"/>
           <p:nvPr/>
         </p:nvSpPr>
@@ -9285,7 +9654,7 @@
         </p:nvSpPr>
         <p:spPr>
           <a:xfrm>
-            <a:off x="2926080" y="2743200"/>
+            <a:off x="2926080" y="2651760"/>
             <a:ext cx="2468880" cy="201168"/>
           </a:xfrm>
           <a:prstGeom prst="rect">
@@ -9324,8 +9693,8 @@
         </p:nvSpPr>
         <p:spPr>
           <a:xfrm>
-            <a:off x="2926080" y="2962656"/>
-            <a:ext cx="2468880" cy="1645920"/>
+            <a:off x="2926080" y="2871216"/>
+            <a:ext cx="2468880" cy="1600200"/>
           </a:xfrm>
           <a:prstGeom prst="rect">
             <a:avLst/>
@@ -9349,7 +9718,7 @@
                 <a:ea typeface="Calibri" pitchFamily="34" charset="-122"/>
                 <a:cs typeface="Calibri" pitchFamily="34" charset="-120"/>
               </a:rPr>
-              <a:t>Executado em 20/09 por Vinicius Fonseca: passo 'Adicionar' FALHOU (nada acontece) e 'Cancelar' FALHOU. Issue #17 aberta.</a:t>
+              <a:t>Executado em 20/09 por Vinicius Fonseca: passo 'Adicionar' FALHOU (nada acontece) e 'Cancelar' FALHOU. Virou a issue #17; a causa está na #20.</a:t>
             </a:r>
             <a:endParaRPr lang="en-US" sz="1300" dirty="0"/>
           </a:p>
@@ -9391,23 +9760,23 @@
         <p:spPr>
           <a:xfrm>
             <a:off x="6035040" y="1371600"/>
-            <a:ext cx="2468880" cy="228600"/>
-          </a:xfrm>
-          <a:prstGeom prst="rect">
-            <a:avLst/>
-          </a:prstGeom>
-          <a:noFill/>
-          <a:ln/>
-        </p:spPr>
-        <p:txBody>
-          <a:bodyPr wrap="square" lIns="0" tIns="0" rIns="0" bIns="0" rtlCol="0" anchor="t"/>
-          <a:lstStyle/>
-          <a:p>
-            <a:pPr indent="0" marL="0">
-              <a:buNone/>
-            </a:pPr>
-            <a:r>
-              <a:rPr lang="en-US" sz="1000" b="1" spc="100" kern="0" dirty="0">
+            <a:ext cx="2468880" cy="457200"/>
+          </a:xfrm>
+          <a:prstGeom prst="rect">
+            <a:avLst/>
+          </a:prstGeom>
+          <a:noFill/>
+          <a:ln/>
+        </p:spPr>
+        <p:txBody>
+          <a:bodyPr wrap="square" lIns="0" tIns="0" rIns="0" bIns="0" rtlCol="0" anchor="t"/>
+          <a:lstStyle/>
+          <a:p>
+            <a:pPr indent="0" marL="0">
+              <a:buNone/>
+            </a:pPr>
+            <a:r>
+              <a:rPr lang="en-US" sz="950" b="1" spc="100" kern="0" dirty="0">
                 <a:solidFill>
                   <a:srgbClr val="F2A900"/>
                 </a:solidFill>
@@ -9415,7 +9784,46 @@
                 <a:ea typeface="Calibri" pitchFamily="34" charset="-122"/>
                 <a:cs typeface="Calibri" pitchFamily="34" charset="-120"/>
               </a:rPr>
-              <a:t>DEFEITO DEF-01</a:t>
+              <a:t>ISSUE #20 · DEF-01</a:t>
+            </a:r>
+            <a:endParaRPr lang="en-US" sz="950" dirty="0"/>
+          </a:p>
+        </p:txBody>
+      </p:sp>
+      <p:sp>
+        <p:nvSpPr>
+          <p:cNvPr id="19" name="Text 17"/>
+          <p:cNvSpPr txBox="1"/>
+          <p:nvPr/>
+        </p:nvSpPr>
+        <p:spPr>
+          <a:xfrm>
+            <a:off x="6035040" y="1874520"/>
+            <a:ext cx="2468880" cy="274320"/>
+          </a:xfrm>
+          <a:prstGeom prst="rect">
+            <a:avLst/>
+          </a:prstGeom>
+          <a:noFill/>
+          <a:ln/>
+        </p:spPr>
+        <p:txBody>
+          <a:bodyPr wrap="square" lIns="0" tIns="0" rIns="0" bIns="0" rtlCol="0" anchor="t"/>
+          <a:lstStyle/>
+          <a:p>
+            <a:pPr indent="0" marL="0">
+              <a:buNone/>
+            </a:pPr>
+            <a:r>
+              <a:rPr lang="en-US" sz="1000" i="1" dirty="0">
+                <a:solidFill>
+                  <a:srgbClr val="E8DFDB"/>
+                </a:solidFill>
+                <a:latin typeface="Calibri" pitchFamily="34" charset="0"/>
+                <a:ea typeface="Calibri" pitchFamily="34" charset="-122"/>
+                <a:cs typeface="Calibri" pitchFamily="34" charset="-120"/>
+              </a:rPr>
+              <a:t>Área de Vinicius Fonseca de Freitas</a:t>
             </a:r>
             <a:endParaRPr lang="en-US" sz="1000" dirty="0"/>
           </a:p>
@@ -9423,30 +9831,30 @@
       </p:sp>
       <p:sp>
         <p:nvSpPr>
-          <p:cNvPr id="19" name="Text 17"/>
-          <p:cNvSpPr txBox="1"/>
-          <p:nvPr/>
-        </p:nvSpPr>
-        <p:spPr>
-          <a:xfrm>
-            <a:off x="6035040" y="1691640"/>
-            <a:ext cx="2468880" cy="2743200"/>
-          </a:xfrm>
-          <a:prstGeom prst="rect">
-            <a:avLst/>
-          </a:prstGeom>
-          <a:noFill/>
-          <a:ln/>
-        </p:spPr>
-        <p:txBody>
-          <a:bodyPr wrap="square" lIns="0" tIns="0" rIns="0" bIns="0" rtlCol="0" anchor="t"/>
-          <a:lstStyle/>
-          <a:p>
-            <a:pPr indent="0" marL="0">
-              <a:buNone/>
-            </a:pPr>
-            <a:r>
-              <a:rPr lang="en-US" sz="1300" dirty="0">
+          <p:cNvPr id="20" name="Text 18"/>
+          <p:cNvSpPr txBox="1"/>
+          <p:nvPr/>
+        </p:nvSpPr>
+        <p:spPr>
+          <a:xfrm>
+            <a:off x="6035040" y="2240280"/>
+            <a:ext cx="2468880" cy="2194560"/>
+          </a:xfrm>
+          <a:prstGeom prst="rect">
+            <a:avLst/>
+          </a:prstGeom>
+          <a:noFill/>
+          <a:ln/>
+        </p:spPr>
+        <p:txBody>
+          <a:bodyPr wrap="square" lIns="0" tIns="0" rIns="0" bIns="0" rtlCol="0" anchor="t"/>
+          <a:lstStyle/>
+          <a:p>
+            <a:pPr indent="0" marL="0">
+              <a:buNone/>
+            </a:pPr>
+            <a:r>
+              <a:rPr lang="en-US" sz="1250" dirty="0">
                 <a:solidFill>
                   <a:srgbClr val="FFFFFF"/>
                 </a:solidFill>
@@ -9456,13 +9864,13 @@
               </a:rPr>
               <a:t>A suspeita de 'ingredientes não salvos' não está no DaoLanche (o INSERT é executado). Está no servlet: o mesmo Iterator é usado em dois laços, e o segundo nunca roda.</a:t>
             </a:r>
-            <a:endParaRPr lang="en-US" sz="1300" dirty="0"/>
-          </a:p>
-        </p:txBody>
-      </p:sp>
-      <p:sp>
-        <p:nvSpPr>
-          <p:cNvPr id="20" name="Text 18"/>
+            <a:endParaRPr lang="en-US" sz="1250" dirty="0"/>
+          </a:p>
+        </p:txBody>
+      </p:sp>
+      <p:sp>
+        <p:nvSpPr>
+          <p:cNvPr id="21" name="Text 19"/>
           <p:cNvSpPr txBox="1"/>
           <p:nvPr/>
         </p:nvSpPr>

</xml_diff>

<commit_message>
docs: casos de teste manuais, plano e apresentação projetada no README
- cinco casos manuais executados, um por integrante, com prints
- deck e roteiro atualizados com os resultados reais dos manuais
- cinco defeitos novos encontrados nos manuais, registrados no relatório
- README do repositório mostra a apresentação e o resumo da entrega
</commit_message>
<xml_diff>
--- a/docs/entrega-1/apresentacao/apresentacao-entrega-1.pptx
+++ b/docs/entrega-1/apresentacao/apresentacao-entrega-1.pptx
@@ -736,7 +736,11 @@
 Não escrevemos teste dizendo
 que preço de venda tem que ser maior que o de compra.
 Parece óbvio, mas não existe nada no sistema que diga isso.
-A gente testa o que está escrito, não o que a gente acha.</a:t>
+A gente testa o que está escrito, não o que a gente acha.
+[PAUSA]
+No manual apareceu mais uma:
+remover um insumo que está sendo usado num lanche
+devolve um erro 500 na cara do usuário.</a:t>
             </a:r>
             <a:endParaRPr lang="en-US" dirty="0"/>
           </a:p>
@@ -832,11 +836,11 @@
 Eles descrevem como deveria funcionar,
 e falham enquanto o defeito existir.
 [PAUSA]
-E seis defeitos abertos no GitHub, da issue vinte até a vinte e cinco.
+E onze defeitos no total: seis já viraram issue, da vinte até a vinte e cinco.
 [PAUSA]
 O que ficou faltando, e a gente não vai esconder:
-dois testes manuais ainda não rodaram, o CT-03 e o CT-05.
-A área de estoque ficou sem classe de regra de negócio,
+cinco achados dos testes manuais ainda não viraram issue.
+E a área de estoque ficou sem classe de regra de negócio,
 como eu mostrei ali atrás.
 E a gente não corrigiu nenhum defeito,
 porque o objetivo dessa entrega era encontrar e registrar.
@@ -1055,7 +1059,10 @@
 Só que se alguém copiar aquele token, ele funciona pra sempre.
 [PAUSA]
 A gente não inventou uma regra que não existe.
-Registrou como observação de segurança, e está no slide.</a:t>
+Registrou como observação de segurança, e está no slide.
+[PAUSA]
+E o teste manual já rodou: oito passos, todos passaram.
+Login, logout e bloqueio de página restrita funcionam.</a:t>
             </a:r>
             <a:endParaRPr lang="en-US" dirty="0"/>
           </a:p>
@@ -1265,7 +1272,11 @@
 O sistema nunca compara com o cookie de quem está logado.
 [PAUSA]
 Então eu, logado na minha conta,
-consigo fazer um pedido no nome de qualquer um de vocês.</a:t>
+consigo fazer um pedido no nome de qualquer um de vocês.
+[PAUSA]
+E o teste manual achou mais duas.
+Finalizar a compra com bebida no carrinho devolve erro 500.
+E carrinho vazio grava um pedido de zero real.</a:t>
             </a:r>
             <a:endParaRPr lang="en-US" dirty="0"/>
           </a:p>
@@ -1480,7 +1491,12 @@
 Então se a pessoa se chama O'Brien, com apóstrofo, o login quebra.
 E se ela for esperta, digita SQL no campo de usuário
 e o banco executa.
-Issue vinte e três.</a:t>
+Issue vinte e três.
+[PAUSA]
+No teste manual apareceram mais duas.
+Dá pra cadastrar duas pessoas com o mesmo usuário,
+e quem entra no login é a última.
+E nome com acento grava corrompido no banco.</a:t>
             </a:r>
             <a:endParaRPr lang="en-US" dirty="0"/>
           </a:p>
@@ -3487,7 +3503,7 @@
                 <a:ea typeface="Calibri" pitchFamily="34" charset="-122"/>
                 <a:cs typeface="Calibri" pitchFamily="34" charset="-120"/>
               </a:rPr>
-              <a:t>Responsável: Felipe Paixão. Não executado — issue #10 aberta. Roteiro pronto: cadastrar insumo com quantidade -5 e zerar o estoque pelo painel.</a:t>
+              <a:t>Executado em 21/09 por Felipe Paixão: 5 PASSOU, 3 FALHOU. Negativo aceito no cadastro e na alteração; remoção de insumo em uso dá HTTP 500. Issue #10.</a:t>
             </a:r>
             <a:endParaRPr lang="en-US" sz="1300" dirty="0"/>
           </a:p>
@@ -3631,7 +3647,7 @@
                 <a:ea typeface="Calibri" pitchFamily="34" charset="-122"/>
                 <a:cs typeface="Calibri" pitchFamily="34" charset="-120"/>
               </a:rPr>
-              <a:t>Quantidade -5 e valores negativos são aceitos: 'Ingrediente Salvo!'. Não há validação no servlet nem CHECK no banco. Não assumimos regra de 'venda maior que compra'.</a:t>
+              <a:t>Quantidade -5 e valores negativos são aceitos, no cadastro e na alteração: não há validação no servlet nem CHECK no banco. Remover insumo usado em lanche devolve HTTP 500 cru. Não assumimos regra de 'venda maior que compra'.</a:t>
             </a:r>
             <a:endParaRPr lang="en-US" sz="1250" dirty="0"/>
           </a:p>
@@ -3970,7 +3986,7 @@
                 <a:ea typeface="Cambria" pitchFamily="34" charset="-122"/>
                 <a:cs typeface="Cambria" pitchFamily="34" charset="-120"/>
               </a:rPr>
-              <a:t>6</a:t>
+              <a:t>11</a:t>
             </a:r>
             <a:endParaRPr lang="en-US" sz="4800" dirty="0"/>
           </a:p>
@@ -4009,7 +4025,7 @@
                 <a:ea typeface="Calibri" pitchFamily="34" charset="-122"/>
                 <a:cs typeface="Calibri" pitchFamily="34" charset="-120"/>
               </a:rPr>
-              <a:t>defeitos documentados</a:t>
+              <a:t>defeitos encontrados</a:t>
             </a:r>
             <a:endParaRPr lang="en-US" sz="1200" dirty="0"/>
           </a:p>
@@ -4026,7 +4042,7 @@
                 <a:ea typeface="Calibri" pitchFamily="34" charset="-122"/>
                 <a:cs typeface="Calibri" pitchFamily="34" charset="-120"/>
               </a:rPr>
-              <a:t>issues #20 a #25 no GitHub</a:t>
+              <a:t>6 com issue aberta (#20 a #25)</a:t>
             </a:r>
             <a:endParaRPr lang="en-US" sz="1200" dirty="0"/>
           </a:p>
@@ -4108,7 +4124,7 @@
                 <a:ea typeface="Calibri" pitchFamily="34" charset="-122"/>
                 <a:cs typeface="Calibri" pitchFamily="34" charset="-120"/>
               </a:rPr>
-              <a:t>CT-03 (Thiago Ferreira) e CT-05 (Felipe Paixão) ainda não executados; CT-04 executado por Vinicius Fonseca com falha.</a:t>
+              <a:t>Os cinco casos manuais foram executados, um por integrante, com prints anexados: 23 passos PASSOU e 13 FALHOU.</a:t>
             </a:r>
             <a:endParaRPr lang="en-US" sz="1300" dirty="0"/>
           </a:p>
@@ -4129,7 +4145,7 @@
                 <a:ea typeface="Calibri" pitchFamily="34" charset="-122"/>
                 <a:cs typeface="Calibri" pitchFamily="34" charset="-120"/>
               </a:rPr>
-              <a:t>Área 5 sem classe não CRUD de complexidade razoável: o sistema não tem regra de estoque.</a:t>
+              <a:t>Cinco achados dos testes manuais ainda não viraram issue; a área 5 não tem classe não CRUD, porque o sistema não tem regra de estoque.</a:t>
             </a:r>
             <a:endParaRPr lang="en-US" sz="1300" dirty="0"/>
           </a:p>
@@ -5451,7 +5467,7 @@
                 <a:ea typeface="Calibri" pitchFamily="34" charset="-122"/>
                 <a:cs typeface="Calibri" pitchFamily="34" charset="-120"/>
               </a:rPr>
-              <a:t>Responsável: Yuri Mascarenhas. Issue #6 fechada pelo grupo. O documento do caso, no formato do CT-04, não está no repositório.</a:t>
+              <a:t>Executado em 21/09 por Yuri Mascarenhas: 8 passos, todos PASSOU. Login, logout e bloqueio de página restrita funcionam. Issue #6 fechada.</a:t>
             </a:r>
             <a:endParaRPr lang="en-US" sz="1300" dirty="0"/>
           </a:p>
@@ -6881,7 +6897,7 @@
                 <a:ea typeface="Calibri" pitchFamily="34" charset="-122"/>
                 <a:cs typeface="Calibri" pitchFamily="34" charset="-120"/>
               </a:rPr>
-              <a:t>Responsável: Vinicius Rocha Pinheiro. Issue #7 fechada pelo grupo. O documento do caso, no formato do CT-04, não está no repositório.</a:t>
+              <a:t>Executado em 21/09 por Vinicius Rocha Pinheiro: 6 PASSOU, 3 FALHOU. Finalizar com bebida devolveu HTTP 500. Issue #7 fechada.</a:t>
             </a:r>
             <a:endParaRPr lang="en-US" sz="1300" dirty="0"/>
           </a:p>
@@ -7025,7 +7041,7 @@
                 <a:ea typeface="Calibri" pitchFamily="34" charset="-122"/>
                 <a:cs typeface="Calibri" pitchFamily="34" charset="-120"/>
               </a:rPr>
-              <a:t>O total ignora a quantidade (35,00 na tela, 20,00 gravado). E o cliente do pedido vem do id do JSON, sem conferir com o cookie: dá para gravar pedido em nome de outro cliente.</a:t>
+              <a:t>Total ignora a quantidade: 36,00 na tela, 18,00 gravado. O cliente vem do id do JSON, sem conferir o cookie. E o manual achou mais: finalizar com bebida dá HTTP 500, e carrinho vazio grava pedido de R$ 0,00.</a:t>
             </a:r>
             <a:endParaRPr lang="en-US" sz="1250" dirty="0"/>
           </a:p>
@@ -8288,7 +8304,7 @@
                 <a:ea typeface="Calibri" pitchFamily="34" charset="-122"/>
                 <a:cs typeface="Calibri" pitchFamily="34" charset="-120"/>
               </a:rPr>
-              <a:t>Responsável: Thiago Ferreira. Não executado — issue #8 aberta. Roteiro pronto: campos obrigatórios vazios e usuário duplicado, cenários que os testes já reprovam.</a:t>
+              <a:t>Executado em 21/09 por Thiago Ferreira: 2 PASSOU, 5 FALHOU. Campos vazios, usuário duplicado e nome com acento corrompido. Issue #8.</a:t>
             </a:r>
             <a:endParaRPr lang="en-US" sz="1300" dirty="0"/>
           </a:p>
@@ -8432,7 +8448,7 @@
                 <a:ea typeface="Calibri" pitchFamily="34" charset="-122"/>
                 <a:cs typeface="Calibri" pitchFamily="34" charset="-120"/>
               </a:rPr>
-              <a:t>Servidor aceita nome, usuário e senha vazios; em cadastro.js a condição !field.name == 'complemento' é sempre falsa. E pesquisaPorUsuario concatena SQL: usuário com apóstrofo quebra o comando.</a:t>
+              <a:t>Aceita nome, usuário e senha vazios: em cadastro.js a condição !field.name == 'complemento' é sempre falsa. Busca por usuário concatena SQL. No manual: usuário duplicado é aceito e quem entra é o último, e nome com acento grava corrompido.</a:t>
             </a:r>
             <a:endParaRPr lang="en-US" sz="1250" dirty="0"/>
           </a:p>
@@ -9718,7 +9734,7 @@
                 <a:ea typeface="Calibri" pitchFamily="34" charset="-122"/>
                 <a:cs typeface="Calibri" pitchFamily="34" charset="-120"/>
               </a:rPr>
-              <a:t>Executado em 20/09 por Vinicius Fonseca: passo 'Adicionar' FALHOU (nada acontece) e 'Cancelar' FALHOU. Virou a issue #17; a causa está na #20.</a:t>
+              <a:t>Executado em 20/09 por Vinicius Fonseca: 2 PASSOU, 2 FALHOU. 'Adicionar' não responde e 'Cancelar' dá tela branca. Virou a issue #17; a causa é a #20.</a:t>
             </a:r>
             <a:endParaRPr lang="en-US" sz="1300" dirty="0"/>
           </a:p>

</xml_diff>

<commit_message>
docs: anexos da apresentação com as evidências da entrega
- cinco slides de anexo: estrutura no repositório, issues, casos manuais e execução das suítes
- capturas do GitHub, cabeçalho de cada caso de teste e saída real do Maven em apresentacao/anexos
- prévias do README atualizadas para os 17 slides
</commit_message>
<xml_diff>
--- a/docs/entrega-1/apresentacao/apresentacao-entrega-1.pptx
+++ b/docs/entrega-1/apresentacao/apresentacao-entrega-1.pptx
@@ -17,9 +17,14 @@
     <p:sldId id="265" r:id="rId11"/>
     <p:sldId id="266" r:id="rId12"/>
     <p:sldId id="267" r:id="rId13"/>
+    <p:sldId id="268" r:id="rId14"/>
+    <p:sldId id="269" r:id="rId15"/>
+    <p:sldId id="270" r:id="rId16"/>
+    <p:sldId id="271" r:id="rId17"/>
+    <p:sldId id="272" r:id="rId18"/>
   </p:sldIdLst>
   <p:notesMasterIdLst>
-    <p:notesMasterId r:id="rId14"/>
+    <p:notesMasterId r:id="rId19"/>
   </p:notesMasterIdLst>
   <p:sldSz cx="9144000" cy="5143500"/>
   <p:notesSz cx="5143500" cy="9144000"/>
@@ -875,6 +880,446 @@
             <a:fld id="{F7021451-1387-4CA6-816F-3879F97B5CBC}" type="slidenum">
               <a:rPr lang="en-US"/>
               <a:t>12</a:t>
+            </a:fld>
+            <a:endParaRPr lang="en-US"/>
+          </a:p>
+        </p:txBody>
+      </p:sp>
+    </p:spTree>
+    <p:extLst>
+      <p:ext uri="{BB962C8B-B14F-4D97-AF65-F5344CB8AC3E}">
+        <p14:creationId xmlns:p14="http://schemas.microsoft.com/office/powerpoint/2010/main" val="1024086991"/>
+      </p:ext>
+    </p:extLst>
+  </p:cSld>
+  <p:clrMapOvr>
+    <a:masterClrMapping/>
+  </p:clrMapOvr>
+</p:notes>
+</file>
+
+<file path=ppt/notesSlides/notesSlide13.xml><?xml version="1.0" encoding="utf-8"?>
+<p:notes xmlns:a="http://schemas.openxmlformats.org/drawingml/2006/main" xmlns:r="http://schemas.openxmlformats.org/officeDocument/2006/relationships" xmlns:p="http://schemas.openxmlformats.org/presentationml/2006/main">
+  <p:cSld>
+    <p:spTree>
+      <p:nvGrpSpPr>
+        <p:cNvPr id="1" name=""/>
+        <p:cNvGrpSpPr/>
+        <p:nvPr/>
+      </p:nvGrpSpPr>
+      <p:grpSpPr>
+        <a:xfrm>
+          <a:off x="0" y="0"/>
+          <a:ext cx="0" cy="0"/>
+          <a:chOff x="0" y="0"/>
+          <a:chExt cx="0" cy="0"/>
+        </a:xfrm>
+      </p:grpSpPr>
+      <p:sp>
+        <p:nvSpPr>
+          <p:cNvPr id="2" name="Slide Image Placeholder 1"/>
+          <p:cNvSpPr>
+            <a:spLocks noGrp="1" noRot="1" noChangeAspect="1"/>
+          </p:cNvSpPr>
+          <p:nvPr>
+            <p:ph type="sldImg"/>
+          </p:nvPr>
+        </p:nvSpPr>
+        <p:spPr/>
+      </p:sp>
+      <p:sp>
+        <p:nvSpPr>
+          <p:cNvPr id="3" name="Notes Placeholder 2"/>
+          <p:cNvSpPr>
+            <a:spLocks noGrp="1"/>
+          </p:cNvSpPr>
+          <p:nvPr>
+            <p:ph type="body" idx="1"/>
+          </p:nvPr>
+        </p:nvSpPr>
+        <p:spPr/>
+        <p:txBody>
+          <a:bodyPr/>
+          <a:lstStyle/>
+          <a:p>
+            <a:r>
+              <a:rPr lang="en-US" dirty="0"/>
+              <a:t>Anexo. Essa é a estrutura real no GitHub. A pasta docs/entrega-1 tem o relatório, a apresentação e os casos manuais. Se a professora quiser conferir qualquer número do deck, está tudo versionado.</a:t>
+            </a:r>
+            <a:endParaRPr lang="en-US" dirty="0"/>
+          </a:p>
+        </p:txBody>
+      </p:sp>
+      <p:sp>
+        <p:nvSpPr>
+          <p:cNvPr id="4" name="Slide Number Placeholder 3"/>
+          <p:cNvSpPr>
+            <a:spLocks noGrp="1"/>
+          </p:cNvSpPr>
+          <p:nvPr>
+            <p:ph type="sldNum" sz="quarter" idx="10"/>
+          </p:nvPr>
+        </p:nvSpPr>
+        <p:spPr/>
+        <p:txBody>
+          <a:bodyPr/>
+          <a:lstStyle/>
+          <a:p>
+            <a:fld id="{F7021451-1387-4CA6-816F-3879F97B5CBC}" type="slidenum">
+              <a:rPr lang="en-US"/>
+              <a:t>13</a:t>
+            </a:fld>
+            <a:endParaRPr lang="en-US"/>
+          </a:p>
+        </p:txBody>
+      </p:sp>
+    </p:spTree>
+    <p:extLst>
+      <p:ext uri="{BB962C8B-B14F-4D97-AF65-F5344CB8AC3E}">
+        <p14:creationId xmlns:p14="http://schemas.microsoft.com/office/powerpoint/2010/main" val="1024086991"/>
+      </p:ext>
+    </p:extLst>
+  </p:cSld>
+  <p:clrMapOvr>
+    <a:masterClrMapping/>
+  </p:clrMapOvr>
+</p:notes>
+</file>
+
+<file path=ppt/notesSlides/notesSlide14.xml><?xml version="1.0" encoding="utf-8"?>
+<p:notes xmlns:a="http://schemas.openxmlformats.org/drawingml/2006/main" xmlns:r="http://schemas.openxmlformats.org/officeDocument/2006/relationships" xmlns:p="http://schemas.openxmlformats.org/presentationml/2006/main">
+  <p:cSld>
+    <p:spTree>
+      <p:nvGrpSpPr>
+        <p:cNvPr id="1" name=""/>
+        <p:cNvGrpSpPr/>
+        <p:nvPr/>
+      </p:nvGrpSpPr>
+      <p:grpSpPr>
+        <a:xfrm>
+          <a:off x="0" y="0"/>
+          <a:ext cx="0" cy="0"/>
+          <a:chOff x="0" y="0"/>
+          <a:chExt cx="0" cy="0"/>
+        </a:xfrm>
+      </p:grpSpPr>
+      <p:sp>
+        <p:nvSpPr>
+          <p:cNvPr id="2" name="Slide Image Placeholder 1"/>
+          <p:cNvSpPr>
+            <a:spLocks noGrp="1" noRot="1" noChangeAspect="1"/>
+          </p:cNvSpPr>
+          <p:nvPr>
+            <p:ph type="sldImg"/>
+          </p:nvPr>
+        </p:nvSpPr>
+        <p:spPr/>
+      </p:sp>
+      <p:sp>
+        <p:nvSpPr>
+          <p:cNvPr id="3" name="Notes Placeholder 2"/>
+          <p:cNvSpPr>
+            <a:spLocks noGrp="1"/>
+          </p:cNvSpPr>
+          <p:nvPr>
+            <p:ph type="body" idx="1"/>
+          </p:nvPr>
+        </p:nvSpPr>
+        <p:spPr/>
+        <p:txBody>
+          <a:bodyPr/>
+          <a:lstStyle/>
+          <a:p>
+            <a:r>
+              <a:rPr lang="en-US" dirty="0"/>
+              <a:t>Anexo. Aqui está a rastreabilidade. Cada classe testada tem issue, cada caso manual tem issue, e cada defeito que abrimos tem uma issue com o teste que reproduz. As issues 20 a 25 são as que a gente abriu nesta entrega.</a:t>
+            </a:r>
+            <a:endParaRPr lang="en-US" dirty="0"/>
+          </a:p>
+        </p:txBody>
+      </p:sp>
+      <p:sp>
+        <p:nvSpPr>
+          <p:cNvPr id="4" name="Slide Number Placeholder 3"/>
+          <p:cNvSpPr>
+            <a:spLocks noGrp="1"/>
+          </p:cNvSpPr>
+          <p:nvPr>
+            <p:ph type="sldNum" sz="quarter" idx="10"/>
+          </p:nvPr>
+        </p:nvSpPr>
+        <p:spPr/>
+        <p:txBody>
+          <a:bodyPr/>
+          <a:lstStyle/>
+          <a:p>
+            <a:fld id="{F7021451-1387-4CA6-816F-3879F97B5CBC}" type="slidenum">
+              <a:rPr lang="en-US"/>
+              <a:t>14</a:t>
+            </a:fld>
+            <a:endParaRPr lang="en-US"/>
+          </a:p>
+        </p:txBody>
+      </p:sp>
+    </p:spTree>
+    <p:extLst>
+      <p:ext uri="{BB962C8B-B14F-4D97-AF65-F5344CB8AC3E}">
+        <p14:creationId xmlns:p14="http://schemas.microsoft.com/office/powerpoint/2010/main" val="1024086991"/>
+      </p:ext>
+    </p:extLst>
+  </p:cSld>
+  <p:clrMapOvr>
+    <a:masterClrMapping/>
+  </p:clrMapOvr>
+</p:notes>
+</file>
+
+<file path=ppt/notesSlides/notesSlide15.xml><?xml version="1.0" encoding="utf-8"?>
+<p:notes xmlns:a="http://schemas.openxmlformats.org/drawingml/2006/main" xmlns:r="http://schemas.openxmlformats.org/officeDocument/2006/relationships" xmlns:p="http://schemas.openxmlformats.org/presentationml/2006/main">
+  <p:cSld>
+    <p:spTree>
+      <p:nvGrpSpPr>
+        <p:cNvPr id="1" name=""/>
+        <p:cNvGrpSpPr/>
+        <p:nvPr/>
+      </p:nvGrpSpPr>
+      <p:grpSpPr>
+        <a:xfrm>
+          <a:off x="0" y="0"/>
+          <a:ext cx="0" cy="0"/>
+          <a:chOff x="0" y="0"/>
+          <a:chExt cx="0" cy="0"/>
+        </a:xfrm>
+      </p:grpSpPr>
+      <p:sp>
+        <p:nvSpPr>
+          <p:cNvPr id="2" name="Slide Image Placeholder 1"/>
+          <p:cNvSpPr>
+            <a:spLocks noGrp="1" noRot="1" noChangeAspect="1"/>
+          </p:cNvSpPr>
+          <p:nvPr>
+            <p:ph type="sldImg"/>
+          </p:nvPr>
+        </p:nvSpPr>
+        <p:spPr/>
+      </p:sp>
+      <p:sp>
+        <p:nvSpPr>
+          <p:cNvPr id="3" name="Notes Placeholder 2"/>
+          <p:cNvSpPr>
+            <a:spLocks noGrp="1"/>
+          </p:cNvSpPr>
+          <p:nvPr>
+            <p:ph type="body" idx="1"/>
+          </p:nvPr>
+        </p:nvSpPr>
+        <p:spPr/>
+        <p:txBody>
+          <a:bodyPr/>
+          <a:lstStyle/>
+          <a:p>
+            <a:r>
+              <a:rPr lang="en-US" dirty="0"/>
+              <a:t>Anexo. Esses são os cabeçalhos dos documentos de teste manual: CT-01 a CT-04. Cada um tem quem executou, a data e o ambiente. O formato é o mesmo modelo que o grupo já usava no CT-04.</a:t>
+            </a:r>
+            <a:endParaRPr lang="en-US" dirty="0"/>
+          </a:p>
+        </p:txBody>
+      </p:sp>
+      <p:sp>
+        <p:nvSpPr>
+          <p:cNvPr id="4" name="Slide Number Placeholder 3"/>
+          <p:cNvSpPr>
+            <a:spLocks noGrp="1"/>
+          </p:cNvSpPr>
+          <p:nvPr>
+            <p:ph type="sldNum" sz="quarter" idx="10"/>
+          </p:nvPr>
+        </p:nvSpPr>
+        <p:spPr/>
+        <p:txBody>
+          <a:bodyPr/>
+          <a:lstStyle/>
+          <a:p>
+            <a:fld id="{F7021451-1387-4CA6-816F-3879F97B5CBC}" type="slidenum">
+              <a:rPr lang="en-US"/>
+              <a:t>15</a:t>
+            </a:fld>
+            <a:endParaRPr lang="en-US"/>
+          </a:p>
+        </p:txBody>
+      </p:sp>
+    </p:spTree>
+    <p:extLst>
+      <p:ext uri="{BB962C8B-B14F-4D97-AF65-F5344CB8AC3E}">
+        <p14:creationId xmlns:p14="http://schemas.microsoft.com/office/powerpoint/2010/main" val="1024086991"/>
+      </p:ext>
+    </p:extLst>
+  </p:cSld>
+  <p:clrMapOvr>
+    <a:masterClrMapping/>
+  </p:clrMapOvr>
+</p:notes>
+</file>
+
+<file path=ppt/notesSlides/notesSlide16.xml><?xml version="1.0" encoding="utf-8"?>
+<p:notes xmlns:a="http://schemas.openxmlformats.org/drawingml/2006/main" xmlns:r="http://schemas.openxmlformats.org/officeDocument/2006/relationships" xmlns:p="http://schemas.openxmlformats.org/presentationml/2006/main">
+  <p:cSld>
+    <p:spTree>
+      <p:nvGrpSpPr>
+        <p:cNvPr id="1" name=""/>
+        <p:cNvGrpSpPr/>
+        <p:nvPr/>
+      </p:nvGrpSpPr>
+      <p:grpSpPr>
+        <a:xfrm>
+          <a:off x="0" y="0"/>
+          <a:ext cx="0" cy="0"/>
+          <a:chOff x="0" y="0"/>
+          <a:chExt cx="0" cy="0"/>
+        </a:xfrm>
+      </p:grpSpPr>
+      <p:sp>
+        <p:nvSpPr>
+          <p:cNvPr id="2" name="Slide Image Placeholder 1"/>
+          <p:cNvSpPr>
+            <a:spLocks noGrp="1" noRot="1" noChangeAspect="1"/>
+          </p:cNvSpPr>
+          <p:nvPr>
+            <p:ph type="sldImg"/>
+          </p:nvPr>
+        </p:nvSpPr>
+        <p:spPr/>
+      </p:sp>
+      <p:sp>
+        <p:nvSpPr>
+          <p:cNvPr id="3" name="Notes Placeholder 2"/>
+          <p:cNvSpPr>
+            <a:spLocks noGrp="1"/>
+          </p:cNvSpPr>
+          <p:nvPr>
+            <p:ph type="body" idx="1"/>
+          </p:nvPr>
+        </p:nvSpPr>
+        <p:spPr/>
+        <p:txBody>
+          <a:bodyPr/>
+          <a:lstStyle/>
+          <a:p>
+            <a:r>
+              <a:rPr lang="en-US" dirty="0"/>
+              <a:t>Anexo. À esquerda o CT-05, o último caso manual. À direita a pasta de testes no repositório, organizada por camada: Controllers, DAO e Helpers.</a:t>
+            </a:r>
+            <a:endParaRPr lang="en-US" dirty="0"/>
+          </a:p>
+        </p:txBody>
+      </p:sp>
+      <p:sp>
+        <p:nvSpPr>
+          <p:cNvPr id="4" name="Slide Number Placeholder 3"/>
+          <p:cNvSpPr>
+            <a:spLocks noGrp="1"/>
+          </p:cNvSpPr>
+          <p:nvPr>
+            <p:ph type="sldNum" sz="quarter" idx="10"/>
+          </p:nvPr>
+        </p:nvSpPr>
+        <p:spPr/>
+        <p:txBody>
+          <a:bodyPr/>
+          <a:lstStyle/>
+          <a:p>
+            <a:fld id="{F7021451-1387-4CA6-816F-3879F97B5CBC}" type="slidenum">
+              <a:rPr lang="en-US"/>
+              <a:t>16</a:t>
+            </a:fld>
+            <a:endParaRPr lang="en-US"/>
+          </a:p>
+        </p:txBody>
+      </p:sp>
+    </p:spTree>
+    <p:extLst>
+      <p:ext uri="{BB962C8B-B14F-4D97-AF65-F5344CB8AC3E}">
+        <p14:creationId xmlns:p14="http://schemas.microsoft.com/office/powerpoint/2010/main" val="1024086991"/>
+      </p:ext>
+    </p:extLst>
+  </p:cSld>
+  <p:clrMapOvr>
+    <a:masterClrMapping/>
+  </p:clrMapOvr>
+</p:notes>
+</file>
+
+<file path=ppt/notesSlides/notesSlide17.xml><?xml version="1.0" encoding="utf-8"?>
+<p:notes xmlns:a="http://schemas.openxmlformats.org/drawingml/2006/main" xmlns:r="http://schemas.openxmlformats.org/officeDocument/2006/relationships" xmlns:p="http://schemas.openxmlformats.org/presentationml/2006/main">
+  <p:cSld>
+    <p:spTree>
+      <p:nvGrpSpPr>
+        <p:cNvPr id="1" name=""/>
+        <p:cNvGrpSpPr/>
+        <p:nvPr/>
+      </p:nvGrpSpPr>
+      <p:grpSpPr>
+        <a:xfrm>
+          <a:off x="0" y="0"/>
+          <a:ext cx="0" cy="0"/>
+          <a:chOff x="0" y="0"/>
+          <a:chExt cx="0" cy="0"/>
+        </a:xfrm>
+      </p:grpSpPr>
+      <p:sp>
+        <p:nvSpPr>
+          <p:cNvPr id="2" name="Slide Image Placeholder 1"/>
+          <p:cNvSpPr>
+            <a:spLocks noGrp="1" noRot="1" noChangeAspect="1"/>
+          </p:cNvSpPr>
+          <p:nvPr>
+            <p:ph type="sldImg"/>
+          </p:nvPr>
+        </p:nvSpPr>
+        <p:spPr/>
+      </p:sp>
+      <p:sp>
+        <p:nvSpPr>
+          <p:cNvPr id="3" name="Notes Placeholder 2"/>
+          <p:cNvSpPr>
+            <a:spLocks noGrp="1"/>
+          </p:cNvSpPr>
+          <p:nvPr>
+            <p:ph type="body" idx="1"/>
+          </p:nvPr>
+        </p:nvSpPr>
+        <p:spPr/>
+        <p:txBody>
+          <a:bodyPr/>
+          <a:lstStyle/>
+          <a:p>
+            <a:r>
+              <a:rPr lang="en-US" dirty="0"/>
+              <a:t>Anexo. Essa é a saída real do Maven. Em cima, a suíte padrão: 115 testes, zero falhas. Embaixo, o perfil de defeitos, com os cinco testes vermelhos e o nome de cada um. Dá pra rodar os dois comandos na hora, se quiserem ver.</a:t>
+            </a:r>
+            <a:endParaRPr lang="en-US" dirty="0"/>
+          </a:p>
+        </p:txBody>
+      </p:sp>
+      <p:sp>
+        <p:nvSpPr>
+          <p:cNvPr id="4" name="Slide Number Placeholder 3"/>
+          <p:cNvSpPr>
+            <a:spLocks noGrp="1"/>
+          </p:cNvSpPr>
+          <p:nvPr>
+            <p:ph type="sldNum" sz="quarter" idx="10"/>
+          </p:nvPr>
+        </p:nvSpPr>
+        <p:spPr/>
+        <p:txBody>
+          <a:bodyPr/>
+          <a:lstStyle/>
+          <a:p>
+            <a:fld id="{F7021451-1387-4CA6-816F-3879F97B5CBC}" type="slidenum">
+              <a:rPr lang="en-US"/>
+              <a:t>17</a:t>
             </a:fld>
             <a:endParaRPr lang="en-US"/>
           </a:p>
@@ -4240,6 +4685,1430 @@
 </p:sld>
 </file>
 
+<file path=ppt/slides/slide13.xml><?xml version="1.0" encoding="utf-8"?>
+<p:sld xmlns:a="http://schemas.openxmlformats.org/drawingml/2006/main" xmlns:r="http://schemas.openxmlformats.org/officeDocument/2006/relationships" xmlns:p="http://schemas.openxmlformats.org/presentationml/2006/main">
+  <p:cSld name="Slide 13">
+    <p:bg>
+      <p:bgPr>
+        <a:solidFill>
+          <a:srgbClr val="FFFFFF"/>
+        </a:solidFill>
+      </p:bgPr>
+    </p:bg>
+    <p:spTree>
+      <p:nvGrpSpPr>
+        <p:cNvPr id="1" name=""/>
+        <p:cNvGrpSpPr/>
+        <p:nvPr/>
+      </p:nvGrpSpPr>
+      <p:grpSpPr>
+        <a:xfrm>
+          <a:off x="0" y="0"/>
+          <a:ext cx="0" cy="0"/>
+          <a:chOff x="0" y="0"/>
+          <a:chExt cx="0" cy="0"/>
+        </a:xfrm>
+      </p:grpSpPr>
+      <p:sp>
+        <p:nvSpPr>
+          <p:cNvPr id="2" name="Text 0"/>
+          <p:cNvSpPr txBox="1"/>
+          <p:nvPr/>
+        </p:nvSpPr>
+        <p:spPr>
+          <a:xfrm>
+            <a:off x="457200" y="292608"/>
+            <a:ext cx="2743200" cy="219456"/>
+          </a:xfrm>
+          <a:prstGeom prst="rect">
+            <a:avLst/>
+          </a:prstGeom>
+          <a:noFill/>
+          <a:ln/>
+        </p:spPr>
+        <p:txBody>
+          <a:bodyPr wrap="square" lIns="0" tIns="0" rIns="0" bIns="0" rtlCol="0" anchor="t"/>
+          <a:lstStyle/>
+          <a:p>
+            <a:pPr indent="0" marL="0">
+              <a:buNone/>
+            </a:pPr>
+            <a:r>
+              <a:rPr lang="en-US" sz="1000" b="1" spc="200" kern="0" dirty="0">
+                <a:solidFill>
+                  <a:srgbClr val="C8352B"/>
+                </a:solidFill>
+                <a:latin typeface="Calibri" pitchFamily="34" charset="0"/>
+                <a:ea typeface="Calibri" pitchFamily="34" charset="-122"/>
+                <a:cs typeface="Calibri" pitchFamily="34" charset="-120"/>
+              </a:rPr>
+              <a:t>ANEXO</a:t>
+            </a:r>
+            <a:endParaRPr lang="en-US" sz="1000" dirty="0"/>
+          </a:p>
+        </p:txBody>
+      </p:sp>
+      <p:sp>
+        <p:nvSpPr>
+          <p:cNvPr id="3" name="Text 1"/>
+          <p:cNvSpPr txBox="1"/>
+          <p:nvPr/>
+        </p:nvSpPr>
+        <p:spPr>
+          <a:xfrm>
+            <a:off x="457200" y="512064"/>
+            <a:ext cx="8229600" cy="411480"/>
+          </a:xfrm>
+          <a:prstGeom prst="rect">
+            <a:avLst/>
+          </a:prstGeom>
+          <a:noFill/>
+          <a:ln/>
+        </p:spPr>
+        <p:txBody>
+          <a:bodyPr wrap="square" lIns="0" tIns="0" rIns="0" bIns="0" rtlCol="0" anchor="t"/>
+          <a:lstStyle/>
+          <a:p>
+            <a:pPr indent="0" marL="0">
+              <a:buNone/>
+            </a:pPr>
+            <a:r>
+              <a:rPr lang="en-US" sz="2300" b="1" dirty="0">
+                <a:solidFill>
+                  <a:srgbClr val="2B1B17"/>
+                </a:solidFill>
+                <a:latin typeface="Cambria" pitchFamily="34" charset="0"/>
+                <a:ea typeface="Cambria" pitchFamily="34" charset="-122"/>
+                <a:cs typeface="Cambria" pitchFamily="34" charset="-120"/>
+              </a:rPr>
+              <a:t>O que está versionado no repositório</a:t>
+            </a:r>
+            <a:endParaRPr lang="en-US" sz="2300" dirty="0"/>
+          </a:p>
+        </p:txBody>
+      </p:sp>
+      <p:sp>
+        <p:nvSpPr>
+          <p:cNvPr id="4" name="Text 2"/>
+          <p:cNvSpPr txBox="1"/>
+          <p:nvPr/>
+        </p:nvSpPr>
+        <p:spPr>
+          <a:xfrm>
+            <a:off x="457200" y="914400"/>
+            <a:ext cx="8229600" cy="237744"/>
+          </a:xfrm>
+          <a:prstGeom prst="rect">
+            <a:avLst/>
+          </a:prstGeom>
+          <a:noFill/>
+          <a:ln/>
+        </p:spPr>
+        <p:txBody>
+          <a:bodyPr wrap="square" lIns="0" tIns="0" rIns="0" bIns="0" rtlCol="0" anchor="t"/>
+          <a:lstStyle/>
+          <a:p>
+            <a:pPr indent="0" marL="0">
+              <a:buNone/>
+            </a:pPr>
+            <a:r>
+              <a:rPr lang="en-US" sz="1100" dirty="0">
+                <a:solidFill>
+                  <a:srgbClr val="6B5B55"/>
+                </a:solidFill>
+                <a:latin typeface="Calibri" pitchFamily="34" charset="0"/>
+                <a:ea typeface="Calibri" pitchFamily="34" charset="-122"/>
+                <a:cs typeface="Calibri" pitchFamily="34" charset="-120"/>
+              </a:rPr>
+              <a:t>Branch docs/entrega-1-manuais-e-apresentacao, capturado do GitHub</a:t>
+            </a:r>
+            <a:endParaRPr lang="en-US" sz="1100" dirty="0"/>
+          </a:p>
+        </p:txBody>
+      </p:sp>
+      <p:pic>
+        <p:nvPicPr>
+          <p:cNvPr id="5" name="Image 0" descr="C:\Users\felip\source\repos\trabalho-qualidade-e-teste-de-software\docs\entrega-1\apresentacao\anexos\github-pasta-entrega1.png">    </p:cNvPr>
+          <p:cNvPicPr>
+            <a:picLocks noChangeAspect="1"/>
+          </p:cNvPicPr>
+          <p:nvPr/>
+        </p:nvPicPr>
+        <p:blipFill>
+          <a:blip r:embed="rId1"/>
+          <a:stretch>
+            <a:fillRect/>
+          </a:stretch>
+        </p:blipFill>
+        <p:spPr>
+          <a:xfrm>
+            <a:off x="457200" y="1207008"/>
+            <a:ext cx="4069080" cy="2978567"/>
+          </a:xfrm>
+          <a:prstGeom prst="rect">
+            <a:avLst/>
+          </a:prstGeom>
+        </p:spPr>
+      </p:pic>
+      <p:pic>
+        <p:nvPicPr>
+          <p:cNvPr id="6" name="Image 1" descr="C:\Users\felip\source\repos\trabalho-qualidade-e-teste-de-software\docs\entrega-1\apresentacao\anexos\github-pasta-casos-manuais.png">    </p:cNvPr>
+          <p:cNvPicPr>
+            <a:picLocks noChangeAspect="1"/>
+          </p:cNvPicPr>
+          <p:nvPr/>
+        </p:nvPicPr>
+        <p:blipFill>
+          <a:blip r:embed="rId2"/>
+          <a:stretch>
+            <a:fillRect/>
+          </a:stretch>
+        </p:blipFill>
+        <p:spPr>
+          <a:xfrm>
+            <a:off x="4617720" y="1207008"/>
+            <a:ext cx="4069080" cy="2978567"/>
+          </a:xfrm>
+          <a:prstGeom prst="rect">
+            <a:avLst/>
+          </a:prstGeom>
+        </p:spPr>
+      </p:pic>
+      <p:sp>
+        <p:nvSpPr>
+          <p:cNvPr id="7" name="Text 3"/>
+          <p:cNvSpPr txBox="1"/>
+          <p:nvPr/>
+        </p:nvSpPr>
+        <p:spPr>
+          <a:xfrm>
+            <a:off x="457200" y="4224528"/>
+            <a:ext cx="4069080" cy="457200"/>
+          </a:xfrm>
+          <a:prstGeom prst="rect">
+            <a:avLst/>
+          </a:prstGeom>
+          <a:noFill/>
+          <a:ln/>
+        </p:spPr>
+        <p:txBody>
+          <a:bodyPr wrap="square" lIns="0" tIns="0" rIns="0" bIns="0" rtlCol="0" anchor="t"/>
+          <a:lstStyle/>
+          <a:p>
+            <a:pPr indent="0" marL="0">
+              <a:buNone/>
+            </a:pPr>
+            <a:r>
+              <a:rPr lang="en-US" sz="1050" dirty="0">
+                <a:solidFill>
+                  <a:srgbClr val="6B5B55"/>
+                </a:solidFill>
+                <a:latin typeface="Calibri" pitchFamily="34" charset="0"/>
+                <a:ea typeface="Calibri" pitchFamily="34" charset="-122"/>
+                <a:cs typeface="Calibri" pitchFamily="34" charset="-120"/>
+              </a:rPr>
+              <a:t>docs/entrega-1: relatório, apresentação e casos manuais</a:t>
+            </a:r>
+            <a:endParaRPr lang="en-US" sz="1050" dirty="0"/>
+          </a:p>
+        </p:txBody>
+      </p:sp>
+      <p:sp>
+        <p:nvSpPr>
+          <p:cNvPr id="8" name="Text 4"/>
+          <p:cNvSpPr txBox="1"/>
+          <p:nvPr/>
+        </p:nvSpPr>
+        <p:spPr>
+          <a:xfrm>
+            <a:off x="4617720" y="4224528"/>
+            <a:ext cx="4069080" cy="457200"/>
+          </a:xfrm>
+          <a:prstGeom prst="rect">
+            <a:avLst/>
+          </a:prstGeom>
+          <a:noFill/>
+          <a:ln/>
+        </p:spPr>
+        <p:txBody>
+          <a:bodyPr wrap="square" lIns="0" tIns="0" rIns="0" bIns="0" rtlCol="0" anchor="t"/>
+          <a:lstStyle/>
+          <a:p>
+            <a:pPr indent="0" marL="0">
+              <a:buNone/>
+            </a:pPr>
+            <a:r>
+              <a:rPr lang="en-US" sz="1050" dirty="0">
+                <a:solidFill>
+                  <a:srgbClr val="6B5B55"/>
+                </a:solidFill>
+                <a:latin typeface="Calibri" pitchFamily="34" charset="0"/>
+                <a:ea typeface="Calibri" pitchFamily="34" charset="-122"/>
+                <a:cs typeface="Calibri" pitchFamily="34" charset="-120"/>
+              </a:rPr>
+              <a:t>casos-manuais: um documento por integrante, com prints</a:t>
+            </a:r>
+            <a:endParaRPr lang="en-US" sz="1050" dirty="0"/>
+          </a:p>
+        </p:txBody>
+      </p:sp>
+      <p:sp>
+        <p:nvSpPr>
+          <p:cNvPr id="9" name="Text 5"/>
+          <p:cNvSpPr txBox="1"/>
+          <p:nvPr/>
+        </p:nvSpPr>
+        <p:spPr>
+          <a:xfrm>
+            <a:off x="457200" y="4681728"/>
+            <a:ext cx="8229600" cy="274320"/>
+          </a:xfrm>
+          <a:prstGeom prst="rect">
+            <a:avLst/>
+          </a:prstGeom>
+          <a:noFill/>
+          <a:ln/>
+        </p:spPr>
+        <p:txBody>
+          <a:bodyPr wrap="square" lIns="0" tIns="0" rIns="0" bIns="0" rtlCol="0" anchor="t"/>
+          <a:lstStyle/>
+          <a:p>
+            <a:pPr indent="0" marL="0">
+              <a:buNone/>
+            </a:pPr>
+            <a:r>
+              <a:rPr lang="en-US" sz="1150" dirty="0">
+                <a:solidFill>
+                  <a:srgbClr val="2B1B17"/>
+                </a:solidFill>
+                <a:latin typeface="Calibri" pitchFamily="34" charset="0"/>
+                <a:ea typeface="Calibri" pitchFamily="34" charset="-122"/>
+                <a:cs typeface="Calibri" pitchFamily="34" charset="-120"/>
+              </a:rPr>
+              <a:t>Tudo o que está nestes slides sai desses arquivos: nada foi montado só para a apresentação.</a:t>
+            </a:r>
+            <a:endParaRPr lang="en-US" sz="1150" dirty="0"/>
+          </a:p>
+        </p:txBody>
+      </p:sp>
+    </p:spTree>
+  </p:cSld>
+  <p:clrMapOvr>
+    <a:masterClrMapping/>
+  </p:clrMapOvr>
+</p:sld>
+</file>
+
+<file path=ppt/slides/slide14.xml><?xml version="1.0" encoding="utf-8"?>
+<p:sld xmlns:a="http://schemas.openxmlformats.org/drawingml/2006/main" xmlns:r="http://schemas.openxmlformats.org/officeDocument/2006/relationships" xmlns:p="http://schemas.openxmlformats.org/presentationml/2006/main">
+  <p:cSld name="Slide 14">
+    <p:bg>
+      <p:bgPr>
+        <a:solidFill>
+          <a:srgbClr val="FFFFFF"/>
+        </a:solidFill>
+      </p:bgPr>
+    </p:bg>
+    <p:spTree>
+      <p:nvGrpSpPr>
+        <p:cNvPr id="1" name=""/>
+        <p:cNvGrpSpPr/>
+        <p:nvPr/>
+      </p:nvGrpSpPr>
+      <p:grpSpPr>
+        <a:xfrm>
+          <a:off x="0" y="0"/>
+          <a:ext cx="0" cy="0"/>
+          <a:chOff x="0" y="0"/>
+          <a:chExt cx="0" cy="0"/>
+        </a:xfrm>
+      </p:grpSpPr>
+      <p:sp>
+        <p:nvSpPr>
+          <p:cNvPr id="2" name="Text 0"/>
+          <p:cNvSpPr txBox="1"/>
+          <p:nvPr/>
+        </p:nvSpPr>
+        <p:spPr>
+          <a:xfrm>
+            <a:off x="457200" y="292608"/>
+            <a:ext cx="2743200" cy="219456"/>
+          </a:xfrm>
+          <a:prstGeom prst="rect">
+            <a:avLst/>
+          </a:prstGeom>
+          <a:noFill/>
+          <a:ln/>
+        </p:spPr>
+        <p:txBody>
+          <a:bodyPr wrap="square" lIns="0" tIns="0" rIns="0" bIns="0" rtlCol="0" anchor="t"/>
+          <a:lstStyle/>
+          <a:p>
+            <a:pPr indent="0" marL="0">
+              <a:buNone/>
+            </a:pPr>
+            <a:r>
+              <a:rPr lang="en-US" sz="1000" b="1" spc="200" kern="0" dirty="0">
+                <a:solidFill>
+                  <a:srgbClr val="C8352B"/>
+                </a:solidFill>
+                <a:latin typeface="Calibri" pitchFamily="34" charset="0"/>
+                <a:ea typeface="Calibri" pitchFamily="34" charset="-122"/>
+                <a:cs typeface="Calibri" pitchFamily="34" charset="-120"/>
+              </a:rPr>
+              <a:t>ANEXO</a:t>
+            </a:r>
+            <a:endParaRPr lang="en-US" sz="1000" dirty="0"/>
+          </a:p>
+        </p:txBody>
+      </p:sp>
+      <p:sp>
+        <p:nvSpPr>
+          <p:cNvPr id="3" name="Text 1"/>
+          <p:cNvSpPr txBox="1"/>
+          <p:nvPr/>
+        </p:nvSpPr>
+        <p:spPr>
+          <a:xfrm>
+            <a:off x="457200" y="512064"/>
+            <a:ext cx="8229600" cy="411480"/>
+          </a:xfrm>
+          <a:prstGeom prst="rect">
+            <a:avLst/>
+          </a:prstGeom>
+          <a:noFill/>
+          <a:ln/>
+        </p:spPr>
+        <p:txBody>
+          <a:bodyPr wrap="square" lIns="0" tIns="0" rIns="0" bIns="0" rtlCol="0" anchor="t"/>
+          <a:lstStyle/>
+          <a:p>
+            <a:pPr indent="0" marL="0">
+              <a:buNone/>
+            </a:pPr>
+            <a:r>
+              <a:rPr lang="en-US" sz="2300" b="1" dirty="0">
+                <a:solidFill>
+                  <a:srgbClr val="2B1B17"/>
+                </a:solidFill>
+                <a:latin typeface="Cambria" pitchFamily="34" charset="0"/>
+                <a:ea typeface="Cambria" pitchFamily="34" charset="-122"/>
+                <a:cs typeface="Cambria" pitchFamily="34" charset="-120"/>
+              </a:rPr>
+              <a:t>Rastreabilidade no GitHub</a:t>
+            </a:r>
+            <a:endParaRPr lang="en-US" sz="2300" dirty="0"/>
+          </a:p>
+        </p:txBody>
+      </p:sp>
+      <p:sp>
+        <p:nvSpPr>
+          <p:cNvPr id="4" name="Text 2"/>
+          <p:cNvSpPr txBox="1"/>
+          <p:nvPr/>
+        </p:nvSpPr>
+        <p:spPr>
+          <a:xfrm>
+            <a:off x="457200" y="914400"/>
+            <a:ext cx="8229600" cy="237744"/>
+          </a:xfrm>
+          <a:prstGeom prst="rect">
+            <a:avLst/>
+          </a:prstGeom>
+          <a:noFill/>
+          <a:ln/>
+        </p:spPr>
+        <p:txBody>
+          <a:bodyPr wrap="square" lIns="0" tIns="0" rIns="0" bIns="0" rtlCol="0" anchor="t"/>
+          <a:lstStyle/>
+          <a:p>
+            <a:pPr indent="0" marL="0">
+              <a:buNone/>
+            </a:pPr>
+            <a:r>
+              <a:rPr lang="en-US" sz="1100" dirty="0">
+                <a:solidFill>
+                  <a:srgbClr val="6B5B55"/>
+                </a:solidFill>
+                <a:latin typeface="Calibri" pitchFamily="34" charset="0"/>
+                <a:ea typeface="Calibri" pitchFamily="34" charset="-122"/>
+                <a:cs typeface="Calibri" pitchFamily="34" charset="-120"/>
+              </a:rPr>
+              <a:t>Issues do repositório: unit-test, manual-test e os defeitos encontrados</a:t>
+            </a:r>
+            <a:endParaRPr lang="en-US" sz="1100" dirty="0"/>
+          </a:p>
+        </p:txBody>
+      </p:sp>
+      <p:pic>
+        <p:nvPicPr>
+          <p:cNvPr id="5" name="Image 0" descr="C:\Users\felip\source\repos\trabalho-qualidade-e-teste-de-software\docs\entrega-1\apresentacao\anexos\github-issues.png">    </p:cNvPr>
+          <p:cNvPicPr>
+            <a:picLocks noChangeAspect="1"/>
+          </p:cNvPicPr>
+          <p:nvPr/>
+        </p:nvPicPr>
+        <p:blipFill>
+          <a:blip r:embed="rId1"/>
+          <a:stretch>
+            <a:fillRect/>
+          </a:stretch>
+        </p:blipFill>
+        <p:spPr>
+          <a:xfrm>
+            <a:off x="4846320" y="1234440"/>
+            <a:ext cx="3840480" cy="3840480"/>
+          </a:xfrm>
+          <a:prstGeom prst="rect">
+            <a:avLst/>
+          </a:prstGeom>
+        </p:spPr>
+      </p:pic>
+      <p:sp>
+        <p:nvSpPr>
+          <p:cNvPr id="6" name="Text 3"/>
+          <p:cNvSpPr txBox="1"/>
+          <p:nvPr/>
+        </p:nvSpPr>
+        <p:spPr>
+          <a:xfrm>
+            <a:off x="457200" y="1371600"/>
+            <a:ext cx="4114800" cy="2743200"/>
+          </a:xfrm>
+          <a:prstGeom prst="rect">
+            <a:avLst/>
+          </a:prstGeom>
+          <a:noFill/>
+          <a:ln/>
+        </p:spPr>
+        <p:txBody>
+          <a:bodyPr wrap="square" lIns="0" tIns="0" rIns="0" bIns="0" rtlCol="0" anchor="t"/>
+          <a:lstStyle/>
+          <a:p>
+            <a:pPr marL="342900" indent="-342900">
+              <a:spcAft>
+                <a:spcPts val="600"/>
+              </a:spcAft>
+              <a:buSzPct val="100000"/>
+              <a:buChar char="•"/>
+            </a:pPr>
+            <a:r>
+              <a:rPr lang="en-US" sz="1250" dirty="0">
+                <a:solidFill>
+                  <a:srgbClr val="2B1B17"/>
+                </a:solidFill>
+                <a:latin typeface="Calibri" pitchFamily="34" charset="0"/>
+                <a:ea typeface="Calibri" pitchFamily="34" charset="-122"/>
+                <a:cs typeface="Calibri" pitchFamily="34" charset="-120"/>
+              </a:rPr>
+              <a:t>17 issues no total: 12 abertas e 5 fechadas.</a:t>
+            </a:r>
+            <a:endParaRPr lang="en-US" sz="1250" dirty="0"/>
+          </a:p>
+          <a:p>
+            <a:pPr marL="342900" indent="-342900">
+              <a:spcAft>
+                <a:spcPts val="600"/>
+              </a:spcAft>
+              <a:buSzPct val="100000"/>
+              <a:buChar char="•"/>
+            </a:pPr>
+            <a:r>
+              <a:rPr lang="en-US" sz="1250" dirty="0">
+                <a:solidFill>
+                  <a:srgbClr val="2B1B17"/>
+                </a:solidFill>
+                <a:latin typeface="Calibri" pitchFamily="34" charset="0"/>
+                <a:ea typeface="Calibri" pitchFamily="34" charset="-122"/>
+                <a:cs typeface="Calibri" pitchFamily="34" charset="-120"/>
+              </a:rPr>
+              <a:t>unit-test (#1 a #5): uma por classe testada.</a:t>
+            </a:r>
+            <a:endParaRPr lang="en-US" sz="1250" dirty="0"/>
+          </a:p>
+          <a:p>
+            <a:pPr marL="342900" indent="-342900">
+              <a:spcAft>
+                <a:spcPts val="600"/>
+              </a:spcAft>
+              <a:buSzPct val="100000"/>
+              <a:buChar char="•"/>
+            </a:pPr>
+            <a:r>
+              <a:rPr lang="en-US" sz="1250" dirty="0">
+                <a:solidFill>
+                  <a:srgbClr val="2B1B17"/>
+                </a:solidFill>
+                <a:latin typeface="Calibri" pitchFamily="34" charset="0"/>
+                <a:ea typeface="Calibri" pitchFamily="34" charset="-122"/>
+                <a:cs typeface="Calibri" pitchFamily="34" charset="-120"/>
+              </a:rPr>
+              <a:t>manual-test (#6 a #10): uma por caso de teste.</a:t>
+            </a:r>
+            <a:endParaRPr lang="en-US" sz="1250" dirty="0"/>
+          </a:p>
+          <a:p>
+            <a:pPr marL="342900" indent="-342900">
+              <a:spcAft>
+                <a:spcPts val="600"/>
+              </a:spcAft>
+              <a:buSzPct val="100000"/>
+              <a:buChar char="•"/>
+            </a:pPr>
+            <a:r>
+              <a:rPr lang="en-US" sz="1250" dirty="0">
+                <a:solidFill>
+                  <a:srgbClr val="2B1B17"/>
+                </a:solidFill>
+                <a:latin typeface="Calibri" pitchFamily="34" charset="0"/>
+                <a:ea typeface="Calibri" pitchFamily="34" charset="-122"/>
+                <a:cs typeface="Calibri" pitchFamily="34" charset="-120"/>
+              </a:rPr>
+              <a:t>bug (#20 a #25): os seis defeitos que abrimos, cada um com o teste que reproduz.</a:t>
+            </a:r>
+            <a:endParaRPr lang="en-US" sz="1250" dirty="0"/>
+          </a:p>
+          <a:p>
+            <a:pPr marL="342900" indent="-342900">
+              <a:spcAft>
+                <a:spcPts val="600"/>
+              </a:spcAft>
+              <a:buSzPct val="100000"/>
+              <a:buChar char="•"/>
+            </a:pPr>
+            <a:r>
+              <a:rPr lang="en-US" sz="1250" dirty="0">
+                <a:solidFill>
+                  <a:srgbClr val="2B1B17"/>
+                </a:solidFill>
+                <a:latin typeface="Calibri" pitchFamily="34" charset="0"/>
+                <a:ea typeface="Calibri" pitchFamily="34" charset="-122"/>
+                <a:cs typeface="Calibri" pitchFamily="34" charset="-120"/>
+              </a:rPr>
+              <a:t>#17: aberta pelo grupo a partir do CT-04; a causa é a #20.</a:t>
+            </a:r>
+            <a:endParaRPr lang="en-US" sz="1250" dirty="0"/>
+          </a:p>
+        </p:txBody>
+      </p:sp>
+      <p:sp>
+        <p:nvSpPr>
+          <p:cNvPr id="7" name="Text 4"/>
+          <p:cNvSpPr txBox="1"/>
+          <p:nvPr/>
+        </p:nvSpPr>
+        <p:spPr>
+          <a:xfrm>
+            <a:off x="457200" y="4206240"/>
+            <a:ext cx="4114800" cy="548640"/>
+          </a:xfrm>
+          <a:prstGeom prst="rect">
+            <a:avLst/>
+          </a:prstGeom>
+          <a:noFill/>
+          <a:ln/>
+        </p:spPr>
+        <p:txBody>
+          <a:bodyPr wrap="square" lIns="0" tIns="0" rIns="0" bIns="0" rtlCol="0" anchor="t"/>
+          <a:lstStyle/>
+          <a:p>
+            <a:pPr indent="0" marL="0">
+              <a:buNone/>
+            </a:pPr>
+            <a:r>
+              <a:rPr lang="en-US" sz="1100" dirty="0">
+                <a:solidFill>
+                  <a:srgbClr val="6B5B55"/>
+                </a:solidFill>
+                <a:latin typeface="Calibri" pitchFamily="34" charset="0"/>
+                <a:ea typeface="Calibri" pitchFamily="34" charset="-122"/>
+                <a:cs typeface="Calibri" pitchFamily="34" charset="-120"/>
+              </a:rPr>
+              <a:t>Os cinco achados dos testes manuais ainda não viraram issue: estão listados em docs/entrega-1/README.md.</a:t>
+            </a:r>
+            <a:endParaRPr lang="en-US" sz="1100" dirty="0"/>
+          </a:p>
+        </p:txBody>
+      </p:sp>
+    </p:spTree>
+  </p:cSld>
+  <p:clrMapOvr>
+    <a:masterClrMapping/>
+  </p:clrMapOvr>
+</p:sld>
+</file>
+
+<file path=ppt/slides/slide15.xml><?xml version="1.0" encoding="utf-8"?>
+<p:sld xmlns:a="http://schemas.openxmlformats.org/drawingml/2006/main" xmlns:r="http://schemas.openxmlformats.org/officeDocument/2006/relationships" xmlns:p="http://schemas.openxmlformats.org/presentationml/2006/main">
+  <p:cSld name="Slide 15">
+    <p:bg>
+      <p:bgPr>
+        <a:solidFill>
+          <a:srgbClr val="FFFFFF"/>
+        </a:solidFill>
+      </p:bgPr>
+    </p:bg>
+    <p:spTree>
+      <p:nvGrpSpPr>
+        <p:cNvPr id="1" name=""/>
+        <p:cNvGrpSpPr/>
+        <p:nvPr/>
+      </p:nvGrpSpPr>
+      <p:grpSpPr>
+        <a:xfrm>
+          <a:off x="0" y="0"/>
+          <a:ext cx="0" cy="0"/>
+          <a:chOff x="0" y="0"/>
+          <a:chExt cx="0" cy="0"/>
+        </a:xfrm>
+      </p:grpSpPr>
+      <p:sp>
+        <p:nvSpPr>
+          <p:cNvPr id="2" name="Text 0"/>
+          <p:cNvSpPr txBox="1"/>
+          <p:nvPr/>
+        </p:nvSpPr>
+        <p:spPr>
+          <a:xfrm>
+            <a:off x="457200" y="292608"/>
+            <a:ext cx="2743200" cy="219456"/>
+          </a:xfrm>
+          <a:prstGeom prst="rect">
+            <a:avLst/>
+          </a:prstGeom>
+          <a:noFill/>
+          <a:ln/>
+        </p:spPr>
+        <p:txBody>
+          <a:bodyPr wrap="square" lIns="0" tIns="0" rIns="0" bIns="0" rtlCol="0" anchor="t"/>
+          <a:lstStyle/>
+          <a:p>
+            <a:pPr indent="0" marL="0">
+              <a:buNone/>
+            </a:pPr>
+            <a:r>
+              <a:rPr lang="en-US" sz="1000" b="1" spc="200" kern="0" dirty="0">
+                <a:solidFill>
+                  <a:srgbClr val="C8352B"/>
+                </a:solidFill>
+                <a:latin typeface="Calibri" pitchFamily="34" charset="0"/>
+                <a:ea typeface="Calibri" pitchFamily="34" charset="-122"/>
+                <a:cs typeface="Calibri" pitchFamily="34" charset="-120"/>
+              </a:rPr>
+              <a:t>ANEXO</a:t>
+            </a:r>
+            <a:endParaRPr lang="en-US" sz="1000" dirty="0"/>
+          </a:p>
+        </p:txBody>
+      </p:sp>
+      <p:sp>
+        <p:nvSpPr>
+          <p:cNvPr id="3" name="Text 1"/>
+          <p:cNvSpPr txBox="1"/>
+          <p:nvPr/>
+        </p:nvSpPr>
+        <p:spPr>
+          <a:xfrm>
+            <a:off x="457200" y="512064"/>
+            <a:ext cx="8229600" cy="411480"/>
+          </a:xfrm>
+          <a:prstGeom prst="rect">
+            <a:avLst/>
+          </a:prstGeom>
+          <a:noFill/>
+          <a:ln/>
+        </p:spPr>
+        <p:txBody>
+          <a:bodyPr wrap="square" lIns="0" tIns="0" rIns="0" bIns="0" rtlCol="0" anchor="t"/>
+          <a:lstStyle/>
+          <a:p>
+            <a:pPr indent="0" marL="0">
+              <a:buNone/>
+            </a:pPr>
+            <a:r>
+              <a:rPr lang="en-US" sz="2300" b="1" dirty="0">
+                <a:solidFill>
+                  <a:srgbClr val="2B1B17"/>
+                </a:solidFill>
+                <a:latin typeface="Cambria" pitchFamily="34" charset="0"/>
+                <a:ea typeface="Cambria" pitchFamily="34" charset="-122"/>
+                <a:cs typeface="Cambria" pitchFamily="34" charset="-120"/>
+              </a:rPr>
+              <a:t>Casos de teste manuais</a:t>
+            </a:r>
+            <a:endParaRPr lang="en-US" sz="2300" dirty="0"/>
+          </a:p>
+        </p:txBody>
+      </p:sp>
+      <p:sp>
+        <p:nvSpPr>
+          <p:cNvPr id="4" name="Text 2"/>
+          <p:cNvSpPr txBox="1"/>
+          <p:nvPr/>
+        </p:nvSpPr>
+        <p:spPr>
+          <a:xfrm>
+            <a:off x="457200" y="914400"/>
+            <a:ext cx="8229600" cy="237744"/>
+          </a:xfrm>
+          <a:prstGeom prst="rect">
+            <a:avLst/>
+          </a:prstGeom>
+          <a:noFill/>
+          <a:ln/>
+        </p:spPr>
+        <p:txBody>
+          <a:bodyPr wrap="square" lIns="0" tIns="0" rIns="0" bIns="0" rtlCol="0" anchor="t"/>
+          <a:lstStyle/>
+          <a:p>
+            <a:pPr indent="0" marL="0">
+              <a:buNone/>
+            </a:pPr>
+            <a:r>
+              <a:rPr lang="en-US" sz="1100" dirty="0">
+                <a:solidFill>
+                  <a:srgbClr val="6B5B55"/>
+                </a:solidFill>
+                <a:latin typeface="Calibri" pitchFamily="34" charset="0"/>
+                <a:ea typeface="Calibri" pitchFamily="34" charset="-122"/>
+                <a:cs typeface="Calibri" pitchFamily="34" charset="-120"/>
+              </a:rPr>
+              <a:t>Cabeçalho dos documentos: testador, data e ambiente de execução</a:t>
+            </a:r>
+            <a:endParaRPr lang="en-US" sz="1100" dirty="0"/>
+          </a:p>
+        </p:txBody>
+      </p:sp>
+      <p:pic>
+        <p:nvPicPr>
+          <p:cNvPr id="5" name="Image 0" descr="C:\Users\felip\source\repos\trabalho-qualidade-e-teste-de-software\docs\entrega-1\apresentacao\anexos\caso-01.png">    </p:cNvPr>
+          <p:cNvPicPr>
+            <a:picLocks noChangeAspect="1"/>
+          </p:cNvPicPr>
+          <p:nvPr/>
+        </p:nvPicPr>
+        <p:blipFill>
+          <a:blip r:embed="rId1"/>
+          <a:stretch>
+            <a:fillRect/>
+          </a:stretch>
+        </p:blipFill>
+        <p:spPr>
+          <a:xfrm>
+            <a:off x="457200" y="1188720"/>
+            <a:ext cx="3566160" cy="1843401"/>
+          </a:xfrm>
+          <a:prstGeom prst="rect">
+            <a:avLst/>
+          </a:prstGeom>
+        </p:spPr>
+      </p:pic>
+      <p:pic>
+        <p:nvPicPr>
+          <p:cNvPr id="6" name="Image 1" descr="C:\Users\felip\source\repos\trabalho-qualidade-e-teste-de-software\docs\entrega-1\apresentacao\anexos\caso-02.png">    </p:cNvPr>
+          <p:cNvPicPr>
+            <a:picLocks noChangeAspect="1"/>
+          </p:cNvPicPr>
+          <p:nvPr/>
+        </p:nvPicPr>
+        <p:blipFill>
+          <a:blip r:embed="rId2"/>
+          <a:stretch>
+            <a:fillRect/>
+          </a:stretch>
+        </p:blipFill>
+        <p:spPr>
+          <a:xfrm>
+            <a:off x="4937760" y="1188720"/>
+            <a:ext cx="3566160" cy="1819272"/>
+          </a:xfrm>
+          <a:prstGeom prst="rect">
+            <a:avLst/>
+          </a:prstGeom>
+        </p:spPr>
+      </p:pic>
+      <p:pic>
+        <p:nvPicPr>
+          <p:cNvPr id="7" name="Image 2" descr="C:\Users\felip\source\repos\trabalho-qualidade-e-teste-de-software\docs\entrega-1\apresentacao\anexos\caso-03.png">    </p:cNvPr>
+          <p:cNvPicPr>
+            <a:picLocks noChangeAspect="1"/>
+          </p:cNvPicPr>
+          <p:nvPr/>
+        </p:nvPicPr>
+        <p:blipFill>
+          <a:blip r:embed="rId3"/>
+          <a:stretch>
+            <a:fillRect/>
+          </a:stretch>
+        </p:blipFill>
+        <p:spPr>
+          <a:xfrm>
+            <a:off x="457200" y="3154680"/>
+            <a:ext cx="3566160" cy="1807373"/>
+          </a:xfrm>
+          <a:prstGeom prst="rect">
+            <a:avLst/>
+          </a:prstGeom>
+        </p:spPr>
+      </p:pic>
+      <p:pic>
+        <p:nvPicPr>
+          <p:cNvPr id="8" name="Image 3" descr="C:\Users\felip\source\repos\trabalho-qualidade-e-teste-de-software\docs\entrega-1\apresentacao\anexos\caso-04.png">    </p:cNvPr>
+          <p:cNvPicPr>
+            <a:picLocks noChangeAspect="1"/>
+          </p:cNvPicPr>
+          <p:nvPr/>
+        </p:nvPicPr>
+        <p:blipFill>
+          <a:blip r:embed="rId4"/>
+          <a:stretch>
+            <a:fillRect/>
+          </a:stretch>
+        </p:blipFill>
+        <p:spPr>
+          <a:xfrm>
+            <a:off x="4937760" y="3154680"/>
+            <a:ext cx="3566160" cy="1102581"/>
+          </a:xfrm>
+          <a:prstGeom prst="rect">
+            <a:avLst/>
+          </a:prstGeom>
+        </p:spPr>
+      </p:pic>
+    </p:spTree>
+  </p:cSld>
+  <p:clrMapOvr>
+    <a:masterClrMapping/>
+  </p:clrMapOvr>
+</p:sld>
+</file>
+
+<file path=ppt/slides/slide16.xml><?xml version="1.0" encoding="utf-8"?>
+<p:sld xmlns:a="http://schemas.openxmlformats.org/drawingml/2006/main" xmlns:r="http://schemas.openxmlformats.org/officeDocument/2006/relationships" xmlns:p="http://schemas.openxmlformats.org/presentationml/2006/main">
+  <p:cSld name="Slide 16">
+    <p:bg>
+      <p:bgPr>
+        <a:solidFill>
+          <a:srgbClr val="FFFFFF"/>
+        </a:solidFill>
+      </p:bgPr>
+    </p:bg>
+    <p:spTree>
+      <p:nvGrpSpPr>
+        <p:cNvPr id="1" name=""/>
+        <p:cNvGrpSpPr/>
+        <p:nvPr/>
+      </p:nvGrpSpPr>
+      <p:grpSpPr>
+        <a:xfrm>
+          <a:off x="0" y="0"/>
+          <a:ext cx="0" cy="0"/>
+          <a:chOff x="0" y="0"/>
+          <a:chExt cx="0" cy="0"/>
+        </a:xfrm>
+      </p:grpSpPr>
+      <p:sp>
+        <p:nvSpPr>
+          <p:cNvPr id="2" name="Text 0"/>
+          <p:cNvSpPr txBox="1"/>
+          <p:nvPr/>
+        </p:nvSpPr>
+        <p:spPr>
+          <a:xfrm>
+            <a:off x="457200" y="292608"/>
+            <a:ext cx="2743200" cy="219456"/>
+          </a:xfrm>
+          <a:prstGeom prst="rect">
+            <a:avLst/>
+          </a:prstGeom>
+          <a:noFill/>
+          <a:ln/>
+        </p:spPr>
+        <p:txBody>
+          <a:bodyPr wrap="square" lIns="0" tIns="0" rIns="0" bIns="0" rtlCol="0" anchor="t"/>
+          <a:lstStyle/>
+          <a:p>
+            <a:pPr indent="0" marL="0">
+              <a:buNone/>
+            </a:pPr>
+            <a:r>
+              <a:rPr lang="en-US" sz="1000" b="1" spc="200" kern="0" dirty="0">
+                <a:solidFill>
+                  <a:srgbClr val="C8352B"/>
+                </a:solidFill>
+                <a:latin typeface="Calibri" pitchFamily="34" charset="0"/>
+                <a:ea typeface="Calibri" pitchFamily="34" charset="-122"/>
+                <a:cs typeface="Calibri" pitchFamily="34" charset="-120"/>
+              </a:rPr>
+              <a:t>ANEXO</a:t>
+            </a:r>
+            <a:endParaRPr lang="en-US" sz="1000" dirty="0"/>
+          </a:p>
+        </p:txBody>
+      </p:sp>
+      <p:sp>
+        <p:nvSpPr>
+          <p:cNvPr id="3" name="Text 1"/>
+          <p:cNvSpPr txBox="1"/>
+          <p:nvPr/>
+        </p:nvSpPr>
+        <p:spPr>
+          <a:xfrm>
+            <a:off x="457200" y="512064"/>
+            <a:ext cx="8229600" cy="411480"/>
+          </a:xfrm>
+          <a:prstGeom prst="rect">
+            <a:avLst/>
+          </a:prstGeom>
+          <a:noFill/>
+          <a:ln/>
+        </p:spPr>
+        <p:txBody>
+          <a:bodyPr wrap="square" lIns="0" tIns="0" rIns="0" bIns="0" rtlCol="0" anchor="t"/>
+          <a:lstStyle/>
+          <a:p>
+            <a:pPr indent="0" marL="0">
+              <a:buNone/>
+            </a:pPr>
+            <a:r>
+              <a:rPr lang="en-US" sz="2300" b="1" dirty="0">
+                <a:solidFill>
+                  <a:srgbClr val="2B1B17"/>
+                </a:solidFill>
+                <a:latin typeface="Cambria" pitchFamily="34" charset="0"/>
+                <a:ea typeface="Cambria" pitchFamily="34" charset="-122"/>
+                <a:cs typeface="Cambria" pitchFamily="34" charset="-120"/>
+              </a:rPr>
+              <a:t>CT-05 e as suítes de teste</a:t>
+            </a:r>
+            <a:endParaRPr lang="en-US" sz="2300" dirty="0"/>
+          </a:p>
+        </p:txBody>
+      </p:sp>
+      <p:sp>
+        <p:nvSpPr>
+          <p:cNvPr id="4" name="Text 2"/>
+          <p:cNvSpPr txBox="1"/>
+          <p:nvPr/>
+        </p:nvSpPr>
+        <p:spPr>
+          <a:xfrm>
+            <a:off x="457200" y="914400"/>
+            <a:ext cx="8229600" cy="237744"/>
+          </a:xfrm>
+          <a:prstGeom prst="rect">
+            <a:avLst/>
+          </a:prstGeom>
+          <a:noFill/>
+          <a:ln/>
+        </p:spPr>
+        <p:txBody>
+          <a:bodyPr wrap="square" lIns="0" tIns="0" rIns="0" bIns="0" rtlCol="0" anchor="t"/>
+          <a:lstStyle/>
+          <a:p>
+            <a:pPr indent="0" marL="0">
+              <a:buNone/>
+            </a:pPr>
+            <a:r>
+              <a:rPr lang="en-US" sz="1100" dirty="0">
+                <a:solidFill>
+                  <a:srgbClr val="6B5B55"/>
+                </a:solidFill>
+                <a:latin typeface="Calibri" pitchFamily="34" charset="0"/>
+                <a:ea typeface="Calibri" pitchFamily="34" charset="-122"/>
+                <a:cs typeface="Calibri" pitchFamily="34" charset="-120"/>
+              </a:rPr>
+              <a:t>Último caso manual e a pasta de testes no repositório</a:t>
+            </a:r>
+            <a:endParaRPr lang="en-US" sz="1100" dirty="0"/>
+          </a:p>
+        </p:txBody>
+      </p:sp>
+      <p:pic>
+        <p:nvPicPr>
+          <p:cNvPr id="5" name="Image 0" descr="C:\Users\felip\source\repos\trabalho-qualidade-e-teste-de-software\docs\entrega-1\apresentacao\anexos\caso-05.png">    </p:cNvPr>
+          <p:cNvPicPr>
+            <a:picLocks noChangeAspect="1"/>
+          </p:cNvPicPr>
+          <p:nvPr/>
+        </p:nvPicPr>
+        <p:blipFill>
+          <a:blip r:embed="rId1"/>
+          <a:stretch>
+            <a:fillRect/>
+          </a:stretch>
+        </p:blipFill>
+        <p:spPr>
+          <a:xfrm>
+            <a:off x="457200" y="1207008"/>
+            <a:ext cx="4069080" cy="2101064"/>
+          </a:xfrm>
+          <a:prstGeom prst="rect">
+            <a:avLst/>
+          </a:prstGeom>
+        </p:spPr>
+      </p:pic>
+      <p:pic>
+        <p:nvPicPr>
+          <p:cNvPr id="6" name="Image 1" descr="C:\Users\felip\source\repos\trabalho-qualidade-e-teste-de-software\docs\entrega-1\apresentacao\anexos\github-pasta-testes.png">    </p:cNvPr>
+          <p:cNvPicPr>
+            <a:picLocks noChangeAspect="1"/>
+          </p:cNvPicPr>
+          <p:nvPr/>
+        </p:nvPicPr>
+        <p:blipFill>
+          <a:blip r:embed="rId2"/>
+          <a:stretch>
+            <a:fillRect/>
+          </a:stretch>
+        </p:blipFill>
+        <p:spPr>
+          <a:xfrm>
+            <a:off x="4617720" y="1207008"/>
+            <a:ext cx="4069080" cy="2978567"/>
+          </a:xfrm>
+          <a:prstGeom prst="rect">
+            <a:avLst/>
+          </a:prstGeom>
+        </p:spPr>
+      </p:pic>
+      <p:sp>
+        <p:nvSpPr>
+          <p:cNvPr id="7" name="Text 3"/>
+          <p:cNvSpPr txBox="1"/>
+          <p:nvPr/>
+        </p:nvSpPr>
+        <p:spPr>
+          <a:xfrm>
+            <a:off x="457200" y="3383280"/>
+            <a:ext cx="4069080" cy="457200"/>
+          </a:xfrm>
+          <a:prstGeom prst="rect">
+            <a:avLst/>
+          </a:prstGeom>
+          <a:noFill/>
+          <a:ln/>
+        </p:spPr>
+        <p:txBody>
+          <a:bodyPr wrap="square" lIns="0" tIns="0" rIns="0" bIns="0" rtlCol="0" anchor="t"/>
+          <a:lstStyle/>
+          <a:p>
+            <a:pPr indent="0" marL="0">
+              <a:buNone/>
+            </a:pPr>
+            <a:r>
+              <a:rPr lang="en-US" sz="1050" dirty="0">
+                <a:solidFill>
+                  <a:srgbClr val="6B5B55"/>
+                </a:solidFill>
+                <a:latin typeface="Calibri" pitchFamily="34" charset="0"/>
+                <a:ea typeface="Calibri" pitchFamily="34" charset="-122"/>
+                <a:cs typeface="Calibri" pitchFamily="34" charset="-120"/>
+              </a:rPr>
+              <a:t>CT-05 — Gestão de insumos e estoque, executado por Felipe Paixão</a:t>
+            </a:r>
+            <a:endParaRPr lang="en-US" sz="1050" dirty="0"/>
+          </a:p>
+        </p:txBody>
+      </p:sp>
+      <p:sp>
+        <p:nvSpPr>
+          <p:cNvPr id="8" name="Text 4"/>
+          <p:cNvSpPr txBox="1"/>
+          <p:nvPr/>
+        </p:nvSpPr>
+        <p:spPr>
+          <a:xfrm>
+            <a:off x="4617720" y="4224528"/>
+            <a:ext cx="4069080" cy="457200"/>
+          </a:xfrm>
+          <a:prstGeom prst="rect">
+            <a:avLst/>
+          </a:prstGeom>
+          <a:noFill/>
+          <a:ln/>
+        </p:spPr>
+        <p:txBody>
+          <a:bodyPr wrap="square" lIns="0" tIns="0" rIns="0" bIns="0" rtlCol="0" anchor="t"/>
+          <a:lstStyle/>
+          <a:p>
+            <a:pPr indent="0" marL="0">
+              <a:buNone/>
+            </a:pPr>
+            <a:r>
+              <a:rPr lang="en-US" sz="1050" dirty="0">
+                <a:solidFill>
+                  <a:srgbClr val="6B5B55"/>
+                </a:solidFill>
+                <a:latin typeface="Calibri" pitchFamily="34" charset="0"/>
+                <a:ea typeface="Calibri" pitchFamily="34" charset="-122"/>
+                <a:cs typeface="Calibri" pitchFamily="34" charset="-120"/>
+              </a:rPr>
+              <a:t>src/test/java: as classes de teste, uma pasta por camada</a:t>
+            </a:r>
+            <a:endParaRPr lang="en-US" sz="1050" dirty="0"/>
+          </a:p>
+        </p:txBody>
+      </p:sp>
+    </p:spTree>
+  </p:cSld>
+  <p:clrMapOvr>
+    <a:masterClrMapping/>
+  </p:clrMapOvr>
+</p:sld>
+</file>
+
+<file path=ppt/slides/slide17.xml><?xml version="1.0" encoding="utf-8"?>
+<p:sld xmlns:a="http://schemas.openxmlformats.org/drawingml/2006/main" xmlns:r="http://schemas.openxmlformats.org/officeDocument/2006/relationships" xmlns:p="http://schemas.openxmlformats.org/presentationml/2006/main">
+  <p:cSld name="Slide 17">
+    <p:bg>
+      <p:bgPr>
+        <a:solidFill>
+          <a:srgbClr val="FFFFFF"/>
+        </a:solidFill>
+      </p:bgPr>
+    </p:bg>
+    <p:spTree>
+      <p:nvGrpSpPr>
+        <p:cNvPr id="1" name=""/>
+        <p:cNvGrpSpPr/>
+        <p:nvPr/>
+      </p:nvGrpSpPr>
+      <p:grpSpPr>
+        <a:xfrm>
+          <a:off x="0" y="0"/>
+          <a:ext cx="0" cy="0"/>
+          <a:chOff x="0" y="0"/>
+          <a:chExt cx="0" cy="0"/>
+        </a:xfrm>
+      </p:grpSpPr>
+      <p:sp>
+        <p:nvSpPr>
+          <p:cNvPr id="2" name="Text 0"/>
+          <p:cNvSpPr txBox="1"/>
+          <p:nvPr/>
+        </p:nvSpPr>
+        <p:spPr>
+          <a:xfrm>
+            <a:off x="457200" y="292608"/>
+            <a:ext cx="2743200" cy="219456"/>
+          </a:xfrm>
+          <a:prstGeom prst="rect">
+            <a:avLst/>
+          </a:prstGeom>
+          <a:noFill/>
+          <a:ln/>
+        </p:spPr>
+        <p:txBody>
+          <a:bodyPr wrap="square" lIns="0" tIns="0" rIns="0" bIns="0" rtlCol="0" anchor="t"/>
+          <a:lstStyle/>
+          <a:p>
+            <a:pPr indent="0" marL="0">
+              <a:buNone/>
+            </a:pPr>
+            <a:r>
+              <a:rPr lang="en-US" sz="1000" b="1" spc="200" kern="0" dirty="0">
+                <a:solidFill>
+                  <a:srgbClr val="C8352B"/>
+                </a:solidFill>
+                <a:latin typeface="Calibri" pitchFamily="34" charset="0"/>
+                <a:ea typeface="Calibri" pitchFamily="34" charset="-122"/>
+                <a:cs typeface="Calibri" pitchFamily="34" charset="-120"/>
+              </a:rPr>
+              <a:t>ANEXO</a:t>
+            </a:r>
+            <a:endParaRPr lang="en-US" sz="1000" dirty="0"/>
+          </a:p>
+        </p:txBody>
+      </p:sp>
+      <p:sp>
+        <p:nvSpPr>
+          <p:cNvPr id="3" name="Text 1"/>
+          <p:cNvSpPr txBox="1"/>
+          <p:nvPr/>
+        </p:nvSpPr>
+        <p:spPr>
+          <a:xfrm>
+            <a:off x="457200" y="512064"/>
+            <a:ext cx="8229600" cy="411480"/>
+          </a:xfrm>
+          <a:prstGeom prst="rect">
+            <a:avLst/>
+          </a:prstGeom>
+          <a:noFill/>
+          <a:ln/>
+        </p:spPr>
+        <p:txBody>
+          <a:bodyPr wrap="square" lIns="0" tIns="0" rIns="0" bIns="0" rtlCol="0" anchor="t"/>
+          <a:lstStyle/>
+          <a:p>
+            <a:pPr indent="0" marL="0">
+              <a:buNone/>
+            </a:pPr>
+            <a:r>
+              <a:rPr lang="en-US" sz="2300" b="1" dirty="0">
+                <a:solidFill>
+                  <a:srgbClr val="2B1B17"/>
+                </a:solidFill>
+                <a:latin typeface="Cambria" pitchFamily="34" charset="0"/>
+                <a:ea typeface="Cambria" pitchFamily="34" charset="-122"/>
+                <a:cs typeface="Cambria" pitchFamily="34" charset="-120"/>
+              </a:rPr>
+              <a:t>Execução das suítes</a:t>
+            </a:r>
+            <a:endParaRPr lang="en-US" sz="2300" dirty="0"/>
+          </a:p>
+        </p:txBody>
+      </p:sp>
+      <p:sp>
+        <p:nvSpPr>
+          <p:cNvPr id="4" name="Text 2"/>
+          <p:cNvSpPr txBox="1"/>
+          <p:nvPr/>
+        </p:nvSpPr>
+        <p:spPr>
+          <a:xfrm>
+            <a:off x="457200" y="914400"/>
+            <a:ext cx="8229600" cy="237744"/>
+          </a:xfrm>
+          <a:prstGeom prst="rect">
+            <a:avLst/>
+          </a:prstGeom>
+          <a:noFill/>
+          <a:ln/>
+        </p:spPr>
+        <p:txBody>
+          <a:bodyPr wrap="square" lIns="0" tIns="0" rIns="0" bIns="0" rtlCol="0" anchor="t"/>
+          <a:lstStyle/>
+          <a:p>
+            <a:pPr indent="0" marL="0">
+              <a:buNone/>
+            </a:pPr>
+            <a:r>
+              <a:rPr lang="en-US" sz="1100" dirty="0">
+                <a:solidFill>
+                  <a:srgbClr val="6B5B55"/>
+                </a:solidFill>
+                <a:latin typeface="Calibri" pitchFamily="34" charset="0"/>
+                <a:ea typeface="Calibri" pitchFamily="34" charset="-122"/>
+                <a:cs typeface="Calibri" pitchFamily="34" charset="-120"/>
+              </a:rPr>
+              <a:t>Saída real do Maven, nas duas suítes</a:t>
+            </a:r>
+            <a:endParaRPr lang="en-US" sz="1100" dirty="0"/>
+          </a:p>
+        </p:txBody>
+      </p:sp>
+      <p:pic>
+        <p:nvPicPr>
+          <p:cNvPr id="5" name="Image 0" descr="C:\Users\felip\source\repos\trabalho-qualidade-e-teste-de-software\docs\entrega-1\apresentacao\anexos\execucao-maven.png">    </p:cNvPr>
+          <p:cNvPicPr>
+            <a:picLocks noChangeAspect="1"/>
+          </p:cNvPicPr>
+          <p:nvPr/>
+        </p:nvPicPr>
+        <p:blipFill>
+          <a:blip r:embed="rId1"/>
+          <a:stretch>
+            <a:fillRect/>
+          </a:stretch>
+        </p:blipFill>
+        <p:spPr>
+          <a:xfrm>
+            <a:off x="457200" y="1234440"/>
+            <a:ext cx="8229600" cy="2495427"/>
+          </a:xfrm>
+          <a:prstGeom prst="rect">
+            <a:avLst/>
+          </a:prstGeom>
+        </p:spPr>
+      </p:pic>
+      <p:sp>
+        <p:nvSpPr>
+          <p:cNvPr id="6" name="Text 3"/>
+          <p:cNvSpPr txBox="1"/>
+          <p:nvPr/>
+        </p:nvSpPr>
+        <p:spPr>
+          <a:xfrm>
+            <a:off x="457200" y="3840480"/>
+            <a:ext cx="8229600" cy="548640"/>
+          </a:xfrm>
+          <a:prstGeom prst="rect">
+            <a:avLst/>
+          </a:prstGeom>
+          <a:noFill/>
+          <a:ln/>
+        </p:spPr>
+        <p:txBody>
+          <a:bodyPr wrap="square" lIns="0" tIns="0" rIns="0" bIns="0" rtlCol="0" anchor="t"/>
+          <a:lstStyle/>
+          <a:p>
+            <a:pPr indent="0" marL="0">
+              <a:buNone/>
+            </a:pPr>
+            <a:r>
+              <a:rPr lang="en-US" sz="1250" dirty="0">
+                <a:solidFill>
+                  <a:srgbClr val="2B1B17"/>
+                </a:solidFill>
+                <a:latin typeface="Calibri" pitchFamily="34" charset="0"/>
+                <a:ea typeface="Calibri" pitchFamily="34" charset="-122"/>
+                <a:cs typeface="Calibri" pitchFamily="34" charset="-120"/>
+              </a:rPr>
+              <a:t>A suíte padrão fica verde. A de defeitos fica vermelha de propósito: cada teste ali descreve o comportamento correto e falha enquanto o defeito existir.</a:t>
+            </a:r>
+            <a:endParaRPr lang="en-US" sz="1250" dirty="0"/>
+          </a:p>
+        </p:txBody>
+      </p:sp>
+      <p:sp>
+        <p:nvSpPr>
+          <p:cNvPr id="7" name="Text 4"/>
+          <p:cNvSpPr txBox="1"/>
+          <p:nvPr/>
+        </p:nvSpPr>
+        <p:spPr>
+          <a:xfrm>
+            <a:off x="457200" y="4526280"/>
+            <a:ext cx="8229600" cy="274320"/>
+          </a:xfrm>
+          <a:prstGeom prst="rect">
+            <a:avLst/>
+          </a:prstGeom>
+          <a:noFill/>
+          <a:ln/>
+        </p:spPr>
+        <p:txBody>
+          <a:bodyPr wrap="square" lIns="0" tIns="0" rIns="0" bIns="0" rtlCol="0" anchor="t"/>
+          <a:lstStyle/>
+          <a:p>
+            <a:pPr indent="0" marL="0">
+              <a:buNone/>
+            </a:pPr>
+            <a:r>
+              <a:rPr lang="en-US" sz="1250" b="1" dirty="0">
+                <a:solidFill>
+                  <a:srgbClr val="2B1B17"/>
+                </a:solidFill>
+                <a:latin typeface="Calibri" pitchFamily="34" charset="0"/>
+                <a:ea typeface="Calibri" pitchFamily="34" charset="-122"/>
+                <a:cs typeface="Calibri" pitchFamily="34" charset="-120"/>
+              </a:rPr>
+              <a:t>Reproduzir:  mvn clean test   ·   mvn test -Pdefeitos</a:t>
+            </a:r>
+            <a:endParaRPr lang="en-US" sz="1250" dirty="0"/>
+          </a:p>
+        </p:txBody>
+      </p:sp>
+    </p:spTree>
+  </p:cSld>
+  <p:clrMapOvr>
+    <a:masterClrMapping/>
+  </p:clrMapOvr>
+</p:sld>
+</file>
+
 <file path=ppt/slides/slide2.xml><?xml version="1.0" encoding="utf-8"?>
 <p:sld xmlns:a="http://schemas.openxmlformats.org/drawingml/2006/main" xmlns:r="http://schemas.openxmlformats.org/officeDocument/2006/relationships" xmlns:p="http://schemas.openxmlformats.org/presentationml/2006/main">
   <p:cSld name="Slide 2">

</xml_diff>

<commit_message>
docs: anexos com um slide por integrante e links clicáveis
- link do repositório visível na abertura, no encerramento e nos anexos
- toda referência #NN vira link para a issue correspondente (56 links no deck)
- um anexo por integrante: cabeçalho do documento do caso e tela do sistema
- telas extraídas dos prints anexados aos próprios casos de teste
</commit_message>
<xml_diff>
--- a/docs/entrega-1/apresentacao/apresentacao-entrega-1.pptx
+++ b/docs/entrega-1/apresentacao/apresentacao-entrega-1.pptx
@@ -22,9 +22,12 @@
     <p:sldId id="270" r:id="rId16"/>
     <p:sldId id="271" r:id="rId17"/>
     <p:sldId id="272" r:id="rId18"/>
+    <p:sldId id="273" r:id="rId19"/>
+    <p:sldId id="274" r:id="rId20"/>
+    <p:sldId id="275" r:id="rId21"/>
   </p:sldIdLst>
   <p:notesMasterIdLst>
-    <p:notesMasterId r:id="rId19"/>
+    <p:notesMasterId r:id="rId22"/>
   </p:notesMasterIdLst>
   <p:sldSz cx="9144000" cy="5143500"/>
   <p:notesSz cx="5143500" cy="9144000"/>
@@ -1120,7 +1123,7 @@
           <a:p>
             <a:r>
               <a:rPr lang="en-US" dirty="0"/>
-              <a:t>Anexo. Esses são os cabeçalhos dos documentos de teste manual: CT-01 a CT-04. Cada um tem quem executou, a data e o ambiente. O formato é o mesmo modelo que o grupo já usava no CT-04.</a:t>
+              <a:t>Anexo do CT-01. À esquerda o cabeçalho do documento, com quem executou e o ambiente. À direita uma tela do sistema tirada durante a execução. Resultado: 8 passos passaram e 0 falharam.</a:t>
             </a:r>
             <a:endParaRPr lang="en-US" dirty="0"/>
           </a:p>
@@ -1208,7 +1211,7 @@
           <a:p>
             <a:r>
               <a:rPr lang="en-US" dirty="0"/>
-              <a:t>Anexo. À esquerda o CT-05, o último caso manual. À direita a pasta de testes no repositório, organizada por camada: Controllers, DAO e Helpers.</a:t>
+              <a:t>Anexo do CT-02. À esquerda o cabeçalho do documento, com quem executou e o ambiente. À direita uma tela do sistema tirada durante a execução. Resultado: 6 passos passaram e 3 falharam.</a:t>
             </a:r>
             <a:endParaRPr lang="en-US" dirty="0"/>
           </a:p>
@@ -1296,7 +1299,7 @@
           <a:p>
             <a:r>
               <a:rPr lang="en-US" dirty="0"/>
-              <a:t>Anexo. Essa é a saída real do Maven. Em cima, a suíte padrão: 115 testes, zero falhas. Embaixo, o perfil de defeitos, com os cinco testes vermelhos e o nome de cada um. Dá pra rodar os dois comandos na hora, se quiserem ver.</a:t>
+              <a:t>Anexo do CT-03. À esquerda o cabeçalho do documento, com quem executou e o ambiente. À direita uma tela do sistema tirada durante a execução. Resultado: 2 passos passaram e 5 falharam.</a:t>
             </a:r>
             <a:endParaRPr lang="en-US" dirty="0"/>
           </a:p>
@@ -1320,6 +1323,182 @@
             <a:fld id="{F7021451-1387-4CA6-816F-3879F97B5CBC}" type="slidenum">
               <a:rPr lang="en-US"/>
               <a:t>17</a:t>
+            </a:fld>
+            <a:endParaRPr lang="en-US"/>
+          </a:p>
+        </p:txBody>
+      </p:sp>
+    </p:spTree>
+    <p:extLst>
+      <p:ext uri="{BB962C8B-B14F-4D97-AF65-F5344CB8AC3E}">
+        <p14:creationId xmlns:p14="http://schemas.microsoft.com/office/powerpoint/2010/main" val="1024086991"/>
+      </p:ext>
+    </p:extLst>
+  </p:cSld>
+  <p:clrMapOvr>
+    <a:masterClrMapping/>
+  </p:clrMapOvr>
+</p:notes>
+</file>
+
+<file path=ppt/notesSlides/notesSlide18.xml><?xml version="1.0" encoding="utf-8"?>
+<p:notes xmlns:a="http://schemas.openxmlformats.org/drawingml/2006/main" xmlns:r="http://schemas.openxmlformats.org/officeDocument/2006/relationships" xmlns:p="http://schemas.openxmlformats.org/presentationml/2006/main">
+  <p:cSld>
+    <p:spTree>
+      <p:nvGrpSpPr>
+        <p:cNvPr id="1" name=""/>
+        <p:cNvGrpSpPr/>
+        <p:nvPr/>
+      </p:nvGrpSpPr>
+      <p:grpSpPr>
+        <a:xfrm>
+          <a:off x="0" y="0"/>
+          <a:ext cx="0" cy="0"/>
+          <a:chOff x="0" y="0"/>
+          <a:chExt cx="0" cy="0"/>
+        </a:xfrm>
+      </p:grpSpPr>
+      <p:sp>
+        <p:nvSpPr>
+          <p:cNvPr id="2" name="Slide Image Placeholder 1"/>
+          <p:cNvSpPr>
+            <a:spLocks noGrp="1" noRot="1" noChangeAspect="1"/>
+          </p:cNvSpPr>
+          <p:nvPr>
+            <p:ph type="sldImg"/>
+          </p:nvPr>
+        </p:nvSpPr>
+        <p:spPr/>
+      </p:sp>
+      <p:sp>
+        <p:nvSpPr>
+          <p:cNvPr id="3" name="Notes Placeholder 2"/>
+          <p:cNvSpPr>
+            <a:spLocks noGrp="1"/>
+          </p:cNvSpPr>
+          <p:nvPr>
+            <p:ph type="body" idx="1"/>
+          </p:nvPr>
+        </p:nvSpPr>
+        <p:spPr/>
+        <p:txBody>
+          <a:bodyPr/>
+          <a:lstStyle/>
+          <a:p>
+            <a:r>
+              <a:rPr lang="en-US" dirty="0"/>
+              <a:t>Anexo do CT-04. À esquerda o cabeçalho do documento, com quem executou e o ambiente. À direita uma tela do sistema tirada durante a execução. Resultado: 2 passos passaram e 2 falharam.</a:t>
+            </a:r>
+            <a:endParaRPr lang="en-US" dirty="0"/>
+          </a:p>
+        </p:txBody>
+      </p:sp>
+      <p:sp>
+        <p:nvSpPr>
+          <p:cNvPr id="4" name="Slide Number Placeholder 3"/>
+          <p:cNvSpPr>
+            <a:spLocks noGrp="1"/>
+          </p:cNvSpPr>
+          <p:nvPr>
+            <p:ph type="sldNum" sz="quarter" idx="10"/>
+          </p:nvPr>
+        </p:nvSpPr>
+        <p:spPr/>
+        <p:txBody>
+          <a:bodyPr/>
+          <a:lstStyle/>
+          <a:p>
+            <a:fld id="{F7021451-1387-4CA6-816F-3879F97B5CBC}" type="slidenum">
+              <a:rPr lang="en-US"/>
+              <a:t>18</a:t>
+            </a:fld>
+            <a:endParaRPr lang="en-US"/>
+          </a:p>
+        </p:txBody>
+      </p:sp>
+    </p:spTree>
+    <p:extLst>
+      <p:ext uri="{BB962C8B-B14F-4D97-AF65-F5344CB8AC3E}">
+        <p14:creationId xmlns:p14="http://schemas.microsoft.com/office/powerpoint/2010/main" val="1024086991"/>
+      </p:ext>
+    </p:extLst>
+  </p:cSld>
+  <p:clrMapOvr>
+    <a:masterClrMapping/>
+  </p:clrMapOvr>
+</p:notes>
+</file>
+
+<file path=ppt/notesSlides/notesSlide19.xml><?xml version="1.0" encoding="utf-8"?>
+<p:notes xmlns:a="http://schemas.openxmlformats.org/drawingml/2006/main" xmlns:r="http://schemas.openxmlformats.org/officeDocument/2006/relationships" xmlns:p="http://schemas.openxmlformats.org/presentationml/2006/main">
+  <p:cSld>
+    <p:spTree>
+      <p:nvGrpSpPr>
+        <p:cNvPr id="1" name=""/>
+        <p:cNvGrpSpPr/>
+        <p:nvPr/>
+      </p:nvGrpSpPr>
+      <p:grpSpPr>
+        <a:xfrm>
+          <a:off x="0" y="0"/>
+          <a:ext cx="0" cy="0"/>
+          <a:chOff x="0" y="0"/>
+          <a:chExt cx="0" cy="0"/>
+        </a:xfrm>
+      </p:grpSpPr>
+      <p:sp>
+        <p:nvSpPr>
+          <p:cNvPr id="2" name="Slide Image Placeholder 1"/>
+          <p:cNvSpPr>
+            <a:spLocks noGrp="1" noRot="1" noChangeAspect="1"/>
+          </p:cNvSpPr>
+          <p:nvPr>
+            <p:ph type="sldImg"/>
+          </p:nvPr>
+        </p:nvSpPr>
+        <p:spPr/>
+      </p:sp>
+      <p:sp>
+        <p:nvSpPr>
+          <p:cNvPr id="3" name="Notes Placeholder 2"/>
+          <p:cNvSpPr>
+            <a:spLocks noGrp="1"/>
+          </p:cNvSpPr>
+          <p:nvPr>
+            <p:ph type="body" idx="1"/>
+          </p:nvPr>
+        </p:nvSpPr>
+        <p:spPr/>
+        <p:txBody>
+          <a:bodyPr/>
+          <a:lstStyle/>
+          <a:p>
+            <a:r>
+              <a:rPr lang="en-US" dirty="0"/>
+              <a:t>Anexo do CT-05. À esquerda o cabeçalho do documento, com quem executou e o ambiente. À direita uma tela do sistema tirada durante a execução. Resultado: 5 passos passaram e 3 falharam.</a:t>
+            </a:r>
+            <a:endParaRPr lang="en-US" dirty="0"/>
+          </a:p>
+        </p:txBody>
+      </p:sp>
+      <p:sp>
+        <p:nvSpPr>
+          <p:cNvPr id="4" name="Slide Number Placeholder 3"/>
+          <p:cNvSpPr>
+            <a:spLocks noGrp="1"/>
+          </p:cNvSpPr>
+          <p:nvPr>
+            <p:ph type="sldNum" sz="quarter" idx="10"/>
+          </p:nvPr>
+        </p:nvSpPr>
+        <p:spPr/>
+        <p:txBody>
+          <a:bodyPr/>
+          <a:lstStyle/>
+          <a:p>
+            <a:fld id="{F7021451-1387-4CA6-816F-3879F97B5CBC}" type="slidenum">
+              <a:rPr lang="en-US"/>
+              <a:t>19</a:t>
             </a:fld>
             <a:endParaRPr lang="en-US"/>
           </a:p>
@@ -1426,6 +1605,94 @@
             <a:fld id="{F7021451-1387-4CA6-816F-3879F97B5CBC}" type="slidenum">
               <a:rPr lang="en-US"/>
               <a:t>2</a:t>
+            </a:fld>
+            <a:endParaRPr lang="en-US"/>
+          </a:p>
+        </p:txBody>
+      </p:sp>
+    </p:spTree>
+    <p:extLst>
+      <p:ext uri="{BB962C8B-B14F-4D97-AF65-F5344CB8AC3E}">
+        <p14:creationId xmlns:p14="http://schemas.microsoft.com/office/powerpoint/2010/main" val="1024086991"/>
+      </p:ext>
+    </p:extLst>
+  </p:cSld>
+  <p:clrMapOvr>
+    <a:masterClrMapping/>
+  </p:clrMapOvr>
+</p:notes>
+</file>
+
+<file path=ppt/notesSlides/notesSlide20.xml><?xml version="1.0" encoding="utf-8"?>
+<p:notes xmlns:a="http://schemas.openxmlformats.org/drawingml/2006/main" xmlns:r="http://schemas.openxmlformats.org/officeDocument/2006/relationships" xmlns:p="http://schemas.openxmlformats.org/presentationml/2006/main">
+  <p:cSld>
+    <p:spTree>
+      <p:nvGrpSpPr>
+        <p:cNvPr id="1" name=""/>
+        <p:cNvGrpSpPr/>
+        <p:nvPr/>
+      </p:nvGrpSpPr>
+      <p:grpSpPr>
+        <a:xfrm>
+          <a:off x="0" y="0"/>
+          <a:ext cx="0" cy="0"/>
+          <a:chOff x="0" y="0"/>
+          <a:chExt cx="0" cy="0"/>
+        </a:xfrm>
+      </p:grpSpPr>
+      <p:sp>
+        <p:nvSpPr>
+          <p:cNvPr id="2" name="Slide Image Placeholder 1"/>
+          <p:cNvSpPr>
+            <a:spLocks noGrp="1" noRot="1" noChangeAspect="1"/>
+          </p:cNvSpPr>
+          <p:nvPr>
+            <p:ph type="sldImg"/>
+          </p:nvPr>
+        </p:nvSpPr>
+        <p:spPr/>
+      </p:sp>
+      <p:sp>
+        <p:nvSpPr>
+          <p:cNvPr id="3" name="Notes Placeholder 2"/>
+          <p:cNvSpPr>
+            <a:spLocks noGrp="1"/>
+          </p:cNvSpPr>
+          <p:nvPr>
+            <p:ph type="body" idx="1"/>
+          </p:nvPr>
+        </p:nvSpPr>
+        <p:spPr/>
+        <p:txBody>
+          <a:bodyPr/>
+          <a:lstStyle/>
+          <a:p>
+            <a:r>
+              <a:rPr lang="en-US" dirty="0"/>
+              <a:t>Anexo. Essa é a saída real do Maven. Em cima, a suíte padrão: 115 testes, zero falhas. Embaixo, o perfil de defeitos, com os cinco testes vermelhos e o nome de cada um. Dá pra rodar os dois comandos na hora, se quiserem ver.</a:t>
+            </a:r>
+            <a:endParaRPr lang="en-US" dirty="0"/>
+          </a:p>
+        </p:txBody>
+      </p:sp>
+      <p:sp>
+        <p:nvSpPr>
+          <p:cNvPr id="4" name="Slide Number Placeholder 3"/>
+          <p:cNvSpPr>
+            <a:spLocks noGrp="1"/>
+          </p:cNvSpPr>
+          <p:nvPr>
+            <p:ph type="sldNum" sz="quarter" idx="10"/>
+          </p:nvPr>
+        </p:nvSpPr>
+        <p:spPr/>
+        <p:txBody>
+          <a:bodyPr/>
+          <a:lstStyle/>
+          <a:p>
+            <a:fld id="{F7021451-1387-4CA6-816F-3879F97B5CBC}" type="slidenum">
+              <a:rPr lang="en-US"/>
+              <a:t>20</a:t>
             </a:fld>
             <a:endParaRPr lang="en-US"/>
           </a:p>
@@ -2693,7 +2960,92 @@
         </p:nvSpPr>
         <p:spPr>
           <a:xfrm>
-            <a:off x="548640" y="3931920"/>
+            <a:off x="548640" y="3154680"/>
+            <a:ext cx="5669280" cy="219456"/>
+          </a:xfrm>
+          <a:prstGeom prst="rect">
+            <a:avLst/>
+          </a:prstGeom>
+          <a:noFill/>
+          <a:ln/>
+        </p:spPr>
+        <p:txBody>
+          <a:bodyPr wrap="square" lIns="0" tIns="0" rIns="0" bIns="0" rtlCol="0" anchor="t"/>
+          <a:lstStyle/>
+          <a:p>
+            <a:pPr indent="0" marL="0">
+              <a:buNone/>
+            </a:pPr>
+            <a:r>
+              <a:rPr lang="en-US" sz="1000" spc="200" kern="0" dirty="0">
+                <a:solidFill>
+                  <a:srgbClr val="F2A900"/>
+                </a:solidFill>
+                <a:latin typeface="Calibri" pitchFamily="34" charset="0"/>
+                <a:ea typeface="Calibri" pitchFamily="34" charset="-122"/>
+                <a:cs typeface="Calibri" pitchFamily="34" charset="-120"/>
+              </a:rPr>
+              <a:t>CÓDIGO, TESTES E DOCUMENTAÇÃO</a:t>
+            </a:r>
+            <a:endParaRPr lang="en-US" sz="1000" dirty="0"/>
+          </a:p>
+        </p:txBody>
+      </p:sp>
+      <p:sp>
+        <p:nvSpPr>
+          <p:cNvPr id="8" name="Text 6"/>
+          <p:cNvSpPr txBox="1"/>
+          <p:nvPr/>
+        </p:nvSpPr>
+        <p:spPr>
+          <a:xfrm>
+            <a:off x="548640" y="3401568"/>
+            <a:ext cx="6035040" cy="475488"/>
+          </a:xfrm>
+          <a:prstGeom prst="rect">
+            <a:avLst/>
+          </a:prstGeom>
+          <a:noFill/>
+          <a:ln/>
+        </p:spPr>
+        <p:txBody>
+          <a:bodyPr wrap="square" lIns="0" tIns="0" rIns="0" bIns="0" rtlCol="0" anchor="t"/>
+          <a:lstStyle/>
+          <a:p>
+            <a:pPr indent="0" marL="0">
+              <a:buNone/>
+            </a:pPr>
+            <a:r>
+              <a:rPr lang="en-US" sz="1450" b="1" u="sng" dirty="0">
+                <a:solidFill>
+                  <a:srgbClr val="FFFFFF"/>
+                </a:solidFill>
+                <a:latin typeface="Calibri" pitchFamily="34" charset="0"/>
+                <a:ea typeface="Calibri" pitchFamily="34" charset="-122"/>
+                <a:cs typeface="Calibri" pitchFamily="34" charset="-120"/>
+                <a:hlinkClick r:id="rId1" invalidUrl="" action="" tgtFrame="" tooltip="Repositório do trabalho" history="1" highlightClick="0" endSnd="0">
+                  <a:extLst>
+                    <a:ext uri="{A12FA001-AC4F-418D-AE19-62706E023703}">
+                      <ahyp:hlinkClr xmlns:ahyp="http://schemas.microsoft.com/office/drawing/2018/hyperlinkcolor" val="tx"/>
+                    </a:ext>
+                  </a:extLst>
+                </a:hlinkClick>
+              </a:rPr>
+              <a:t>github.com/vini-pinheiro/trabalho-qualidade-e-teste-de-software</a:t>
+            </a:r>
+            <a:endParaRPr lang="en-US" sz="1450" dirty="0"/>
+          </a:p>
+        </p:txBody>
+      </p:sp>
+      <p:sp>
+        <p:nvSpPr>
+          <p:cNvPr id="9" name="Text 7"/>
+          <p:cNvSpPr txBox="1"/>
+          <p:nvPr/>
+        </p:nvSpPr>
+        <p:spPr>
+          <a:xfrm>
+            <a:off x="548640" y="4114800"/>
             <a:ext cx="5669280" cy="548640"/>
           </a:xfrm>
           <a:prstGeom prst="rect">
@@ -3362,7 +3714,77 @@
                 <a:ea typeface="Calibri" pitchFamily="34" charset="-122"/>
                 <a:cs typeface="Calibri" pitchFamily="34" charset="-120"/>
               </a:rPr>
-              <a:t>DaoIngredienteTest · IngredienteControllersTest · issues #5 e #10 · DEF-07</a:t>
+              <a:t>DaoIngredienteTest · IngredienteControllersTest · issues </a:t>
+            </a:r>
+            <a:pPr indent="0" marL="0">
+              <a:buNone/>
+            </a:pPr>
+            <a:r>
+              <a:rPr lang="en-US" sz="850" u="sng" dirty="0">
+                <a:solidFill>
+                  <a:srgbClr val="C8352B"/>
+                </a:solidFill>
+                <a:latin typeface="Calibri" pitchFamily="34" charset="0"/>
+                <a:ea typeface="Calibri" pitchFamily="34" charset="-122"/>
+                <a:cs typeface="Calibri" pitchFamily="34" charset="-120"/>
+                <a:hlinkClick r:id="rId1" invalidUrl="" action="" tgtFrame="" tooltip="Issue #5" history="1" highlightClick="0" endSnd="0">
+                  <a:extLst>
+                    <a:ext uri="{A12FA001-AC4F-418D-AE19-62706E023703}">
+                      <ahyp:hlinkClr xmlns:ahyp="http://schemas.microsoft.com/office/drawing/2018/hyperlinkcolor" val="tx"/>
+                    </a:ext>
+                  </a:extLst>
+                </a:hlinkClick>
+              </a:rPr>
+              <a:t>#5</a:t>
+            </a:r>
+            <a:pPr indent="0" marL="0">
+              <a:buNone/>
+            </a:pPr>
+            <a:r>
+              <a:rPr lang="en-US" sz="850" dirty="0">
+                <a:solidFill>
+                  <a:srgbClr val="6B5B55"/>
+                </a:solidFill>
+                <a:latin typeface="Calibri" pitchFamily="34" charset="0"/>
+                <a:ea typeface="Calibri" pitchFamily="34" charset="-122"/>
+                <a:cs typeface="Calibri" pitchFamily="34" charset="-120"/>
+              </a:rPr>
+              <a:t> e </a:t>
+            </a:r>
+            <a:pPr indent="0" marL="0">
+              <a:buNone/>
+            </a:pPr>
+            <a:r>
+              <a:rPr lang="en-US" sz="850" u="sng" dirty="0">
+                <a:solidFill>
+                  <a:srgbClr val="C8352B"/>
+                </a:solidFill>
+                <a:latin typeface="Calibri" pitchFamily="34" charset="0"/>
+                <a:ea typeface="Calibri" pitchFamily="34" charset="-122"/>
+                <a:cs typeface="Calibri" pitchFamily="34" charset="-120"/>
+                <a:hlinkClick r:id="rId2" invalidUrl="" action="" tgtFrame="" tooltip="Issue #10" history="1" highlightClick="0" endSnd="0">
+                  <a:extLst>
+                    <a:ext uri="{A12FA001-AC4F-418D-AE19-62706E023703}">
+                      <ahyp:hlinkClr xmlns:ahyp="http://schemas.microsoft.com/office/drawing/2018/hyperlinkcolor" val="tx"/>
+                    </a:ext>
+                  </a:extLst>
+                </a:hlinkClick>
+              </a:rPr>
+              <a:t>#10</a:t>
+            </a:r>
+            <a:pPr indent="0" marL="0">
+              <a:buNone/>
+            </a:pPr>
+            <a:r>
+              <a:rPr lang="en-US" sz="850" dirty="0">
+                <a:solidFill>
+                  <a:srgbClr val="6B5B55"/>
+                </a:solidFill>
+                <a:latin typeface="Calibri" pitchFamily="34" charset="0"/>
+                <a:ea typeface="Calibri" pitchFamily="34" charset="-122"/>
+                <a:cs typeface="Calibri" pitchFamily="34" charset="-120"/>
+              </a:rPr>
+              <a:t> · DEF-07</a:t>
             </a:r>
             <a:endParaRPr lang="en-US" sz="850" dirty="0"/>
           </a:p>
@@ -4014,7 +4436,42 @@
                 <a:ea typeface="Calibri" pitchFamily="34" charset="-122"/>
                 <a:cs typeface="Calibri" pitchFamily="34" charset="-120"/>
               </a:rPr>
-              <a:t>ISSUE #25 · DEF-07</a:t>
+              <a:t>ISSUE </a:t>
+            </a:r>
+            <a:pPr indent="0" marL="0">
+              <a:buNone/>
+            </a:pPr>
+            <a:r>
+              <a:rPr lang="en-US" sz="950" b="1" u="sng" spc="100" kern="0" dirty="0">
+                <a:solidFill>
+                  <a:srgbClr val="F2A900"/>
+                </a:solidFill>
+                <a:latin typeface="Calibri" pitchFamily="34" charset="0"/>
+                <a:ea typeface="Calibri" pitchFamily="34" charset="-122"/>
+                <a:cs typeface="Calibri" pitchFamily="34" charset="-120"/>
+                <a:hlinkClick r:id="rId1" invalidUrl="" action="" tgtFrame="" tooltip="Issue #25" history="1" highlightClick="0" endSnd="0">
+                  <a:extLst>
+                    <a:ext uri="{A12FA001-AC4F-418D-AE19-62706E023703}">
+                      <ahyp:hlinkClr xmlns:ahyp="http://schemas.microsoft.com/office/drawing/2018/hyperlinkcolor" val="tx"/>
+                    </a:ext>
+                  </a:extLst>
+                </a:hlinkClick>
+              </a:rPr>
+              <a:t>#25</a:t>
+            </a:r>
+            <a:pPr indent="0" marL="0">
+              <a:buNone/>
+            </a:pPr>
+            <a:r>
+              <a:rPr lang="en-US" sz="950" b="1" spc="100" kern="0" dirty="0">
+                <a:solidFill>
+                  <a:srgbClr val="F2A900"/>
+                </a:solidFill>
+                <a:latin typeface="Calibri" pitchFamily="34" charset="0"/>
+                <a:ea typeface="Calibri" pitchFamily="34" charset="-122"/>
+                <a:cs typeface="Calibri" pitchFamily="34" charset="-120"/>
+              </a:rPr>
+              <a:t> · DEF-07</a:t>
             </a:r>
             <a:endParaRPr lang="en-US" sz="950" dirty="0"/>
           </a:p>
@@ -4131,7 +4588,77 @@
                 <a:ea typeface="Calibri" pitchFamily="34" charset="-122"/>
                 <a:cs typeface="Calibri" pitchFamily="34" charset="-120"/>
               </a:rPr>
-              <a:t>Sem testes de integração nesta entrega  ·  DaoIngredienteTest · IngredienteControllersTest · issues #5 e #10 · DEF-07</a:t>
+              <a:t>Sem testes de integração nesta entrega  ·  DaoIngredienteTest · IngredienteControllersTest · issues </a:t>
+            </a:r>
+            <a:pPr indent="0" marL="0">
+              <a:buNone/>
+            </a:pPr>
+            <a:r>
+              <a:rPr lang="en-US" sz="850" u="sng" dirty="0">
+                <a:solidFill>
+                  <a:srgbClr val="C8352B"/>
+                </a:solidFill>
+                <a:latin typeface="Calibri" pitchFamily="34" charset="0"/>
+                <a:ea typeface="Calibri" pitchFamily="34" charset="-122"/>
+                <a:cs typeface="Calibri" pitchFamily="34" charset="-120"/>
+                <a:hlinkClick r:id="rId2" invalidUrl="" action="" tgtFrame="" tooltip="Issue #5" history="1" highlightClick="0" endSnd="0">
+                  <a:extLst>
+                    <a:ext uri="{A12FA001-AC4F-418D-AE19-62706E023703}">
+                      <ahyp:hlinkClr xmlns:ahyp="http://schemas.microsoft.com/office/drawing/2018/hyperlinkcolor" val="tx"/>
+                    </a:ext>
+                  </a:extLst>
+                </a:hlinkClick>
+              </a:rPr>
+              <a:t>#5</a:t>
+            </a:r>
+            <a:pPr indent="0" marL="0">
+              <a:buNone/>
+            </a:pPr>
+            <a:r>
+              <a:rPr lang="en-US" sz="850" dirty="0">
+                <a:solidFill>
+                  <a:srgbClr val="6B5B55"/>
+                </a:solidFill>
+                <a:latin typeface="Calibri" pitchFamily="34" charset="0"/>
+                <a:ea typeface="Calibri" pitchFamily="34" charset="-122"/>
+                <a:cs typeface="Calibri" pitchFamily="34" charset="-120"/>
+              </a:rPr>
+              <a:t> e </a:t>
+            </a:r>
+            <a:pPr indent="0" marL="0">
+              <a:buNone/>
+            </a:pPr>
+            <a:r>
+              <a:rPr lang="en-US" sz="850" u="sng" dirty="0">
+                <a:solidFill>
+                  <a:srgbClr val="C8352B"/>
+                </a:solidFill>
+                <a:latin typeface="Calibri" pitchFamily="34" charset="0"/>
+                <a:ea typeface="Calibri" pitchFamily="34" charset="-122"/>
+                <a:cs typeface="Calibri" pitchFamily="34" charset="-120"/>
+                <a:hlinkClick r:id="rId3" invalidUrl="" action="" tgtFrame="" tooltip="Issue #10" history="1" highlightClick="0" endSnd="0">
+                  <a:extLst>
+                    <a:ext uri="{A12FA001-AC4F-418D-AE19-62706E023703}">
+                      <ahyp:hlinkClr xmlns:ahyp="http://schemas.microsoft.com/office/drawing/2018/hyperlinkcolor" val="tx"/>
+                    </a:ext>
+                  </a:extLst>
+                </a:hlinkClick>
+              </a:rPr>
+              <a:t>#10</a:t>
+            </a:r>
+            <a:pPr indent="0" marL="0">
+              <a:buNone/>
+            </a:pPr>
+            <a:r>
+              <a:rPr lang="en-US" sz="850" dirty="0">
+                <a:solidFill>
+                  <a:srgbClr val="6B5B55"/>
+                </a:solidFill>
+                <a:latin typeface="Calibri" pitchFamily="34" charset="0"/>
+                <a:ea typeface="Calibri" pitchFamily="34" charset="-122"/>
+                <a:cs typeface="Calibri" pitchFamily="34" charset="-120"/>
+              </a:rPr>
+              <a:t> · DEF-07</a:t>
             </a:r>
             <a:endParaRPr lang="en-US" sz="850" dirty="0"/>
           </a:p>
@@ -4646,7 +5173,53 @@
         </p:nvSpPr>
         <p:spPr>
           <a:xfrm>
-            <a:off x="548640" y="4709160"/>
+            <a:off x="548640" y="4507992"/>
+            <a:ext cx="8046720" cy="274320"/>
+          </a:xfrm>
+          <a:prstGeom prst="rect">
+            <a:avLst/>
+          </a:prstGeom>
+          <a:noFill/>
+          <a:ln/>
+        </p:spPr>
+        <p:txBody>
+          <a:bodyPr wrap="square" lIns="0" tIns="0" rIns="0" bIns="0" rtlCol="0" anchor="t"/>
+          <a:lstStyle/>
+          <a:p>
+            <a:pPr indent="0" marL="0">
+              <a:buNone/>
+            </a:pPr>
+            <a:r>
+              <a:rPr lang="en-US" sz="1300" b="1" u="sng" dirty="0">
+                <a:solidFill>
+                  <a:srgbClr val="F2A900"/>
+                </a:solidFill>
+                <a:latin typeface="Calibri" pitchFamily="34" charset="0"/>
+                <a:ea typeface="Calibri" pitchFamily="34" charset="-122"/>
+                <a:cs typeface="Calibri" pitchFamily="34" charset="-120"/>
+                <a:hlinkClick r:id="rId1" invalidUrl="" action="" tgtFrame="" tooltip="Repositório do trabalho" history="1" highlightClick="0" endSnd="0">
+                  <a:extLst>
+                    <a:ext uri="{A12FA001-AC4F-418D-AE19-62706E023703}">
+                      <ahyp:hlinkClr xmlns:ahyp="http://schemas.microsoft.com/office/drawing/2018/hyperlinkcolor" val="tx"/>
+                    </a:ext>
+                  </a:extLst>
+                </a:hlinkClick>
+              </a:rPr>
+              <a:t>github.com/vini-pinheiro/trabalho-qualidade-e-teste-de-software</a:t>
+            </a:r>
+            <a:endParaRPr lang="en-US" sz="1300" dirty="0"/>
+          </a:p>
+        </p:txBody>
+      </p:sp>
+      <p:sp>
+        <p:nvSpPr>
+          <p:cNvPr id="12" name="Text 10"/>
+          <p:cNvSpPr txBox="1"/>
+          <p:nvPr/>
+        </p:nvSpPr>
+        <p:spPr>
+          <a:xfrm>
+            <a:off x="548640" y="4846320"/>
             <a:ext cx="8046720" cy="228600"/>
           </a:xfrm>
           <a:prstGeom prst="rect">
@@ -4960,24 +5533,24 @@
         </p:nvSpPr>
         <p:spPr>
           <a:xfrm>
-            <a:off x="457200" y="4681728"/>
-            <a:ext cx="8229600" cy="274320"/>
-          </a:xfrm>
-          <a:prstGeom prst="rect">
-            <a:avLst/>
-          </a:prstGeom>
-          <a:noFill/>
-          <a:ln/>
-        </p:spPr>
-        <p:txBody>
-          <a:bodyPr wrap="square" lIns="0" tIns="0" rIns="0" bIns="0" rtlCol="0" anchor="t"/>
-          <a:lstStyle/>
-          <a:p>
-            <a:pPr indent="0" marL="0">
-              <a:buNone/>
-            </a:pPr>
-            <a:r>
-              <a:rPr lang="en-US" sz="1150" dirty="0">
+            <a:off x="457200" y="4617720"/>
+            <a:ext cx="8229600" cy="457200"/>
+          </a:xfrm>
+          <a:prstGeom prst="rect">
+            <a:avLst/>
+          </a:prstGeom>
+          <a:noFill/>
+          <a:ln/>
+        </p:spPr>
+        <p:txBody>
+          <a:bodyPr wrap="square" lIns="0" tIns="0" rIns="0" bIns="0" rtlCol="0" anchor="t"/>
+          <a:lstStyle/>
+          <a:p>
+            <a:pPr indent="0" marL="0">
+              <a:buNone/>
+            </a:pPr>
+            <a:r>
+              <a:rPr lang="en-US" sz="1100" dirty="0">
                 <a:solidFill>
                   <a:srgbClr val="2B1B17"/>
                 </a:solidFill>
@@ -4985,9 +5558,30 @@
                 <a:ea typeface="Calibri" pitchFamily="34" charset="-122"/>
                 <a:cs typeface="Calibri" pitchFamily="34" charset="-120"/>
               </a:rPr>
-              <a:t>Tudo o que está nestes slides sai desses arquivos: nada foi montado só para a apresentação.</a:t>
-            </a:r>
-            <a:endParaRPr lang="en-US" sz="1150" dirty="0"/>
+              <a:t>Tudo o que está nestes slides sai desses arquivos:  </a:t>
+            </a:r>
+            <a:pPr indent="0" marL="0">
+              <a:buNone/>
+            </a:pPr>
+            <a:r>
+              <a:rPr lang="en-US" sz="1100" b="1" u="sng" dirty="0">
+                <a:solidFill>
+                  <a:srgbClr val="C8352B"/>
+                </a:solidFill>
+                <a:latin typeface="Calibri" pitchFamily="34" charset="0"/>
+                <a:ea typeface="Calibri" pitchFamily="34" charset="-122"/>
+                <a:cs typeface="Calibri" pitchFamily="34" charset="-120"/>
+                <a:hlinkClick r:id="rId3" invalidUrl="" action="" tgtFrame="" tooltip="Repositório do trabalho" history="1" highlightClick="0" endSnd="0">
+                  <a:extLst>
+                    <a:ext uri="{A12FA001-AC4F-418D-AE19-62706E023703}">
+                      <ahyp:hlinkClr xmlns:ahyp="http://schemas.microsoft.com/office/drawing/2018/hyperlinkcolor" val="tx"/>
+                    </a:ext>
+                  </a:extLst>
+                </a:hlinkClick>
+              </a:rPr>
+              <a:t>github.com/vini-pinheiro/trabalho-qualidade-e-teste-de-software</a:t>
+            </a:r>
+            <a:endParaRPr lang="en-US" sz="1100" dirty="0"/>
           </a:p>
         </p:txBody>
       </p:sp>
@@ -5172,8 +5766,8 @@
         </p:nvSpPr>
         <p:spPr>
           <a:xfrm>
-            <a:off x="457200" y="1371600"/>
-            <a:ext cx="4114800" cy="2743200"/>
+            <a:off x="457200" y="1325880"/>
+            <a:ext cx="4114800" cy="2057400"/>
           </a:xfrm>
           <a:prstGeom prst="rect">
             <a:avLst/>
@@ -5299,24 +5893,568 @@
         </p:nvSpPr>
         <p:spPr>
           <a:xfrm>
-            <a:off x="457200" y="4206240"/>
-            <a:ext cx="4114800" cy="548640"/>
-          </a:xfrm>
-          <a:prstGeom prst="rect">
-            <a:avLst/>
-          </a:prstGeom>
-          <a:noFill/>
-          <a:ln/>
-        </p:spPr>
-        <p:txBody>
-          <a:bodyPr wrap="square" lIns="0" tIns="0" rIns="0" bIns="0" rtlCol="0" anchor="t"/>
-          <a:lstStyle/>
-          <a:p>
-            <a:pPr indent="0" marL="0">
-              <a:buNone/>
-            </a:pPr>
-            <a:r>
-              <a:rPr lang="en-US" sz="1100" dirty="0">
+            <a:off x="457200" y="3401568"/>
+            <a:ext cx="4114800" cy="201168"/>
+          </a:xfrm>
+          <a:prstGeom prst="rect">
+            <a:avLst/>
+          </a:prstGeom>
+          <a:noFill/>
+          <a:ln/>
+        </p:spPr>
+        <p:txBody>
+          <a:bodyPr wrap="square" lIns="0" tIns="0" rIns="0" bIns="0" rtlCol="0" anchor="t"/>
+          <a:lstStyle/>
+          <a:p>
+            <a:pPr indent="0" marL="0">
+              <a:buNone/>
+            </a:pPr>
+            <a:r>
+              <a:rPr lang="en-US" sz="1000" b="1" spc="100" kern="0" dirty="0">
+                <a:solidFill>
+                  <a:srgbClr val="C8352B"/>
+                </a:solidFill>
+                <a:latin typeface="Calibri" pitchFamily="34" charset="0"/>
+                <a:ea typeface="Calibri" pitchFamily="34" charset="-122"/>
+                <a:cs typeface="Calibri" pitchFamily="34" charset="-120"/>
+              </a:rPr>
+              <a:t>ABRIR NO GITHUB</a:t>
+            </a:r>
+            <a:endParaRPr lang="en-US" sz="1000" dirty="0"/>
+          </a:p>
+        </p:txBody>
+      </p:sp>
+      <p:sp>
+        <p:nvSpPr>
+          <p:cNvPr id="8" name="Text 5"/>
+          <p:cNvSpPr txBox="1"/>
+          <p:nvPr/>
+        </p:nvSpPr>
+        <p:spPr>
+          <a:xfrm>
+            <a:off x="457200" y="3602736"/>
+            <a:ext cx="4206240" cy="420624"/>
+          </a:xfrm>
+          <a:prstGeom prst="rect">
+            <a:avLst/>
+          </a:prstGeom>
+          <a:noFill/>
+          <a:ln/>
+        </p:spPr>
+        <p:txBody>
+          <a:bodyPr wrap="square" lIns="0" tIns="0" rIns="0" bIns="0" rtlCol="0" anchor="t"/>
+          <a:lstStyle/>
+          <a:p>
+            <a:pPr indent="0" marL="0">
+              <a:buNone/>
+            </a:pPr>
+            <a:r>
+              <a:rPr lang="en-US" sz="1100" b="1" u="sng" dirty="0">
+                <a:solidFill>
+                  <a:srgbClr val="2B1B17"/>
+                </a:solidFill>
+                <a:latin typeface="Calibri" pitchFamily="34" charset="0"/>
+                <a:ea typeface="Calibri" pitchFamily="34" charset="-122"/>
+                <a:cs typeface="Calibri" pitchFamily="34" charset="-120"/>
+                <a:hlinkClick r:id="rId2" invalidUrl="" action="" tgtFrame="" tooltip="Todas as issues" history="1" highlightClick="0" endSnd="0">
+                  <a:extLst>
+                    <a:ext uri="{A12FA001-AC4F-418D-AE19-62706E023703}">
+                      <ahyp:hlinkClr xmlns:ahyp="http://schemas.microsoft.com/office/drawing/2018/hyperlinkcolor" val="tx"/>
+                    </a:ext>
+                  </a:extLst>
+                </a:hlinkClick>
+              </a:rPr>
+              <a:t>github.com/vini-pinheiro/</a:t>
+            </a:r>
+            <a:endParaRPr lang="en-US" sz="1100" dirty="0"/>
+          </a:p>
+          <a:p>
+            <a:pPr indent="0" marL="0">
+              <a:buNone/>
+            </a:pPr>
+            <a:r>
+              <a:rPr lang="en-US" sz="1100" b="1" u="sng" dirty="0">
+                <a:solidFill>
+                  <a:srgbClr val="2B1B17"/>
+                </a:solidFill>
+                <a:latin typeface="Calibri" pitchFamily="34" charset="0"/>
+                <a:ea typeface="Calibri" pitchFamily="34" charset="-122"/>
+                <a:cs typeface="Calibri" pitchFamily="34" charset="-120"/>
+                <a:hlinkClick r:id="rId2" invalidUrl="" action="" tgtFrame="" tooltip="Todas as issues" history="1" highlightClick="0" endSnd="0">
+                  <a:extLst>
+                    <a:ext uri="{A12FA001-AC4F-418D-AE19-62706E023703}">
+                      <ahyp:hlinkClr xmlns:ahyp="http://schemas.microsoft.com/office/drawing/2018/hyperlinkcolor" val="tx"/>
+                    </a:ext>
+                  </a:extLst>
+                </a:hlinkClick>
+              </a:rPr>
+              <a:t>trabalho-qualidade-e-teste-de-software/issues</a:t>
+            </a:r>
+            <a:endParaRPr lang="en-US" sz="1100" dirty="0"/>
+          </a:p>
+        </p:txBody>
+      </p:sp>
+      <p:sp>
+        <p:nvSpPr>
+          <p:cNvPr id="9" name="Text 6"/>
+          <p:cNvSpPr txBox="1"/>
+          <p:nvPr/>
+        </p:nvSpPr>
+        <p:spPr>
+          <a:xfrm>
+            <a:off x="457200" y="4078224"/>
+            <a:ext cx="4206240" cy="237744"/>
+          </a:xfrm>
+          <a:prstGeom prst="rect">
+            <a:avLst/>
+          </a:prstGeom>
+          <a:noFill/>
+          <a:ln/>
+        </p:spPr>
+        <p:txBody>
+          <a:bodyPr wrap="square" lIns="0" tIns="0" rIns="0" bIns="0" rtlCol="0" anchor="t"/>
+          <a:lstStyle/>
+          <a:p>
+            <a:pPr indent="0" marL="0">
+              <a:buNone/>
+            </a:pPr>
+            <a:r>
+              <a:rPr lang="en-US" sz="1150" dirty="0">
+                <a:solidFill>
+                  <a:srgbClr val="2B1B17"/>
+                </a:solidFill>
+                <a:latin typeface="Calibri" pitchFamily="34" charset="0"/>
+                <a:ea typeface="Calibri" pitchFamily="34" charset="-122"/>
+                <a:cs typeface="Calibri" pitchFamily="34" charset="-120"/>
+              </a:rPr>
+              <a:t>Defeitos: </a:t>
+            </a:r>
+            <a:pPr indent="0" marL="0">
+              <a:buNone/>
+            </a:pPr>
+            <a:r>
+              <a:rPr lang="en-US" sz="1150" u="sng" dirty="0">
+                <a:solidFill>
+                  <a:srgbClr val="C8352B"/>
+                </a:solidFill>
+                <a:latin typeface="Calibri" pitchFamily="34" charset="0"/>
+                <a:ea typeface="Calibri" pitchFamily="34" charset="-122"/>
+                <a:cs typeface="Calibri" pitchFamily="34" charset="-120"/>
+                <a:hlinkClick r:id="rId3" invalidUrl="" action="" tgtFrame="" tooltip="Issue #20" history="1" highlightClick="0" endSnd="0">
+                  <a:extLst>
+                    <a:ext uri="{A12FA001-AC4F-418D-AE19-62706E023703}">
+                      <ahyp:hlinkClr xmlns:ahyp="http://schemas.microsoft.com/office/drawing/2018/hyperlinkcolor" val="tx"/>
+                    </a:ext>
+                  </a:extLst>
+                </a:hlinkClick>
+              </a:rPr>
+              <a:t>#20</a:t>
+            </a:r>
+            <a:pPr indent="0" marL="0">
+              <a:buNone/>
+            </a:pPr>
+            <a:r>
+              <a:rPr lang="en-US" sz="1150" dirty="0">
+                <a:solidFill>
+                  <a:srgbClr val="2B1B17"/>
+                </a:solidFill>
+                <a:latin typeface="Calibri" pitchFamily="34" charset="0"/>
+                <a:ea typeface="Calibri" pitchFamily="34" charset="-122"/>
+                <a:cs typeface="Calibri" pitchFamily="34" charset="-120"/>
+              </a:rPr>
+              <a:t> · </a:t>
+            </a:r>
+            <a:pPr indent="0" marL="0">
+              <a:buNone/>
+            </a:pPr>
+            <a:r>
+              <a:rPr lang="en-US" sz="1150" u="sng" dirty="0">
+                <a:solidFill>
+                  <a:srgbClr val="C8352B"/>
+                </a:solidFill>
+                <a:latin typeface="Calibri" pitchFamily="34" charset="0"/>
+                <a:ea typeface="Calibri" pitchFamily="34" charset="-122"/>
+                <a:cs typeface="Calibri" pitchFamily="34" charset="-120"/>
+                <a:hlinkClick r:id="rId4" invalidUrl="" action="" tgtFrame="" tooltip="Issue #21" history="1" highlightClick="0" endSnd="0">
+                  <a:extLst>
+                    <a:ext uri="{A12FA001-AC4F-418D-AE19-62706E023703}">
+                      <ahyp:hlinkClr xmlns:ahyp="http://schemas.microsoft.com/office/drawing/2018/hyperlinkcolor" val="tx"/>
+                    </a:ext>
+                  </a:extLst>
+                </a:hlinkClick>
+              </a:rPr>
+              <a:t>#21</a:t>
+            </a:r>
+            <a:pPr indent="0" marL="0">
+              <a:buNone/>
+            </a:pPr>
+            <a:r>
+              <a:rPr lang="en-US" sz="1150" dirty="0">
+                <a:solidFill>
+                  <a:srgbClr val="2B1B17"/>
+                </a:solidFill>
+                <a:latin typeface="Calibri" pitchFamily="34" charset="0"/>
+                <a:ea typeface="Calibri" pitchFamily="34" charset="-122"/>
+                <a:cs typeface="Calibri" pitchFamily="34" charset="-120"/>
+              </a:rPr>
+              <a:t> · </a:t>
+            </a:r>
+            <a:pPr indent="0" marL="0">
+              <a:buNone/>
+            </a:pPr>
+            <a:r>
+              <a:rPr lang="en-US" sz="1150" u="sng" dirty="0">
+                <a:solidFill>
+                  <a:srgbClr val="C8352B"/>
+                </a:solidFill>
+                <a:latin typeface="Calibri" pitchFamily="34" charset="0"/>
+                <a:ea typeface="Calibri" pitchFamily="34" charset="-122"/>
+                <a:cs typeface="Calibri" pitchFamily="34" charset="-120"/>
+                <a:hlinkClick r:id="rId5" invalidUrl="" action="" tgtFrame="" tooltip="Issue #22" history="1" highlightClick="0" endSnd="0">
+                  <a:extLst>
+                    <a:ext uri="{A12FA001-AC4F-418D-AE19-62706E023703}">
+                      <ahyp:hlinkClr xmlns:ahyp="http://schemas.microsoft.com/office/drawing/2018/hyperlinkcolor" val="tx"/>
+                    </a:ext>
+                  </a:extLst>
+                </a:hlinkClick>
+              </a:rPr>
+              <a:t>#22</a:t>
+            </a:r>
+            <a:pPr indent="0" marL="0">
+              <a:buNone/>
+            </a:pPr>
+            <a:r>
+              <a:rPr lang="en-US" sz="1150" dirty="0">
+                <a:solidFill>
+                  <a:srgbClr val="2B1B17"/>
+                </a:solidFill>
+                <a:latin typeface="Calibri" pitchFamily="34" charset="0"/>
+                <a:ea typeface="Calibri" pitchFamily="34" charset="-122"/>
+                <a:cs typeface="Calibri" pitchFamily="34" charset="-120"/>
+              </a:rPr>
+              <a:t> · </a:t>
+            </a:r>
+            <a:pPr indent="0" marL="0">
+              <a:buNone/>
+            </a:pPr>
+            <a:r>
+              <a:rPr lang="en-US" sz="1150" u="sng" dirty="0">
+                <a:solidFill>
+                  <a:srgbClr val="C8352B"/>
+                </a:solidFill>
+                <a:latin typeface="Calibri" pitchFamily="34" charset="0"/>
+                <a:ea typeface="Calibri" pitchFamily="34" charset="-122"/>
+                <a:cs typeface="Calibri" pitchFamily="34" charset="-120"/>
+                <a:hlinkClick r:id="rId6" invalidUrl="" action="" tgtFrame="" tooltip="Issue #23" history="1" highlightClick="0" endSnd="0">
+                  <a:extLst>
+                    <a:ext uri="{A12FA001-AC4F-418D-AE19-62706E023703}">
+                      <ahyp:hlinkClr xmlns:ahyp="http://schemas.microsoft.com/office/drawing/2018/hyperlinkcolor" val="tx"/>
+                    </a:ext>
+                  </a:extLst>
+                </a:hlinkClick>
+              </a:rPr>
+              <a:t>#23</a:t>
+            </a:r>
+            <a:pPr indent="0" marL="0">
+              <a:buNone/>
+            </a:pPr>
+            <a:r>
+              <a:rPr lang="en-US" sz="1150" dirty="0">
+                <a:solidFill>
+                  <a:srgbClr val="2B1B17"/>
+                </a:solidFill>
+                <a:latin typeface="Calibri" pitchFamily="34" charset="0"/>
+                <a:ea typeface="Calibri" pitchFamily="34" charset="-122"/>
+                <a:cs typeface="Calibri" pitchFamily="34" charset="-120"/>
+              </a:rPr>
+              <a:t> · </a:t>
+            </a:r>
+            <a:pPr indent="0" marL="0">
+              <a:buNone/>
+            </a:pPr>
+            <a:r>
+              <a:rPr lang="en-US" sz="1150" u="sng" dirty="0">
+                <a:solidFill>
+                  <a:srgbClr val="C8352B"/>
+                </a:solidFill>
+                <a:latin typeface="Calibri" pitchFamily="34" charset="0"/>
+                <a:ea typeface="Calibri" pitchFamily="34" charset="-122"/>
+                <a:cs typeface="Calibri" pitchFamily="34" charset="-120"/>
+                <a:hlinkClick r:id="rId7" invalidUrl="" action="" tgtFrame="" tooltip="Issue #24" history="1" highlightClick="0" endSnd="0">
+                  <a:extLst>
+                    <a:ext uri="{A12FA001-AC4F-418D-AE19-62706E023703}">
+                      <ahyp:hlinkClr xmlns:ahyp="http://schemas.microsoft.com/office/drawing/2018/hyperlinkcolor" val="tx"/>
+                    </a:ext>
+                  </a:extLst>
+                </a:hlinkClick>
+              </a:rPr>
+              <a:t>#24</a:t>
+            </a:r>
+            <a:pPr indent="0" marL="0">
+              <a:buNone/>
+            </a:pPr>
+            <a:r>
+              <a:rPr lang="en-US" sz="1150" dirty="0">
+                <a:solidFill>
+                  <a:srgbClr val="2B1B17"/>
+                </a:solidFill>
+                <a:latin typeface="Calibri" pitchFamily="34" charset="0"/>
+                <a:ea typeface="Calibri" pitchFamily="34" charset="-122"/>
+                <a:cs typeface="Calibri" pitchFamily="34" charset="-120"/>
+              </a:rPr>
+              <a:t> · </a:t>
+            </a:r>
+            <a:pPr indent="0" marL="0">
+              <a:buNone/>
+            </a:pPr>
+            <a:r>
+              <a:rPr lang="en-US" sz="1150" u="sng" dirty="0">
+                <a:solidFill>
+                  <a:srgbClr val="C8352B"/>
+                </a:solidFill>
+                <a:latin typeface="Calibri" pitchFamily="34" charset="0"/>
+                <a:ea typeface="Calibri" pitchFamily="34" charset="-122"/>
+                <a:cs typeface="Calibri" pitchFamily="34" charset="-120"/>
+                <a:hlinkClick r:id="rId8" invalidUrl="" action="" tgtFrame="" tooltip="Issue #25" history="1" highlightClick="0" endSnd="0">
+                  <a:extLst>
+                    <a:ext uri="{A12FA001-AC4F-418D-AE19-62706E023703}">
+                      <ahyp:hlinkClr xmlns:ahyp="http://schemas.microsoft.com/office/drawing/2018/hyperlinkcolor" val="tx"/>
+                    </a:ext>
+                  </a:extLst>
+                </a:hlinkClick>
+              </a:rPr>
+              <a:t>#25</a:t>
+            </a:r>
+            <a:pPr indent="0" marL="0">
+              <a:buNone/>
+            </a:pPr>
+            <a:r>
+              <a:rPr lang="en-US" sz="1150" dirty="0">
+                <a:solidFill>
+                  <a:srgbClr val="2B1B17"/>
+                </a:solidFill>
+                <a:latin typeface="Calibri" pitchFamily="34" charset="0"/>
+                <a:ea typeface="Calibri" pitchFamily="34" charset="-122"/>
+                <a:cs typeface="Calibri" pitchFamily="34" charset="-120"/>
+              </a:rPr>
+              <a:t> · </a:t>
+            </a:r>
+            <a:pPr indent="0" marL="0">
+              <a:buNone/>
+            </a:pPr>
+            <a:r>
+              <a:rPr lang="en-US" sz="1150" u="sng" dirty="0">
+                <a:solidFill>
+                  <a:srgbClr val="C8352B"/>
+                </a:solidFill>
+                <a:latin typeface="Calibri" pitchFamily="34" charset="0"/>
+                <a:ea typeface="Calibri" pitchFamily="34" charset="-122"/>
+                <a:cs typeface="Calibri" pitchFamily="34" charset="-120"/>
+                <a:hlinkClick r:id="rId9" invalidUrl="" action="" tgtFrame="" tooltip="Issue #17" history="1" highlightClick="0" endSnd="0">
+                  <a:extLst>
+                    <a:ext uri="{A12FA001-AC4F-418D-AE19-62706E023703}">
+                      <ahyp:hlinkClr xmlns:ahyp="http://schemas.microsoft.com/office/drawing/2018/hyperlinkcolor" val="tx"/>
+                    </a:ext>
+                  </a:extLst>
+                </a:hlinkClick>
+              </a:rPr>
+              <a:t>#17</a:t>
+            </a:r>
+            <a:endParaRPr lang="en-US" sz="1150" dirty="0"/>
+          </a:p>
+        </p:txBody>
+      </p:sp>
+      <p:sp>
+        <p:nvSpPr>
+          <p:cNvPr id="10" name="Text 7"/>
+          <p:cNvSpPr txBox="1"/>
+          <p:nvPr/>
+        </p:nvSpPr>
+        <p:spPr>
+          <a:xfrm>
+            <a:off x="457200" y="4334256"/>
+            <a:ext cx="4206240" cy="237744"/>
+          </a:xfrm>
+          <a:prstGeom prst="rect">
+            <a:avLst/>
+          </a:prstGeom>
+          <a:noFill/>
+          <a:ln/>
+        </p:spPr>
+        <p:txBody>
+          <a:bodyPr wrap="square" lIns="0" tIns="0" rIns="0" bIns="0" rtlCol="0" anchor="t"/>
+          <a:lstStyle/>
+          <a:p>
+            <a:pPr indent="0" marL="0">
+              <a:buNone/>
+            </a:pPr>
+            <a:r>
+              <a:rPr lang="en-US" sz="1150" dirty="0">
+                <a:solidFill>
+                  <a:srgbClr val="2B1B17"/>
+                </a:solidFill>
+                <a:latin typeface="Calibri" pitchFamily="34" charset="0"/>
+                <a:ea typeface="Calibri" pitchFamily="34" charset="-122"/>
+                <a:cs typeface="Calibri" pitchFamily="34" charset="-120"/>
+              </a:rPr>
+              <a:t>Testes unitários: </a:t>
+            </a:r>
+            <a:pPr indent="0" marL="0">
+              <a:buNone/>
+            </a:pPr>
+            <a:r>
+              <a:rPr lang="en-US" sz="1150" u="sng" dirty="0">
+                <a:solidFill>
+                  <a:srgbClr val="C8352B"/>
+                </a:solidFill>
+                <a:latin typeface="Calibri" pitchFamily="34" charset="0"/>
+                <a:ea typeface="Calibri" pitchFamily="34" charset="-122"/>
+                <a:cs typeface="Calibri" pitchFamily="34" charset="-120"/>
+                <a:hlinkClick r:id="rId10" invalidUrl="" action="" tgtFrame="" tooltip="Issue #1" history="1" highlightClick="0" endSnd="0">
+                  <a:extLst>
+                    <a:ext uri="{A12FA001-AC4F-418D-AE19-62706E023703}">
+                      <ahyp:hlinkClr xmlns:ahyp="http://schemas.microsoft.com/office/drawing/2018/hyperlinkcolor" val="tx"/>
+                    </a:ext>
+                  </a:extLst>
+                </a:hlinkClick>
+              </a:rPr>
+              <a:t>#1</a:t>
+            </a:r>
+            <a:pPr indent="0" marL="0">
+              <a:buNone/>
+            </a:pPr>
+            <a:r>
+              <a:rPr lang="en-US" sz="1150" dirty="0">
+                <a:solidFill>
+                  <a:srgbClr val="2B1B17"/>
+                </a:solidFill>
+                <a:latin typeface="Calibri" pitchFamily="34" charset="0"/>
+                <a:ea typeface="Calibri" pitchFamily="34" charset="-122"/>
+                <a:cs typeface="Calibri" pitchFamily="34" charset="-120"/>
+              </a:rPr>
+              <a:t> a </a:t>
+            </a:r>
+            <a:pPr indent="0" marL="0">
+              <a:buNone/>
+            </a:pPr>
+            <a:r>
+              <a:rPr lang="en-US" sz="1150" u="sng" dirty="0">
+                <a:solidFill>
+                  <a:srgbClr val="C8352B"/>
+                </a:solidFill>
+                <a:latin typeface="Calibri" pitchFamily="34" charset="0"/>
+                <a:ea typeface="Calibri" pitchFamily="34" charset="-122"/>
+                <a:cs typeface="Calibri" pitchFamily="34" charset="-120"/>
+                <a:hlinkClick r:id="rId11" invalidUrl="" action="" tgtFrame="" tooltip="Issue #5" history="1" highlightClick="0" endSnd="0">
+                  <a:extLst>
+                    <a:ext uri="{A12FA001-AC4F-418D-AE19-62706E023703}">
+                      <ahyp:hlinkClr xmlns:ahyp="http://schemas.microsoft.com/office/drawing/2018/hyperlinkcolor" val="tx"/>
+                    </a:ext>
+                  </a:extLst>
+                </a:hlinkClick>
+              </a:rPr>
+              <a:t>#5</a:t>
+            </a:r>
+            <a:pPr indent="0" marL="0">
+              <a:buNone/>
+            </a:pPr>
+            <a:r>
+              <a:rPr lang="en-US" sz="1150" dirty="0">
+                <a:solidFill>
+                  <a:srgbClr val="2B1B17"/>
+                </a:solidFill>
+                <a:latin typeface="Calibri" pitchFamily="34" charset="0"/>
+                <a:ea typeface="Calibri" pitchFamily="34" charset="-122"/>
+                <a:cs typeface="Calibri" pitchFamily="34" charset="-120"/>
+              </a:rPr>
+              <a:t> · Casos manuais: </a:t>
+            </a:r>
+            <a:pPr indent="0" marL="0">
+              <a:buNone/>
+            </a:pPr>
+            <a:r>
+              <a:rPr lang="en-US" sz="1150" u="sng" dirty="0">
+                <a:solidFill>
+                  <a:srgbClr val="C8352B"/>
+                </a:solidFill>
+                <a:latin typeface="Calibri" pitchFamily="34" charset="0"/>
+                <a:ea typeface="Calibri" pitchFamily="34" charset="-122"/>
+                <a:cs typeface="Calibri" pitchFamily="34" charset="-120"/>
+                <a:hlinkClick r:id="rId12" invalidUrl="" action="" tgtFrame="" tooltip="Issue #6" history="1" highlightClick="0" endSnd="0">
+                  <a:extLst>
+                    <a:ext uri="{A12FA001-AC4F-418D-AE19-62706E023703}">
+                      <ahyp:hlinkClr xmlns:ahyp="http://schemas.microsoft.com/office/drawing/2018/hyperlinkcolor" val="tx"/>
+                    </a:ext>
+                  </a:extLst>
+                </a:hlinkClick>
+              </a:rPr>
+              <a:t>#6</a:t>
+            </a:r>
+            <a:pPr indent="0" marL="0">
+              <a:buNone/>
+            </a:pPr>
+            <a:r>
+              <a:rPr lang="en-US" sz="1150" dirty="0">
+                <a:solidFill>
+                  <a:srgbClr val="2B1B17"/>
+                </a:solidFill>
+                <a:latin typeface="Calibri" pitchFamily="34" charset="0"/>
+                <a:ea typeface="Calibri" pitchFamily="34" charset="-122"/>
+                <a:cs typeface="Calibri" pitchFamily="34" charset="-120"/>
+              </a:rPr>
+              <a:t> a </a:t>
+            </a:r>
+            <a:pPr indent="0" marL="0">
+              <a:buNone/>
+            </a:pPr>
+            <a:r>
+              <a:rPr lang="en-US" sz="1150" u="sng" dirty="0">
+                <a:solidFill>
+                  <a:srgbClr val="C8352B"/>
+                </a:solidFill>
+                <a:latin typeface="Calibri" pitchFamily="34" charset="0"/>
+                <a:ea typeface="Calibri" pitchFamily="34" charset="-122"/>
+                <a:cs typeface="Calibri" pitchFamily="34" charset="-120"/>
+                <a:hlinkClick r:id="rId13" invalidUrl="" action="" tgtFrame="" tooltip="Issue #10" history="1" highlightClick="0" endSnd="0">
+                  <a:extLst>
+                    <a:ext uri="{A12FA001-AC4F-418D-AE19-62706E023703}">
+                      <ahyp:hlinkClr xmlns:ahyp="http://schemas.microsoft.com/office/drawing/2018/hyperlinkcolor" val="tx"/>
+                    </a:ext>
+                  </a:extLst>
+                </a:hlinkClick>
+              </a:rPr>
+              <a:t>#10</a:t>
+            </a:r>
+            <a:endParaRPr lang="en-US" sz="1150" dirty="0"/>
+          </a:p>
+        </p:txBody>
+      </p:sp>
+      <p:sp>
+        <p:nvSpPr>
+          <p:cNvPr id="11" name="Text 8"/>
+          <p:cNvSpPr txBox="1"/>
+          <p:nvPr/>
+        </p:nvSpPr>
+        <p:spPr>
+          <a:xfrm>
+            <a:off x="457200" y="4608576"/>
+            <a:ext cx="4206240" cy="411480"/>
+          </a:xfrm>
+          <a:prstGeom prst="rect">
+            <a:avLst/>
+          </a:prstGeom>
+          <a:noFill/>
+          <a:ln/>
+        </p:spPr>
+        <p:txBody>
+          <a:bodyPr wrap="square" lIns="0" tIns="0" rIns="0" bIns="0" rtlCol="0" anchor="t"/>
+          <a:lstStyle/>
+          <a:p>
+            <a:pPr indent="0" marL="0">
+              <a:buNone/>
+            </a:pPr>
+            <a:r>
+              <a:rPr lang="en-US" sz="950" dirty="0">
                 <a:solidFill>
                   <a:srgbClr val="6B5B55"/>
                 </a:solidFill>
@@ -5326,7 +6464,7 @@
               </a:rPr>
               <a:t>Os cinco achados dos testes manuais ainda não viraram issue: estão listados em docs/entrega-1/README.md.</a:t>
             </a:r>
-            <a:endParaRPr lang="en-US" sz="1100" dirty="0"/>
+            <a:endParaRPr lang="en-US" sz="950" dirty="0"/>
           </a:p>
         </p:txBody>
       </p:sp>
@@ -5434,7 +6572,7 @@
                 <a:ea typeface="Cambria" pitchFamily="34" charset="-122"/>
                 <a:cs typeface="Cambria" pitchFamily="34" charset="-120"/>
               </a:rPr>
-              <a:t>Casos de teste manuais</a:t>
+              <a:t>CT-01 — Autenticação e sessão</a:t>
             </a:r>
             <a:endParaRPr lang="en-US" sz="2300" dirty="0"/>
           </a:p>
@@ -5473,7 +6611,7 @@
                 <a:ea typeface="Calibri" pitchFamily="34" charset="-122"/>
                 <a:cs typeface="Calibri" pitchFamily="34" charset="-120"/>
               </a:rPr>
-              <a:t>Cabeçalho dos documentos: testador, data e ambiente de execução</a:t>
+              <a:t>Yuri Mascarenhas  ·  executado em 21/09  ·  8 passos PASSOU, 0 FALHOU</a:t>
             </a:r>
             <a:endParaRPr lang="en-US" sz="1100" dirty="0"/>
           </a:p>
@@ -5495,8 +6633,8 @@
         </p:blipFill>
         <p:spPr>
           <a:xfrm>
-            <a:off x="457200" y="1188720"/>
-            <a:ext cx="3566160" cy="1843401"/>
+            <a:off x="457200" y="1207008"/>
+            <a:ext cx="3886200" cy="2008834"/>
           </a:xfrm>
           <a:prstGeom prst="rect">
             <a:avLst/>
@@ -5505,7 +6643,7 @@
       </p:pic>
       <p:pic>
         <p:nvPicPr>
-          <p:cNvPr id="6" name="Image 1" descr="C:\Users\felip\source\repos\trabalho-qualidade-e-teste-de-software\docs\entrega-1\apresentacao\anexos\caso-02.png">    </p:cNvPr>
+          <p:cNvPr id="6" name="Image 1" descr="C:\Users\felip\source\repos\trabalho-qualidade-e-teste-de-software\docs\entrega-1\apresentacao\anexos\tela-01.png">    </p:cNvPr>
           <p:cNvPicPr>
             <a:picLocks noChangeAspect="1"/>
           </p:cNvPicPr>
@@ -5519,62 +6657,152 @@
         </p:blipFill>
         <p:spPr>
           <a:xfrm>
-            <a:off x="4937760" y="1188720"/>
-            <a:ext cx="3566160" cy="1819272"/>
+            <a:off x="4617720" y="1207008"/>
+            <a:ext cx="4069080" cy="2289782"/>
           </a:xfrm>
           <a:prstGeom prst="rect">
             <a:avLst/>
           </a:prstGeom>
         </p:spPr>
       </p:pic>
-      <p:pic>
-        <p:nvPicPr>
-          <p:cNvPr id="7" name="Image 2" descr="C:\Users\felip\source\repos\trabalho-qualidade-e-teste-de-software\docs\entrega-1\apresentacao\anexos\caso-03.png">    </p:cNvPr>
-          <p:cNvPicPr>
-            <a:picLocks noChangeAspect="1"/>
-          </p:cNvPicPr>
-          <p:nvPr/>
-        </p:nvPicPr>
-        <p:blipFill>
-          <a:blip r:embed="rId3"/>
-          <a:stretch>
-            <a:fillRect/>
-          </a:stretch>
-        </p:blipFill>
-        <p:spPr>
-          <a:xfrm>
-            <a:off x="457200" y="3154680"/>
-            <a:ext cx="3566160" cy="1807373"/>
-          </a:xfrm>
-          <a:prstGeom prst="rect">
-            <a:avLst/>
-          </a:prstGeom>
-        </p:spPr>
-      </p:pic>
-      <p:pic>
-        <p:nvPicPr>
-          <p:cNvPr id="8" name="Image 3" descr="C:\Users\felip\source\repos\trabalho-qualidade-e-teste-de-software\docs\entrega-1\apresentacao\anexos\caso-04.png">    </p:cNvPr>
-          <p:cNvPicPr>
-            <a:picLocks noChangeAspect="1"/>
-          </p:cNvPicPr>
-          <p:nvPr/>
-        </p:nvPicPr>
-        <p:blipFill>
-          <a:blip r:embed="rId4"/>
-          <a:stretch>
-            <a:fillRect/>
-          </a:stretch>
-        </p:blipFill>
-        <p:spPr>
-          <a:xfrm>
-            <a:off x="4937760" y="3154680"/>
-            <a:ext cx="3566160" cy="1102581"/>
-          </a:xfrm>
-          <a:prstGeom prst="rect">
-            <a:avLst/>
-          </a:prstGeom>
-        </p:spPr>
-      </p:pic>
+      <p:sp>
+        <p:nvSpPr>
+          <p:cNvPr id="7" name="Text 3"/>
+          <p:cNvSpPr txBox="1"/>
+          <p:nvPr/>
+        </p:nvSpPr>
+        <p:spPr>
+          <a:xfrm>
+            <a:off x="4617720" y="3566160"/>
+            <a:ext cx="4069080" cy="457200"/>
+          </a:xfrm>
+          <a:prstGeom prst="rect">
+            <a:avLst/>
+          </a:prstGeom>
+          <a:noFill/>
+          <a:ln/>
+        </p:spPr>
+        <p:txBody>
+          <a:bodyPr wrap="square" lIns="0" tIns="0" rIns="0" bIns="0" rtlCol="0" anchor="t"/>
+          <a:lstStyle/>
+          <a:p>
+            <a:pPr indent="0" marL="0">
+              <a:buNone/>
+            </a:pPr>
+            <a:r>
+              <a:rPr lang="en-US" sz="1050" dirty="0">
+                <a:solidFill>
+                  <a:srgbClr val="6B5B55"/>
+                </a:solidFill>
+                <a:latin typeface="Calibri" pitchFamily="34" charset="0"/>
+                <a:ea typeface="Calibri" pitchFamily="34" charset="-122"/>
+                <a:cs typeface="Calibri" pitchFamily="34" charset="-120"/>
+              </a:rPr>
+              <a:t>Sessão ativa: nome e endereço carregados a partir do cookie de login</a:t>
+            </a:r>
+            <a:endParaRPr lang="en-US" sz="1050" dirty="0"/>
+          </a:p>
+        </p:txBody>
+      </p:sp>
+      <p:sp>
+        <p:nvSpPr>
+          <p:cNvPr id="8" name="Text 4"/>
+          <p:cNvSpPr txBox="1"/>
+          <p:nvPr/>
+        </p:nvSpPr>
+        <p:spPr>
+          <a:xfrm>
+            <a:off x="457200" y="4114800"/>
+            <a:ext cx="8229600" cy="411480"/>
+          </a:xfrm>
+          <a:prstGeom prst="rect">
+            <a:avLst/>
+          </a:prstGeom>
+          <a:noFill/>
+          <a:ln/>
+        </p:spPr>
+        <p:txBody>
+          <a:bodyPr wrap="square" lIns="0" tIns="0" rIns="0" bIns="0" rtlCol="0" anchor="t"/>
+          <a:lstStyle/>
+          <a:p>
+            <a:pPr indent="0" marL="0">
+              <a:buNone/>
+            </a:pPr>
+            <a:r>
+              <a:rPr lang="en-US" sz="1250" dirty="0">
+                <a:solidFill>
+                  <a:srgbClr val="2B1B17"/>
+                </a:solidFill>
+                <a:latin typeface="Calibri" pitchFamily="34" charset="0"/>
+                <a:ea typeface="Calibri" pitchFamily="34" charset="-122"/>
+                <a:cs typeface="Calibri" pitchFamily="34" charset="-120"/>
+              </a:rPr>
+              <a:t>Todos os passos passaram. Fica a observação: o token não expira no servidor.</a:t>
+            </a:r>
+            <a:endParaRPr lang="en-US" sz="1250" dirty="0"/>
+          </a:p>
+        </p:txBody>
+      </p:sp>
+      <p:sp>
+        <p:nvSpPr>
+          <p:cNvPr id="9" name="Text 5"/>
+          <p:cNvSpPr txBox="1"/>
+          <p:nvPr/>
+        </p:nvSpPr>
+        <p:spPr>
+          <a:xfrm>
+            <a:off x="457200" y="4617720"/>
+            <a:ext cx="8229600" cy="274320"/>
+          </a:xfrm>
+          <a:prstGeom prst="rect">
+            <a:avLst/>
+          </a:prstGeom>
+          <a:noFill/>
+          <a:ln/>
+        </p:spPr>
+        <p:txBody>
+          <a:bodyPr wrap="square" lIns="0" tIns="0" rIns="0" bIns="0" rtlCol="0" anchor="t"/>
+          <a:lstStyle/>
+          <a:p>
+            <a:pPr indent="0" marL="0">
+              <a:buNone/>
+            </a:pPr>
+            <a:r>
+              <a:rPr lang="en-US" sz="1100" dirty="0">
+                <a:solidFill>
+                  <a:srgbClr val="2B1B17"/>
+                </a:solidFill>
+                <a:latin typeface="Calibri" pitchFamily="34" charset="0"/>
+                <a:ea typeface="Calibri" pitchFamily="34" charset="-122"/>
+                <a:cs typeface="Calibri" pitchFamily="34" charset="-120"/>
+              </a:rPr>
+              <a:t>Caso: </a:t>
+            </a:r>
+            <a:pPr indent="0" marL="0">
+              <a:buNone/>
+            </a:pPr>
+            <a:r>
+              <a:rPr lang="en-US" sz="1100" u="sng" dirty="0">
+                <a:solidFill>
+                  <a:srgbClr val="C8352B"/>
+                </a:solidFill>
+                <a:latin typeface="Calibri" pitchFamily="34" charset="0"/>
+                <a:ea typeface="Calibri" pitchFamily="34" charset="-122"/>
+                <a:cs typeface="Calibri" pitchFamily="34" charset="-120"/>
+                <a:hlinkClick r:id="rId3" invalidUrl="" action="" tgtFrame="" tooltip="Issue #6" history="1" highlightClick="0" endSnd="0">
+                  <a:extLst>
+                    <a:ext uri="{A12FA001-AC4F-418D-AE19-62706E023703}">
+                      <ahyp:hlinkClr xmlns:ahyp="http://schemas.microsoft.com/office/drawing/2018/hyperlinkcolor" val="tx"/>
+                    </a:ext>
+                  </a:extLst>
+                </a:hlinkClick>
+              </a:rPr>
+              <a:t>#6</a:t>
+            </a:r>
+            <a:endParaRPr lang="en-US" sz="1100" dirty="0"/>
+          </a:p>
+        </p:txBody>
+      </p:sp>
     </p:spTree>
   </p:cSld>
   <p:clrMapOvr>
@@ -5679,7 +6907,7 @@
                 <a:ea typeface="Cambria" pitchFamily="34" charset="-122"/>
                 <a:cs typeface="Cambria" pitchFamily="34" charset="-120"/>
               </a:rPr>
-              <a:t>CT-05 e as suítes de teste</a:t>
+              <a:t>CT-02 — Carrinho e finalização de compra</a:t>
             </a:r>
             <a:endParaRPr lang="en-US" sz="2300" dirty="0"/>
           </a:p>
@@ -5718,7 +6946,7 @@
                 <a:ea typeface="Calibri" pitchFamily="34" charset="-122"/>
                 <a:cs typeface="Calibri" pitchFamily="34" charset="-120"/>
               </a:rPr>
-              <a:t>Último caso manual e a pasta de testes no repositório</a:t>
+              <a:t>Vinicius Rocha Pinheiro  ·  executado em 21/09  ·  6 passos PASSOU, 3 FALHOU</a:t>
             </a:r>
             <a:endParaRPr lang="en-US" sz="1100" dirty="0"/>
           </a:p>
@@ -5726,7 +6954,7 @@
       </p:sp>
       <p:pic>
         <p:nvPicPr>
-          <p:cNvPr id="5" name="Image 0" descr="C:\Users\felip\source\repos\trabalho-qualidade-e-teste-de-software\docs\entrega-1\apresentacao\anexos\caso-05.png">    </p:cNvPr>
+          <p:cNvPr id="5" name="Image 0" descr="C:\Users\felip\source\repos\trabalho-qualidade-e-teste-de-software\docs\entrega-1\apresentacao\anexos\caso-02.png">    </p:cNvPr>
           <p:cNvPicPr>
             <a:picLocks noChangeAspect="1"/>
           </p:cNvPicPr>
@@ -5741,7 +6969,7 @@
         <p:spPr>
           <a:xfrm>
             <a:off x="457200" y="1207008"/>
-            <a:ext cx="4069080" cy="2101064"/>
+            <a:ext cx="3886200" cy="1982540"/>
           </a:xfrm>
           <a:prstGeom prst="rect">
             <a:avLst/>
@@ -5750,7 +6978,7 @@
       </p:pic>
       <p:pic>
         <p:nvPicPr>
-          <p:cNvPr id="6" name="Image 1" descr="C:\Users\felip\source\repos\trabalho-qualidade-e-teste-de-software\docs\entrega-1\apresentacao\anexos\github-pasta-testes.png">    </p:cNvPr>
+          <p:cNvPr id="6" name="Image 1" descr="C:\Users\felip\source\repos\trabalho-qualidade-e-teste-de-software\docs\entrega-1\apresentacao\anexos\tela-02.png">    </p:cNvPr>
           <p:cNvPicPr>
             <a:picLocks noChangeAspect="1"/>
           </p:cNvPicPr>
@@ -5765,7 +6993,7 @@
         <p:spPr>
           <a:xfrm>
             <a:off x="4617720" y="1207008"/>
-            <a:ext cx="4069080" cy="2978567"/>
+            <a:ext cx="4069080" cy="2289782"/>
           </a:xfrm>
           <a:prstGeom prst="rect">
             <a:avLst/>
@@ -5780,7 +7008,7 @@
         </p:nvSpPr>
         <p:spPr>
           <a:xfrm>
-            <a:off x="457200" y="3383280"/>
+            <a:off x="4617720" y="3566160"/>
             <a:ext cx="4069080" cy="457200"/>
           </a:xfrm>
           <a:prstGeom prst="rect">
@@ -5805,7 +7033,7 @@
                 <a:ea typeface="Calibri" pitchFamily="34" charset="-122"/>
                 <a:cs typeface="Calibri" pitchFamily="34" charset="-120"/>
               </a:rPr>
-              <a:t>CT-05 — Gestão de insumos e estoque, executado por Felipe Paixão</a:t>
+              <a:t>Resumo do pedido mostrando R$ 36,00 na tela; o banco gravou R$ 18,00</a:t>
             </a:r>
             <a:endParaRPr lang="en-US" sz="1050" dirty="0"/>
           </a:p>
@@ -5819,34 +7047,164 @@
         </p:nvSpPr>
         <p:spPr>
           <a:xfrm>
-            <a:off x="4617720" y="4224528"/>
-            <a:ext cx="4069080" cy="457200"/>
-          </a:xfrm>
-          <a:prstGeom prst="rect">
-            <a:avLst/>
-          </a:prstGeom>
-          <a:noFill/>
-          <a:ln/>
-        </p:spPr>
-        <p:txBody>
-          <a:bodyPr wrap="square" lIns="0" tIns="0" rIns="0" bIns="0" rtlCol="0" anchor="t"/>
-          <a:lstStyle/>
-          <a:p>
-            <a:pPr indent="0" marL="0">
-              <a:buNone/>
-            </a:pPr>
-            <a:r>
-              <a:rPr lang="en-US" sz="1050" dirty="0">
-                <a:solidFill>
-                  <a:srgbClr val="6B5B55"/>
-                </a:solidFill>
-                <a:latin typeface="Calibri" pitchFamily="34" charset="0"/>
-                <a:ea typeface="Calibri" pitchFamily="34" charset="-122"/>
-                <a:cs typeface="Calibri" pitchFamily="34" charset="-120"/>
-              </a:rPr>
-              <a:t>src/test/java: as classes de teste, uma pasta por camada</a:t>
-            </a:r>
-            <a:endParaRPr lang="en-US" sz="1050" dirty="0"/>
+            <a:off x="457200" y="4114800"/>
+            <a:ext cx="8229600" cy="411480"/>
+          </a:xfrm>
+          <a:prstGeom prst="rect">
+            <a:avLst/>
+          </a:prstGeom>
+          <a:noFill/>
+          <a:ln/>
+        </p:spPr>
+        <p:txBody>
+          <a:bodyPr wrap="square" lIns="0" tIns="0" rIns="0" bIns="0" rtlCol="0" anchor="t"/>
+          <a:lstStyle/>
+          <a:p>
+            <a:pPr indent="0" marL="0">
+              <a:buNone/>
+            </a:pPr>
+            <a:r>
+              <a:rPr lang="en-US" sz="1250" dirty="0">
+                <a:solidFill>
+                  <a:srgbClr val="2B1B17"/>
+                </a:solidFill>
+                <a:latin typeface="Calibri" pitchFamily="34" charset="0"/>
+                <a:ea typeface="Calibri" pitchFamily="34" charset="-122"/>
+                <a:cs typeface="Calibri" pitchFamily="34" charset="-120"/>
+              </a:rPr>
+              <a:t>Finalizar com bebida devolveu HTTP 500 e o carrinho vazio gravou pedido de R$ 0,00.</a:t>
+            </a:r>
+            <a:endParaRPr lang="en-US" sz="1250" dirty="0"/>
+          </a:p>
+        </p:txBody>
+      </p:sp>
+      <p:sp>
+        <p:nvSpPr>
+          <p:cNvPr id="9" name="Text 5"/>
+          <p:cNvSpPr txBox="1"/>
+          <p:nvPr/>
+        </p:nvSpPr>
+        <p:spPr>
+          <a:xfrm>
+            <a:off x="457200" y="4617720"/>
+            <a:ext cx="8229600" cy="274320"/>
+          </a:xfrm>
+          <a:prstGeom prst="rect">
+            <a:avLst/>
+          </a:prstGeom>
+          <a:noFill/>
+          <a:ln/>
+        </p:spPr>
+        <p:txBody>
+          <a:bodyPr wrap="square" lIns="0" tIns="0" rIns="0" bIns="0" rtlCol="0" anchor="t"/>
+          <a:lstStyle/>
+          <a:p>
+            <a:pPr indent="0" marL="0">
+              <a:buNone/>
+            </a:pPr>
+            <a:r>
+              <a:rPr lang="en-US" sz="1100" dirty="0">
+                <a:solidFill>
+                  <a:srgbClr val="2B1B17"/>
+                </a:solidFill>
+                <a:latin typeface="Calibri" pitchFamily="34" charset="0"/>
+                <a:ea typeface="Calibri" pitchFamily="34" charset="-122"/>
+                <a:cs typeface="Calibri" pitchFamily="34" charset="-120"/>
+              </a:rPr>
+              <a:t>Caso: </a:t>
+            </a:r>
+            <a:pPr indent="0" marL="0">
+              <a:buNone/>
+            </a:pPr>
+            <a:r>
+              <a:rPr lang="en-US" sz="1100" u="sng" dirty="0">
+                <a:solidFill>
+                  <a:srgbClr val="C8352B"/>
+                </a:solidFill>
+                <a:latin typeface="Calibri" pitchFamily="34" charset="0"/>
+                <a:ea typeface="Calibri" pitchFamily="34" charset="-122"/>
+                <a:cs typeface="Calibri" pitchFamily="34" charset="-120"/>
+                <a:hlinkClick r:id="rId3" invalidUrl="" action="" tgtFrame="" tooltip="Issue #7" history="1" highlightClick="0" endSnd="0">
+                  <a:extLst>
+                    <a:ext uri="{A12FA001-AC4F-418D-AE19-62706E023703}">
+                      <ahyp:hlinkClr xmlns:ahyp="http://schemas.microsoft.com/office/drawing/2018/hyperlinkcolor" val="tx"/>
+                    </a:ext>
+                  </a:extLst>
+                </a:hlinkClick>
+              </a:rPr>
+              <a:t>#7</a:t>
+            </a:r>
+            <a:pPr indent="0" marL="0">
+              <a:buNone/>
+            </a:pPr>
+            <a:r>
+              <a:rPr lang="en-US" sz="1100" dirty="0">
+                <a:solidFill>
+                  <a:srgbClr val="2B1B17"/>
+                </a:solidFill>
+                <a:latin typeface="Calibri" pitchFamily="34" charset="0"/>
+                <a:ea typeface="Calibri" pitchFamily="34" charset="-122"/>
+                <a:cs typeface="Calibri" pitchFamily="34" charset="-120"/>
+              </a:rPr>
+              <a:t> · defeitos: </a:t>
+            </a:r>
+            <a:pPr indent="0" marL="0">
+              <a:buNone/>
+            </a:pPr>
+            <a:r>
+              <a:rPr lang="en-US" sz="1100" u="sng" dirty="0">
+                <a:solidFill>
+                  <a:srgbClr val="C8352B"/>
+                </a:solidFill>
+                <a:latin typeface="Calibri" pitchFamily="34" charset="0"/>
+                <a:ea typeface="Calibri" pitchFamily="34" charset="-122"/>
+                <a:cs typeface="Calibri" pitchFamily="34" charset="-120"/>
+                <a:hlinkClick r:id="rId4" invalidUrl="" action="" tgtFrame="" tooltip="Issue #21" history="1" highlightClick="0" endSnd="0">
+                  <a:extLst>
+                    <a:ext uri="{A12FA001-AC4F-418D-AE19-62706E023703}">
+                      <ahyp:hlinkClr xmlns:ahyp="http://schemas.microsoft.com/office/drawing/2018/hyperlinkcolor" val="tx"/>
+                    </a:ext>
+                  </a:extLst>
+                </a:hlinkClick>
+              </a:rPr>
+              <a:t>#21</a:t>
+            </a:r>
+            <a:pPr indent="0" marL="0">
+              <a:buNone/>
+            </a:pPr>
+            <a:r>
+              <a:rPr lang="en-US" sz="1100" dirty="0">
+                <a:solidFill>
+                  <a:srgbClr val="2B1B17"/>
+                </a:solidFill>
+                <a:latin typeface="Calibri" pitchFamily="34" charset="0"/>
+                <a:ea typeface="Calibri" pitchFamily="34" charset="-122"/>
+                <a:cs typeface="Calibri" pitchFamily="34" charset="-120"/>
+              </a:rPr>
+              <a:t> e </a:t>
+            </a:r>
+            <a:pPr indent="0" marL="0">
+              <a:buNone/>
+            </a:pPr>
+            <a:r>
+              <a:rPr lang="en-US" sz="1100" u="sng" dirty="0">
+                <a:solidFill>
+                  <a:srgbClr val="C8352B"/>
+                </a:solidFill>
+                <a:latin typeface="Calibri" pitchFamily="34" charset="0"/>
+                <a:ea typeface="Calibri" pitchFamily="34" charset="-122"/>
+                <a:cs typeface="Calibri" pitchFamily="34" charset="-120"/>
+                <a:hlinkClick r:id="rId5" invalidUrl="" action="" tgtFrame="" tooltip="Issue #22" history="1" highlightClick="0" endSnd="0">
+                  <a:extLst>
+                    <a:ext uri="{A12FA001-AC4F-418D-AE19-62706E023703}">
+                      <ahyp:hlinkClr xmlns:ahyp="http://schemas.microsoft.com/office/drawing/2018/hyperlinkcolor" val="tx"/>
+                    </a:ext>
+                  </a:extLst>
+                </a:hlinkClick>
+              </a:rPr>
+              <a:t>#22</a:t>
+            </a:r>
+            <a:endParaRPr lang="en-US" sz="1100" dirty="0"/>
           </a:p>
         </p:txBody>
       </p:sp>
@@ -5954,7 +7312,7 @@
                 <a:ea typeface="Cambria" pitchFamily="34" charset="-122"/>
                 <a:cs typeface="Cambria" pitchFamily="34" charset="-120"/>
               </a:rPr>
-              <a:t>Execução das suítes</a:t>
+              <a:t>CT-03 — Cadastro de cliente</a:t>
             </a:r>
             <a:endParaRPr lang="en-US" sz="2300" dirty="0"/>
           </a:p>
@@ -5993,7 +7351,7 @@
                 <a:ea typeface="Calibri" pitchFamily="34" charset="-122"/>
                 <a:cs typeface="Calibri" pitchFamily="34" charset="-120"/>
               </a:rPr>
-              <a:t>Saída real do Maven, nas duas suítes</a:t>
+              <a:t>Thiago Ferreira  ·  executado em 21/09  ·  2 passos PASSOU, 5 FALHOU</a:t>
             </a:r>
             <a:endParaRPr lang="en-US" sz="1100" dirty="0"/>
           </a:p>
@@ -6001,7 +7359,7 @@
       </p:sp>
       <p:pic>
         <p:nvPicPr>
-          <p:cNvPr id="5" name="Image 0" descr="C:\Users\felip\source\repos\trabalho-qualidade-e-teste-de-software\docs\entrega-1\apresentacao\anexos\execucao-maven.png">    </p:cNvPr>
+          <p:cNvPr id="5" name="Image 0" descr="C:\Users\felip\source\repos\trabalho-qualidade-e-teste-de-software\docs\entrega-1\apresentacao\anexos\caso-03.png">    </p:cNvPr>
           <p:cNvPicPr>
             <a:picLocks noChangeAspect="1"/>
           </p:cNvPicPr>
@@ -6015,24 +7373,87 @@
         </p:blipFill>
         <p:spPr>
           <a:xfrm>
-            <a:off x="457200" y="1234440"/>
-            <a:ext cx="8229600" cy="2495427"/>
+            <a:off x="457200" y="1207008"/>
+            <a:ext cx="3886200" cy="1969573"/>
           </a:xfrm>
           <a:prstGeom prst="rect">
             <a:avLst/>
           </a:prstGeom>
         </p:spPr>
       </p:pic>
-      <p:sp>
-        <p:nvSpPr>
-          <p:cNvPr id="6" name="Text 3"/>
-          <p:cNvSpPr txBox="1"/>
-          <p:nvPr/>
-        </p:nvSpPr>
-        <p:spPr>
-          <a:xfrm>
-            <a:off x="457200" y="3840480"/>
-            <a:ext cx="8229600" cy="548640"/>
+      <p:pic>
+        <p:nvPicPr>
+          <p:cNvPr id="6" name="Image 1" descr="C:\Users\felip\source\repos\trabalho-qualidade-e-teste-de-software\docs\entrega-1\apresentacao\anexos\tela-03.png">    </p:cNvPr>
+          <p:cNvPicPr>
+            <a:picLocks noChangeAspect="1"/>
+          </p:cNvPicPr>
+          <p:nvPr/>
+        </p:nvPicPr>
+        <p:blipFill>
+          <a:blip r:embed="rId2"/>
+          <a:stretch>
+            <a:fillRect/>
+          </a:stretch>
+        </p:blipFill>
+        <p:spPr>
+          <a:xfrm>
+            <a:off x="4617720" y="1207008"/>
+            <a:ext cx="4069080" cy="2289782"/>
+          </a:xfrm>
+          <a:prstGeom prst="rect">
+            <a:avLst/>
+          </a:prstGeom>
+        </p:spPr>
+      </p:pic>
+      <p:sp>
+        <p:nvSpPr>
+          <p:cNvPr id="7" name="Text 3"/>
+          <p:cNvSpPr txBox="1"/>
+          <p:nvPr/>
+        </p:nvSpPr>
+        <p:spPr>
+          <a:xfrm>
+            <a:off x="4617720" y="3566160"/>
+            <a:ext cx="4069080" cy="457200"/>
+          </a:xfrm>
+          <a:prstGeom prst="rect">
+            <a:avLst/>
+          </a:prstGeom>
+          <a:noFill/>
+          <a:ln/>
+        </p:spPr>
+        <p:txBody>
+          <a:bodyPr wrap="square" lIns="0" tIns="0" rIns="0" bIns="0" rtlCol="0" anchor="t"/>
+          <a:lstStyle/>
+          <a:p>
+            <a:pPr indent="0" marL="0">
+              <a:buNone/>
+            </a:pPr>
+            <a:r>
+              <a:rPr lang="en-US" sz="1050" dirty="0">
+                <a:solidFill>
+                  <a:srgbClr val="6B5B55"/>
+                </a:solidFill>
+                <a:latin typeface="Calibri" pitchFamily="34" charset="0"/>
+                <a:ea typeface="Calibri" pitchFamily="34" charset="-122"/>
+                <a:cs typeface="Calibri" pitchFamily="34" charset="-120"/>
+              </a:rPr>
+              <a:t>Nome cadastrado como "José Conceição" aparece corrompido na tela</a:t>
+            </a:r>
+            <a:endParaRPr lang="en-US" sz="1050" dirty="0"/>
+          </a:p>
+        </p:txBody>
+      </p:sp>
+      <p:sp>
+        <p:nvSpPr>
+          <p:cNvPr id="8" name="Text 4"/>
+          <p:cNvSpPr txBox="1"/>
+          <p:nvPr/>
+        </p:nvSpPr>
+        <p:spPr>
+          <a:xfrm>
+            <a:off x="457200" y="4114800"/>
+            <a:ext cx="8229600" cy="411480"/>
           </a:xfrm>
           <a:prstGeom prst="rect">
             <a:avLst/>
@@ -6056,7 +7477,7 @@
                 <a:ea typeface="Calibri" pitchFamily="34" charset="-122"/>
                 <a:cs typeface="Calibri" pitchFamily="34" charset="-120"/>
               </a:rPr>
-              <a:t>A suíte padrão fica verde. A de defeitos fica vermelha de propósito: cada teste ali descreve o comportamento correto e falha enquanto o defeito existir.</a:t>
+              <a:t>Campos vazios aceitos, usuário duplicado aceito e acentuação corrompida.</a:t>
             </a:r>
             <a:endParaRPr lang="en-US" sz="1250" dirty="0"/>
           </a:p>
@@ -6064,13 +7485,13 @@
       </p:sp>
       <p:sp>
         <p:nvSpPr>
-          <p:cNvPr id="7" name="Text 4"/>
-          <p:cNvSpPr txBox="1"/>
-          <p:nvPr/>
-        </p:nvSpPr>
-        <p:spPr>
-          <a:xfrm>
-            <a:off x="457200" y="4526280"/>
+          <p:cNvPr id="9" name="Text 5"/>
+          <p:cNvSpPr txBox="1"/>
+          <p:nvPr/>
+        </p:nvSpPr>
+        <p:spPr>
+          <a:xfrm>
+            <a:off x="457200" y="4617720"/>
             <a:ext cx="8229600" cy="274320"/>
           </a:xfrm>
           <a:prstGeom prst="rect">
@@ -6087,7 +7508,7 @@
               <a:buNone/>
             </a:pPr>
             <a:r>
-              <a:rPr lang="en-US" sz="1250" b="1" dirty="0">
+              <a:rPr lang="en-US" sz="1100" dirty="0">
                 <a:solidFill>
                   <a:srgbClr val="2B1B17"/>
                 </a:solidFill>
@@ -6095,9 +7516,875 @@
                 <a:ea typeface="Calibri" pitchFamily="34" charset="-122"/>
                 <a:cs typeface="Calibri" pitchFamily="34" charset="-120"/>
               </a:rPr>
-              <a:t>Reproduzir:  mvn clean test   ·   mvn test -Pdefeitos</a:t>
+              <a:t>Caso: </a:t>
+            </a:r>
+            <a:pPr indent="0" marL="0">
+              <a:buNone/>
+            </a:pPr>
+            <a:r>
+              <a:rPr lang="en-US" sz="1100" u="sng" dirty="0">
+                <a:solidFill>
+                  <a:srgbClr val="C8352B"/>
+                </a:solidFill>
+                <a:latin typeface="Calibri" pitchFamily="34" charset="0"/>
+                <a:ea typeface="Calibri" pitchFamily="34" charset="-122"/>
+                <a:cs typeface="Calibri" pitchFamily="34" charset="-120"/>
+                <a:hlinkClick r:id="rId3" invalidUrl="" action="" tgtFrame="" tooltip="Issue #8" history="1" highlightClick="0" endSnd="0">
+                  <a:extLst>
+                    <a:ext uri="{A12FA001-AC4F-418D-AE19-62706E023703}">
+                      <ahyp:hlinkClr xmlns:ahyp="http://schemas.microsoft.com/office/drawing/2018/hyperlinkcolor" val="tx"/>
+                    </a:ext>
+                  </a:extLst>
+                </a:hlinkClick>
+              </a:rPr>
+              <a:t>#8</a:t>
+            </a:r>
+            <a:pPr indent="0" marL="0">
+              <a:buNone/>
+            </a:pPr>
+            <a:r>
+              <a:rPr lang="en-US" sz="1100" dirty="0">
+                <a:solidFill>
+                  <a:srgbClr val="2B1B17"/>
+                </a:solidFill>
+                <a:latin typeface="Calibri" pitchFamily="34" charset="0"/>
+                <a:ea typeface="Calibri" pitchFamily="34" charset="-122"/>
+                <a:cs typeface="Calibri" pitchFamily="34" charset="-120"/>
+              </a:rPr>
+              <a:t> · defeitos: </a:t>
+            </a:r>
+            <a:pPr indent="0" marL="0">
+              <a:buNone/>
+            </a:pPr>
+            <a:r>
+              <a:rPr lang="en-US" sz="1100" u="sng" dirty="0">
+                <a:solidFill>
+                  <a:srgbClr val="C8352B"/>
+                </a:solidFill>
+                <a:latin typeface="Calibri" pitchFamily="34" charset="0"/>
+                <a:ea typeface="Calibri" pitchFamily="34" charset="-122"/>
+                <a:cs typeface="Calibri" pitchFamily="34" charset="-120"/>
+                <a:hlinkClick r:id="rId4" invalidUrl="" action="" tgtFrame="" tooltip="Issue #24" history="1" highlightClick="0" endSnd="0">
+                  <a:extLst>
+                    <a:ext uri="{A12FA001-AC4F-418D-AE19-62706E023703}">
+                      <ahyp:hlinkClr xmlns:ahyp="http://schemas.microsoft.com/office/drawing/2018/hyperlinkcolor" val="tx"/>
+                    </a:ext>
+                  </a:extLst>
+                </a:hlinkClick>
+              </a:rPr>
+              <a:t>#24</a:t>
+            </a:r>
+            <a:pPr indent="0" marL="0">
+              <a:buNone/>
+            </a:pPr>
+            <a:r>
+              <a:rPr lang="en-US" sz="1100" dirty="0">
+                <a:solidFill>
+                  <a:srgbClr val="2B1B17"/>
+                </a:solidFill>
+                <a:latin typeface="Calibri" pitchFamily="34" charset="0"/>
+                <a:ea typeface="Calibri" pitchFamily="34" charset="-122"/>
+                <a:cs typeface="Calibri" pitchFamily="34" charset="-120"/>
+              </a:rPr>
+              <a:t> e </a:t>
+            </a:r>
+            <a:pPr indent="0" marL="0">
+              <a:buNone/>
+            </a:pPr>
+            <a:r>
+              <a:rPr lang="en-US" sz="1100" u="sng" dirty="0">
+                <a:solidFill>
+                  <a:srgbClr val="C8352B"/>
+                </a:solidFill>
+                <a:latin typeface="Calibri" pitchFamily="34" charset="0"/>
+                <a:ea typeface="Calibri" pitchFamily="34" charset="-122"/>
+                <a:cs typeface="Calibri" pitchFamily="34" charset="-120"/>
+                <a:hlinkClick r:id="rId5" invalidUrl="" action="" tgtFrame="" tooltip="Issue #23" history="1" highlightClick="0" endSnd="0">
+                  <a:extLst>
+                    <a:ext uri="{A12FA001-AC4F-418D-AE19-62706E023703}">
+                      <ahyp:hlinkClr xmlns:ahyp="http://schemas.microsoft.com/office/drawing/2018/hyperlinkcolor" val="tx"/>
+                    </a:ext>
+                  </a:extLst>
+                </a:hlinkClick>
+              </a:rPr>
+              <a:t>#23</a:t>
+            </a:r>
+            <a:endParaRPr lang="en-US" sz="1100" dirty="0"/>
+          </a:p>
+        </p:txBody>
+      </p:sp>
+    </p:spTree>
+  </p:cSld>
+  <p:clrMapOvr>
+    <a:masterClrMapping/>
+  </p:clrMapOvr>
+</p:sld>
+</file>
+
+<file path=ppt/slides/slide18.xml><?xml version="1.0" encoding="utf-8"?>
+<p:sld xmlns:a="http://schemas.openxmlformats.org/drawingml/2006/main" xmlns:r="http://schemas.openxmlformats.org/officeDocument/2006/relationships" xmlns:p="http://schemas.openxmlformats.org/presentationml/2006/main">
+  <p:cSld name="Slide 18">
+    <p:bg>
+      <p:bgPr>
+        <a:solidFill>
+          <a:srgbClr val="FFFFFF"/>
+        </a:solidFill>
+      </p:bgPr>
+    </p:bg>
+    <p:spTree>
+      <p:nvGrpSpPr>
+        <p:cNvPr id="1" name=""/>
+        <p:cNvGrpSpPr/>
+        <p:nvPr/>
+      </p:nvGrpSpPr>
+      <p:grpSpPr>
+        <a:xfrm>
+          <a:off x="0" y="0"/>
+          <a:ext cx="0" cy="0"/>
+          <a:chOff x="0" y="0"/>
+          <a:chExt cx="0" cy="0"/>
+        </a:xfrm>
+      </p:grpSpPr>
+      <p:sp>
+        <p:nvSpPr>
+          <p:cNvPr id="2" name="Text 0"/>
+          <p:cNvSpPr txBox="1"/>
+          <p:nvPr/>
+        </p:nvSpPr>
+        <p:spPr>
+          <a:xfrm>
+            <a:off x="457200" y="292608"/>
+            <a:ext cx="2743200" cy="219456"/>
+          </a:xfrm>
+          <a:prstGeom prst="rect">
+            <a:avLst/>
+          </a:prstGeom>
+          <a:noFill/>
+          <a:ln/>
+        </p:spPr>
+        <p:txBody>
+          <a:bodyPr wrap="square" lIns="0" tIns="0" rIns="0" bIns="0" rtlCol="0" anchor="t"/>
+          <a:lstStyle/>
+          <a:p>
+            <a:pPr indent="0" marL="0">
+              <a:buNone/>
+            </a:pPr>
+            <a:r>
+              <a:rPr lang="en-US" sz="1000" b="1" spc="200" kern="0" dirty="0">
+                <a:solidFill>
+                  <a:srgbClr val="C8352B"/>
+                </a:solidFill>
+                <a:latin typeface="Calibri" pitchFamily="34" charset="0"/>
+                <a:ea typeface="Calibri" pitchFamily="34" charset="-122"/>
+                <a:cs typeface="Calibri" pitchFamily="34" charset="-120"/>
+              </a:rPr>
+              <a:t>ANEXO</a:t>
+            </a:r>
+            <a:endParaRPr lang="en-US" sz="1000" dirty="0"/>
+          </a:p>
+        </p:txBody>
+      </p:sp>
+      <p:sp>
+        <p:nvSpPr>
+          <p:cNvPr id="3" name="Text 1"/>
+          <p:cNvSpPr txBox="1"/>
+          <p:nvPr/>
+        </p:nvSpPr>
+        <p:spPr>
+          <a:xfrm>
+            <a:off x="457200" y="512064"/>
+            <a:ext cx="8229600" cy="411480"/>
+          </a:xfrm>
+          <a:prstGeom prst="rect">
+            <a:avLst/>
+          </a:prstGeom>
+          <a:noFill/>
+          <a:ln/>
+        </p:spPr>
+        <p:txBody>
+          <a:bodyPr wrap="square" lIns="0" tIns="0" rIns="0" bIns="0" rtlCol="0" anchor="t"/>
+          <a:lstStyle/>
+          <a:p>
+            <a:pPr indent="0" marL="0">
+              <a:buNone/>
+            </a:pPr>
+            <a:r>
+              <a:rPr lang="en-US" sz="2300" b="1" dirty="0">
+                <a:solidFill>
+                  <a:srgbClr val="2B1B17"/>
+                </a:solidFill>
+                <a:latin typeface="Cambria" pitchFamily="34" charset="0"/>
+                <a:ea typeface="Cambria" pitchFamily="34" charset="-122"/>
+                <a:cs typeface="Cambria" pitchFamily="34" charset="-120"/>
+              </a:rPr>
+              <a:t>CT-04 — Montagem de lanche personalizado</a:t>
+            </a:r>
+            <a:endParaRPr lang="en-US" sz="2300" dirty="0"/>
+          </a:p>
+        </p:txBody>
+      </p:sp>
+      <p:sp>
+        <p:nvSpPr>
+          <p:cNvPr id="4" name="Text 2"/>
+          <p:cNvSpPr txBox="1"/>
+          <p:nvPr/>
+        </p:nvSpPr>
+        <p:spPr>
+          <a:xfrm>
+            <a:off x="457200" y="914400"/>
+            <a:ext cx="8229600" cy="237744"/>
+          </a:xfrm>
+          <a:prstGeom prst="rect">
+            <a:avLst/>
+          </a:prstGeom>
+          <a:noFill/>
+          <a:ln/>
+        </p:spPr>
+        <p:txBody>
+          <a:bodyPr wrap="square" lIns="0" tIns="0" rIns="0" bIns="0" rtlCol="0" anchor="t"/>
+          <a:lstStyle/>
+          <a:p>
+            <a:pPr indent="0" marL="0">
+              <a:buNone/>
+            </a:pPr>
+            <a:r>
+              <a:rPr lang="en-US" sz="1100" dirty="0">
+                <a:solidFill>
+                  <a:srgbClr val="6B5B55"/>
+                </a:solidFill>
+                <a:latin typeface="Calibri" pitchFamily="34" charset="0"/>
+                <a:ea typeface="Calibri" pitchFamily="34" charset="-122"/>
+                <a:cs typeface="Calibri" pitchFamily="34" charset="-120"/>
+              </a:rPr>
+              <a:t>Vinicius Fonseca  ·  executado em 20/09  ·  2 passos PASSOU, 2 FALHOU</a:t>
+            </a:r>
+            <a:endParaRPr lang="en-US" sz="1100" dirty="0"/>
+          </a:p>
+        </p:txBody>
+      </p:sp>
+      <p:pic>
+        <p:nvPicPr>
+          <p:cNvPr id="5" name="Image 0" descr="C:\Users\felip\source\repos\trabalho-qualidade-e-teste-de-software\docs\entrega-1\apresentacao\anexos\caso-04.png">    </p:cNvPr>
+          <p:cNvPicPr>
+            <a:picLocks noChangeAspect="1"/>
+          </p:cNvPicPr>
+          <p:nvPr/>
+        </p:nvPicPr>
+        <p:blipFill>
+          <a:blip r:embed="rId1"/>
+          <a:stretch>
+            <a:fillRect/>
+          </a:stretch>
+        </p:blipFill>
+        <p:spPr>
+          <a:xfrm>
+            <a:off x="457200" y="1207008"/>
+            <a:ext cx="3886200" cy="1201530"/>
+          </a:xfrm>
+          <a:prstGeom prst="rect">
+            <a:avLst/>
+          </a:prstGeom>
+        </p:spPr>
+      </p:pic>
+      <p:pic>
+        <p:nvPicPr>
+          <p:cNvPr id="6" name="Image 1" descr="C:\Users\felip\source\repos\trabalho-qualidade-e-teste-de-software\docs\entrega-1\apresentacao\anexos\tela-04.png">    </p:cNvPr>
+          <p:cNvPicPr>
+            <a:picLocks noChangeAspect="1"/>
+          </p:cNvPicPr>
+          <p:nvPr/>
+        </p:nvPicPr>
+        <p:blipFill>
+          <a:blip r:embed="rId2"/>
+          <a:stretch>
+            <a:fillRect/>
+          </a:stretch>
+        </p:blipFill>
+        <p:spPr>
+          <a:xfrm>
+            <a:off x="4617720" y="1207008"/>
+            <a:ext cx="4069080" cy="1860679"/>
+          </a:xfrm>
+          <a:prstGeom prst="rect">
+            <a:avLst/>
+          </a:prstGeom>
+        </p:spPr>
+      </p:pic>
+      <p:sp>
+        <p:nvSpPr>
+          <p:cNvPr id="7" name="Text 3"/>
+          <p:cNvSpPr txBox="1"/>
+          <p:nvPr/>
+        </p:nvSpPr>
+        <p:spPr>
+          <a:xfrm>
+            <a:off x="4617720" y="3566160"/>
+            <a:ext cx="4069080" cy="457200"/>
+          </a:xfrm>
+          <a:prstGeom prst="rect">
+            <a:avLst/>
+          </a:prstGeom>
+          <a:noFill/>
+          <a:ln/>
+        </p:spPr>
+        <p:txBody>
+          <a:bodyPr wrap="square" lIns="0" tIns="0" rIns="0" bIns="0" rtlCol="0" anchor="t"/>
+          <a:lstStyle/>
+          <a:p>
+            <a:pPr indent="0" marL="0">
+              <a:buNone/>
+            </a:pPr>
+            <a:r>
+              <a:rPr lang="en-US" sz="1050" dirty="0">
+                <a:solidFill>
+                  <a:srgbClr val="6B5B55"/>
+                </a:solidFill>
+                <a:latin typeface="Calibri" pitchFamily="34" charset="0"/>
+                <a:ea typeface="Calibri" pitchFamily="34" charset="-122"/>
+                <a:cs typeface="Calibri" pitchFamily="34" charset="-120"/>
+              </a:rPr>
+              <a:t>Tela de montagem: escolha do pão e dos ingredientes, com o preço somado</a:t>
+            </a:r>
+            <a:endParaRPr lang="en-US" sz="1050" dirty="0"/>
+          </a:p>
+        </p:txBody>
+      </p:sp>
+      <p:sp>
+        <p:nvSpPr>
+          <p:cNvPr id="8" name="Text 4"/>
+          <p:cNvSpPr txBox="1"/>
+          <p:nvPr/>
+        </p:nvSpPr>
+        <p:spPr>
+          <a:xfrm>
+            <a:off x="457200" y="4114800"/>
+            <a:ext cx="8229600" cy="411480"/>
+          </a:xfrm>
+          <a:prstGeom prst="rect">
+            <a:avLst/>
+          </a:prstGeom>
+          <a:noFill/>
+          <a:ln/>
+        </p:spPr>
+        <p:txBody>
+          <a:bodyPr wrap="square" lIns="0" tIns="0" rIns="0" bIns="0" rtlCol="0" anchor="t"/>
+          <a:lstStyle/>
+          <a:p>
+            <a:pPr indent="0" marL="0">
+              <a:buNone/>
+            </a:pPr>
+            <a:r>
+              <a:rPr lang="en-US" sz="1250" dirty="0">
+                <a:solidFill>
+                  <a:srgbClr val="2B1B17"/>
+                </a:solidFill>
+                <a:latin typeface="Calibri" pitchFamily="34" charset="0"/>
+                <a:ea typeface="Calibri" pitchFamily="34" charset="-122"/>
+                <a:cs typeface="Calibri" pitchFamily="34" charset="-120"/>
+              </a:rPr>
+              <a:t>O botão Adicionar não responde e Cancelar devolve tela branca.</a:t>
             </a:r>
             <a:endParaRPr lang="en-US" sz="1250" dirty="0"/>
+          </a:p>
+        </p:txBody>
+      </p:sp>
+      <p:sp>
+        <p:nvSpPr>
+          <p:cNvPr id="9" name="Text 5"/>
+          <p:cNvSpPr txBox="1"/>
+          <p:nvPr/>
+        </p:nvSpPr>
+        <p:spPr>
+          <a:xfrm>
+            <a:off x="457200" y="4617720"/>
+            <a:ext cx="8229600" cy="274320"/>
+          </a:xfrm>
+          <a:prstGeom prst="rect">
+            <a:avLst/>
+          </a:prstGeom>
+          <a:noFill/>
+          <a:ln/>
+        </p:spPr>
+        <p:txBody>
+          <a:bodyPr wrap="square" lIns="0" tIns="0" rIns="0" bIns="0" rtlCol="0" anchor="t"/>
+          <a:lstStyle/>
+          <a:p>
+            <a:pPr indent="0" marL="0">
+              <a:buNone/>
+            </a:pPr>
+            <a:r>
+              <a:rPr lang="en-US" sz="1100" dirty="0">
+                <a:solidFill>
+                  <a:srgbClr val="2B1B17"/>
+                </a:solidFill>
+                <a:latin typeface="Calibri" pitchFamily="34" charset="0"/>
+                <a:ea typeface="Calibri" pitchFamily="34" charset="-122"/>
+                <a:cs typeface="Calibri" pitchFamily="34" charset="-120"/>
+              </a:rPr>
+              <a:t>Caso: </a:t>
+            </a:r>
+            <a:pPr indent="0" marL="0">
+              <a:buNone/>
+            </a:pPr>
+            <a:r>
+              <a:rPr lang="en-US" sz="1100" u="sng" dirty="0">
+                <a:solidFill>
+                  <a:srgbClr val="C8352B"/>
+                </a:solidFill>
+                <a:latin typeface="Calibri" pitchFamily="34" charset="0"/>
+                <a:ea typeface="Calibri" pitchFamily="34" charset="-122"/>
+                <a:cs typeface="Calibri" pitchFamily="34" charset="-120"/>
+                <a:hlinkClick r:id="rId3" invalidUrl="" action="" tgtFrame="" tooltip="Issue #9" history="1" highlightClick="0" endSnd="0">
+                  <a:extLst>
+                    <a:ext uri="{A12FA001-AC4F-418D-AE19-62706E023703}">
+                      <ahyp:hlinkClr xmlns:ahyp="http://schemas.microsoft.com/office/drawing/2018/hyperlinkcolor" val="tx"/>
+                    </a:ext>
+                  </a:extLst>
+                </a:hlinkClick>
+              </a:rPr>
+              <a:t>#9</a:t>
+            </a:r>
+            <a:pPr indent="0" marL="0">
+              <a:buNone/>
+            </a:pPr>
+            <a:r>
+              <a:rPr lang="en-US" sz="1100" dirty="0">
+                <a:solidFill>
+                  <a:srgbClr val="2B1B17"/>
+                </a:solidFill>
+                <a:latin typeface="Calibri" pitchFamily="34" charset="0"/>
+                <a:ea typeface="Calibri" pitchFamily="34" charset="-122"/>
+                <a:cs typeface="Calibri" pitchFamily="34" charset="-120"/>
+              </a:rPr>
+              <a:t> · defeitos: </a:t>
+            </a:r>
+            <a:pPr indent="0" marL="0">
+              <a:buNone/>
+            </a:pPr>
+            <a:r>
+              <a:rPr lang="en-US" sz="1100" u="sng" dirty="0">
+                <a:solidFill>
+                  <a:srgbClr val="C8352B"/>
+                </a:solidFill>
+                <a:latin typeface="Calibri" pitchFamily="34" charset="0"/>
+                <a:ea typeface="Calibri" pitchFamily="34" charset="-122"/>
+                <a:cs typeface="Calibri" pitchFamily="34" charset="-120"/>
+                <a:hlinkClick r:id="rId4" invalidUrl="" action="" tgtFrame="" tooltip="Issue #17" history="1" highlightClick="0" endSnd="0">
+                  <a:extLst>
+                    <a:ext uri="{A12FA001-AC4F-418D-AE19-62706E023703}">
+                      <ahyp:hlinkClr xmlns:ahyp="http://schemas.microsoft.com/office/drawing/2018/hyperlinkcolor" val="tx"/>
+                    </a:ext>
+                  </a:extLst>
+                </a:hlinkClick>
+              </a:rPr>
+              <a:t>#17</a:t>
+            </a:r>
+            <a:pPr indent="0" marL="0">
+              <a:buNone/>
+            </a:pPr>
+            <a:r>
+              <a:rPr lang="en-US" sz="1100" dirty="0">
+                <a:solidFill>
+                  <a:srgbClr val="2B1B17"/>
+                </a:solidFill>
+                <a:latin typeface="Calibri" pitchFamily="34" charset="0"/>
+                <a:ea typeface="Calibri" pitchFamily="34" charset="-122"/>
+                <a:cs typeface="Calibri" pitchFamily="34" charset="-120"/>
+              </a:rPr>
+              <a:t> e </a:t>
+            </a:r>
+            <a:pPr indent="0" marL="0">
+              <a:buNone/>
+            </a:pPr>
+            <a:r>
+              <a:rPr lang="en-US" sz="1100" u="sng" dirty="0">
+                <a:solidFill>
+                  <a:srgbClr val="C8352B"/>
+                </a:solidFill>
+                <a:latin typeface="Calibri" pitchFamily="34" charset="0"/>
+                <a:ea typeface="Calibri" pitchFamily="34" charset="-122"/>
+                <a:cs typeface="Calibri" pitchFamily="34" charset="-120"/>
+                <a:hlinkClick r:id="rId5" invalidUrl="" action="" tgtFrame="" tooltip="Issue #20" history="1" highlightClick="0" endSnd="0">
+                  <a:extLst>
+                    <a:ext uri="{A12FA001-AC4F-418D-AE19-62706E023703}">
+                      <ahyp:hlinkClr xmlns:ahyp="http://schemas.microsoft.com/office/drawing/2018/hyperlinkcolor" val="tx"/>
+                    </a:ext>
+                  </a:extLst>
+                </a:hlinkClick>
+              </a:rPr>
+              <a:t>#20</a:t>
+            </a:r>
+            <a:endParaRPr lang="en-US" sz="1100" dirty="0"/>
+          </a:p>
+        </p:txBody>
+      </p:sp>
+    </p:spTree>
+  </p:cSld>
+  <p:clrMapOvr>
+    <a:masterClrMapping/>
+  </p:clrMapOvr>
+</p:sld>
+</file>
+
+<file path=ppt/slides/slide19.xml><?xml version="1.0" encoding="utf-8"?>
+<p:sld xmlns:a="http://schemas.openxmlformats.org/drawingml/2006/main" xmlns:r="http://schemas.openxmlformats.org/officeDocument/2006/relationships" xmlns:p="http://schemas.openxmlformats.org/presentationml/2006/main">
+  <p:cSld name="Slide 19">
+    <p:bg>
+      <p:bgPr>
+        <a:solidFill>
+          <a:srgbClr val="FFFFFF"/>
+        </a:solidFill>
+      </p:bgPr>
+    </p:bg>
+    <p:spTree>
+      <p:nvGrpSpPr>
+        <p:cNvPr id="1" name=""/>
+        <p:cNvGrpSpPr/>
+        <p:nvPr/>
+      </p:nvGrpSpPr>
+      <p:grpSpPr>
+        <a:xfrm>
+          <a:off x="0" y="0"/>
+          <a:ext cx="0" cy="0"/>
+          <a:chOff x="0" y="0"/>
+          <a:chExt cx="0" cy="0"/>
+        </a:xfrm>
+      </p:grpSpPr>
+      <p:sp>
+        <p:nvSpPr>
+          <p:cNvPr id="2" name="Text 0"/>
+          <p:cNvSpPr txBox="1"/>
+          <p:nvPr/>
+        </p:nvSpPr>
+        <p:spPr>
+          <a:xfrm>
+            <a:off x="457200" y="292608"/>
+            <a:ext cx="2743200" cy="219456"/>
+          </a:xfrm>
+          <a:prstGeom prst="rect">
+            <a:avLst/>
+          </a:prstGeom>
+          <a:noFill/>
+          <a:ln/>
+        </p:spPr>
+        <p:txBody>
+          <a:bodyPr wrap="square" lIns="0" tIns="0" rIns="0" bIns="0" rtlCol="0" anchor="t"/>
+          <a:lstStyle/>
+          <a:p>
+            <a:pPr indent="0" marL="0">
+              <a:buNone/>
+            </a:pPr>
+            <a:r>
+              <a:rPr lang="en-US" sz="1000" b="1" spc="200" kern="0" dirty="0">
+                <a:solidFill>
+                  <a:srgbClr val="C8352B"/>
+                </a:solidFill>
+                <a:latin typeface="Calibri" pitchFamily="34" charset="0"/>
+                <a:ea typeface="Calibri" pitchFamily="34" charset="-122"/>
+                <a:cs typeface="Calibri" pitchFamily="34" charset="-120"/>
+              </a:rPr>
+              <a:t>ANEXO</a:t>
+            </a:r>
+            <a:endParaRPr lang="en-US" sz="1000" dirty="0"/>
+          </a:p>
+        </p:txBody>
+      </p:sp>
+      <p:sp>
+        <p:nvSpPr>
+          <p:cNvPr id="3" name="Text 1"/>
+          <p:cNvSpPr txBox="1"/>
+          <p:nvPr/>
+        </p:nvSpPr>
+        <p:spPr>
+          <a:xfrm>
+            <a:off x="457200" y="512064"/>
+            <a:ext cx="8229600" cy="411480"/>
+          </a:xfrm>
+          <a:prstGeom prst="rect">
+            <a:avLst/>
+          </a:prstGeom>
+          <a:noFill/>
+          <a:ln/>
+        </p:spPr>
+        <p:txBody>
+          <a:bodyPr wrap="square" lIns="0" tIns="0" rIns="0" bIns="0" rtlCol="0" anchor="t"/>
+          <a:lstStyle/>
+          <a:p>
+            <a:pPr indent="0" marL="0">
+              <a:buNone/>
+            </a:pPr>
+            <a:r>
+              <a:rPr lang="en-US" sz="2300" b="1" dirty="0">
+                <a:solidFill>
+                  <a:srgbClr val="2B1B17"/>
+                </a:solidFill>
+                <a:latin typeface="Cambria" pitchFamily="34" charset="0"/>
+                <a:ea typeface="Cambria" pitchFamily="34" charset="-122"/>
+                <a:cs typeface="Cambria" pitchFamily="34" charset="-120"/>
+              </a:rPr>
+              <a:t>CT-05 — Gestão de insumos e estoque</a:t>
+            </a:r>
+            <a:endParaRPr lang="en-US" sz="2300" dirty="0"/>
+          </a:p>
+        </p:txBody>
+      </p:sp>
+      <p:sp>
+        <p:nvSpPr>
+          <p:cNvPr id="4" name="Text 2"/>
+          <p:cNvSpPr txBox="1"/>
+          <p:nvPr/>
+        </p:nvSpPr>
+        <p:spPr>
+          <a:xfrm>
+            <a:off x="457200" y="914400"/>
+            <a:ext cx="8229600" cy="237744"/>
+          </a:xfrm>
+          <a:prstGeom prst="rect">
+            <a:avLst/>
+          </a:prstGeom>
+          <a:noFill/>
+          <a:ln/>
+        </p:spPr>
+        <p:txBody>
+          <a:bodyPr wrap="square" lIns="0" tIns="0" rIns="0" bIns="0" rtlCol="0" anchor="t"/>
+          <a:lstStyle/>
+          <a:p>
+            <a:pPr indent="0" marL="0">
+              <a:buNone/>
+            </a:pPr>
+            <a:r>
+              <a:rPr lang="en-US" sz="1100" dirty="0">
+                <a:solidFill>
+                  <a:srgbClr val="6B5B55"/>
+                </a:solidFill>
+                <a:latin typeface="Calibri" pitchFamily="34" charset="0"/>
+                <a:ea typeface="Calibri" pitchFamily="34" charset="-122"/>
+                <a:cs typeface="Calibri" pitchFamily="34" charset="-120"/>
+              </a:rPr>
+              <a:t>Felipe Paixão  ·  executado em 21/09  ·  5 passos PASSOU, 3 FALHOU</a:t>
+            </a:r>
+            <a:endParaRPr lang="en-US" sz="1100" dirty="0"/>
+          </a:p>
+        </p:txBody>
+      </p:sp>
+      <p:pic>
+        <p:nvPicPr>
+          <p:cNvPr id="5" name="Image 0" descr="C:\Users\felip\source\repos\trabalho-qualidade-e-teste-de-software\docs\entrega-1\apresentacao\anexos\caso-05.png">    </p:cNvPr>
+          <p:cNvPicPr>
+            <a:picLocks noChangeAspect="1"/>
+          </p:cNvPicPr>
+          <p:nvPr/>
+        </p:nvPicPr>
+        <p:blipFill>
+          <a:blip r:embed="rId1"/>
+          <a:stretch>
+            <a:fillRect/>
+          </a:stretch>
+        </p:blipFill>
+        <p:spPr>
+          <a:xfrm>
+            <a:off x="457200" y="1207008"/>
+            <a:ext cx="3886200" cy="2006635"/>
+          </a:xfrm>
+          <a:prstGeom prst="rect">
+            <a:avLst/>
+          </a:prstGeom>
+        </p:spPr>
+      </p:pic>
+      <p:pic>
+        <p:nvPicPr>
+          <p:cNvPr id="6" name="Image 1" descr="C:\Users\felip\source\repos\trabalho-qualidade-e-teste-de-software\docs\entrega-1\apresentacao\anexos\tela-05.png">    </p:cNvPr>
+          <p:cNvPicPr>
+            <a:picLocks noChangeAspect="1"/>
+          </p:cNvPicPr>
+          <p:nvPr/>
+        </p:nvPicPr>
+        <p:blipFill>
+          <a:blip r:embed="rId2"/>
+          <a:stretch>
+            <a:fillRect/>
+          </a:stretch>
+        </p:blipFill>
+        <p:spPr>
+          <a:xfrm>
+            <a:off x="4617720" y="1207008"/>
+            <a:ext cx="4069080" cy="2289782"/>
+          </a:xfrm>
+          <a:prstGeom prst="rect">
+            <a:avLst/>
+          </a:prstGeom>
+        </p:spPr>
+      </p:pic>
+      <p:sp>
+        <p:nvSpPr>
+          <p:cNvPr id="7" name="Text 3"/>
+          <p:cNvSpPr txBox="1"/>
+          <p:nvPr/>
+        </p:nvSpPr>
+        <p:spPr>
+          <a:xfrm>
+            <a:off x="4617720" y="3566160"/>
+            <a:ext cx="4069080" cy="457200"/>
+          </a:xfrm>
+          <a:prstGeom prst="rect">
+            <a:avLst/>
+          </a:prstGeom>
+          <a:noFill/>
+          <a:ln/>
+        </p:spPr>
+        <p:txBody>
+          <a:bodyPr wrap="square" lIns="0" tIns="0" rIns="0" bIns="0" rtlCol="0" anchor="t"/>
+          <a:lstStyle/>
+          <a:p>
+            <a:pPr indent="0" marL="0">
+              <a:buNone/>
+            </a:pPr>
+            <a:r>
+              <a:rPr lang="en-US" sz="1050" dirty="0">
+                <a:solidFill>
+                  <a:srgbClr val="6B5B55"/>
+                </a:solidFill>
+                <a:latin typeface="Calibri" pitchFamily="34" charset="0"/>
+                <a:ea typeface="Calibri" pitchFamily="34" charset="-122"/>
+                <a:cs typeface="Calibri" pitchFamily="34" charset="-120"/>
+              </a:rPr>
+              <a:t>Painel de estoque: insumos com quantidade, preço de compra e de venda</a:t>
+            </a:r>
+            <a:endParaRPr lang="en-US" sz="1050" dirty="0"/>
+          </a:p>
+        </p:txBody>
+      </p:sp>
+      <p:sp>
+        <p:nvSpPr>
+          <p:cNvPr id="8" name="Text 4"/>
+          <p:cNvSpPr txBox="1"/>
+          <p:nvPr/>
+        </p:nvSpPr>
+        <p:spPr>
+          <a:xfrm>
+            <a:off x="457200" y="4114800"/>
+            <a:ext cx="8229600" cy="411480"/>
+          </a:xfrm>
+          <a:prstGeom prst="rect">
+            <a:avLst/>
+          </a:prstGeom>
+          <a:noFill/>
+          <a:ln/>
+        </p:spPr>
+        <p:txBody>
+          <a:bodyPr wrap="square" lIns="0" tIns="0" rIns="0" bIns="0" rtlCol="0" anchor="t"/>
+          <a:lstStyle/>
+          <a:p>
+            <a:pPr indent="0" marL="0">
+              <a:buNone/>
+            </a:pPr>
+            <a:r>
+              <a:rPr lang="en-US" sz="1250" dirty="0">
+                <a:solidFill>
+                  <a:srgbClr val="2B1B17"/>
+                </a:solidFill>
+                <a:latin typeface="Calibri" pitchFamily="34" charset="0"/>
+                <a:ea typeface="Calibri" pitchFamily="34" charset="-122"/>
+                <a:cs typeface="Calibri" pitchFamily="34" charset="-120"/>
+              </a:rPr>
+              <a:t>Quantidade negativa aceita no cadastro e na alteração; remoção de insumo em uso dá HTTP 500.</a:t>
+            </a:r>
+            <a:endParaRPr lang="en-US" sz="1250" dirty="0"/>
+          </a:p>
+        </p:txBody>
+      </p:sp>
+      <p:sp>
+        <p:nvSpPr>
+          <p:cNvPr id="9" name="Text 5"/>
+          <p:cNvSpPr txBox="1"/>
+          <p:nvPr/>
+        </p:nvSpPr>
+        <p:spPr>
+          <a:xfrm>
+            <a:off x="457200" y="4617720"/>
+            <a:ext cx="8229600" cy="274320"/>
+          </a:xfrm>
+          <a:prstGeom prst="rect">
+            <a:avLst/>
+          </a:prstGeom>
+          <a:noFill/>
+          <a:ln/>
+        </p:spPr>
+        <p:txBody>
+          <a:bodyPr wrap="square" lIns="0" tIns="0" rIns="0" bIns="0" rtlCol="0" anchor="t"/>
+          <a:lstStyle/>
+          <a:p>
+            <a:pPr indent="0" marL="0">
+              <a:buNone/>
+            </a:pPr>
+            <a:r>
+              <a:rPr lang="en-US" sz="1100" dirty="0">
+                <a:solidFill>
+                  <a:srgbClr val="2B1B17"/>
+                </a:solidFill>
+                <a:latin typeface="Calibri" pitchFamily="34" charset="0"/>
+                <a:ea typeface="Calibri" pitchFamily="34" charset="-122"/>
+                <a:cs typeface="Calibri" pitchFamily="34" charset="-120"/>
+              </a:rPr>
+              <a:t>Caso: </a:t>
+            </a:r>
+            <a:pPr indent="0" marL="0">
+              <a:buNone/>
+            </a:pPr>
+            <a:r>
+              <a:rPr lang="en-US" sz="1100" u="sng" dirty="0">
+                <a:solidFill>
+                  <a:srgbClr val="C8352B"/>
+                </a:solidFill>
+                <a:latin typeface="Calibri" pitchFamily="34" charset="0"/>
+                <a:ea typeface="Calibri" pitchFamily="34" charset="-122"/>
+                <a:cs typeface="Calibri" pitchFamily="34" charset="-120"/>
+                <a:hlinkClick r:id="rId3" invalidUrl="" action="" tgtFrame="" tooltip="Issue #10" history="1" highlightClick="0" endSnd="0">
+                  <a:extLst>
+                    <a:ext uri="{A12FA001-AC4F-418D-AE19-62706E023703}">
+                      <ahyp:hlinkClr xmlns:ahyp="http://schemas.microsoft.com/office/drawing/2018/hyperlinkcolor" val="tx"/>
+                    </a:ext>
+                  </a:extLst>
+                </a:hlinkClick>
+              </a:rPr>
+              <a:t>#10</a:t>
+            </a:r>
+            <a:pPr indent="0" marL="0">
+              <a:buNone/>
+            </a:pPr>
+            <a:r>
+              <a:rPr lang="en-US" sz="1100" dirty="0">
+                <a:solidFill>
+                  <a:srgbClr val="2B1B17"/>
+                </a:solidFill>
+                <a:latin typeface="Calibri" pitchFamily="34" charset="0"/>
+                <a:ea typeface="Calibri" pitchFamily="34" charset="-122"/>
+                <a:cs typeface="Calibri" pitchFamily="34" charset="-120"/>
+              </a:rPr>
+              <a:t> · defeito: </a:t>
+            </a:r>
+            <a:pPr indent="0" marL="0">
+              <a:buNone/>
+            </a:pPr>
+            <a:r>
+              <a:rPr lang="en-US" sz="1100" u="sng" dirty="0">
+                <a:solidFill>
+                  <a:srgbClr val="C8352B"/>
+                </a:solidFill>
+                <a:latin typeface="Calibri" pitchFamily="34" charset="0"/>
+                <a:ea typeface="Calibri" pitchFamily="34" charset="-122"/>
+                <a:cs typeface="Calibri" pitchFamily="34" charset="-120"/>
+                <a:hlinkClick r:id="rId4" invalidUrl="" action="" tgtFrame="" tooltip="Issue #25" history="1" highlightClick="0" endSnd="0">
+                  <a:extLst>
+                    <a:ext uri="{A12FA001-AC4F-418D-AE19-62706E023703}">
+                      <ahyp:hlinkClr xmlns:ahyp="http://schemas.microsoft.com/office/drawing/2018/hyperlinkcolor" val="tx"/>
+                    </a:ext>
+                  </a:extLst>
+                </a:hlinkClick>
+              </a:rPr>
+              <a:t>#25</a:t>
+            </a:r>
+            <a:endParaRPr lang="en-US" sz="1100" dirty="0"/>
           </a:p>
         </p:txBody>
       </p:sp>
@@ -6750,9 +9037,316 @@
                 <a:ea typeface="Calibri" pitchFamily="34" charset="-122"/>
                 <a:cs typeface="Calibri" pitchFamily="34" charset="-120"/>
               </a:rPr>
-              <a:t>ValidadorCookieTest · ValidadorCookieLimitesTest · issues #1 e #6</a:t>
+              <a:t>ValidadorCookieTest · ValidadorCookieLimitesTest · issues </a:t>
+            </a:r>
+            <a:pPr indent="0" marL="0">
+              <a:buNone/>
+            </a:pPr>
+            <a:r>
+              <a:rPr lang="en-US" sz="850" u="sng" dirty="0">
+                <a:solidFill>
+                  <a:srgbClr val="C8352B"/>
+                </a:solidFill>
+                <a:latin typeface="Calibri" pitchFamily="34" charset="0"/>
+                <a:ea typeface="Calibri" pitchFamily="34" charset="-122"/>
+                <a:cs typeface="Calibri" pitchFamily="34" charset="-120"/>
+                <a:hlinkClick r:id="rId1" invalidUrl="" action="" tgtFrame="" tooltip="Issue #1" history="1" highlightClick="0" endSnd="0">
+                  <a:extLst>
+                    <a:ext uri="{A12FA001-AC4F-418D-AE19-62706E023703}">
+                      <ahyp:hlinkClr xmlns:ahyp="http://schemas.microsoft.com/office/drawing/2018/hyperlinkcolor" val="tx"/>
+                    </a:ext>
+                  </a:extLst>
+                </a:hlinkClick>
+              </a:rPr>
+              <a:t>#1</a:t>
+            </a:r>
+            <a:pPr indent="0" marL="0">
+              <a:buNone/>
+            </a:pPr>
+            <a:r>
+              <a:rPr lang="en-US" sz="850" dirty="0">
+                <a:solidFill>
+                  <a:srgbClr val="6B5B55"/>
+                </a:solidFill>
+                <a:latin typeface="Calibri" pitchFamily="34" charset="0"/>
+                <a:ea typeface="Calibri" pitchFamily="34" charset="-122"/>
+                <a:cs typeface="Calibri" pitchFamily="34" charset="-120"/>
+              </a:rPr>
+              <a:t> e </a:t>
+            </a:r>
+            <a:pPr indent="0" marL="0">
+              <a:buNone/>
+            </a:pPr>
+            <a:r>
+              <a:rPr lang="en-US" sz="850" u="sng" dirty="0">
+                <a:solidFill>
+                  <a:srgbClr val="C8352B"/>
+                </a:solidFill>
+                <a:latin typeface="Calibri" pitchFamily="34" charset="0"/>
+                <a:ea typeface="Calibri" pitchFamily="34" charset="-122"/>
+                <a:cs typeface="Calibri" pitchFamily="34" charset="-120"/>
+                <a:hlinkClick r:id="rId2" invalidUrl="" action="" tgtFrame="" tooltip="Issue #6" history="1" highlightClick="0" endSnd="0">
+                  <a:extLst>
+                    <a:ext uri="{A12FA001-AC4F-418D-AE19-62706E023703}">
+                      <ahyp:hlinkClr xmlns:ahyp="http://schemas.microsoft.com/office/drawing/2018/hyperlinkcolor" val="tx"/>
+                    </a:ext>
+                  </a:extLst>
+                </a:hlinkClick>
+              </a:rPr>
+              <a:t>#6</a:t>
             </a:r>
             <a:endParaRPr lang="en-US" sz="850" dirty="0"/>
+          </a:p>
+        </p:txBody>
+      </p:sp>
+    </p:spTree>
+  </p:cSld>
+  <p:clrMapOvr>
+    <a:masterClrMapping/>
+  </p:clrMapOvr>
+</p:sld>
+</file>
+
+<file path=ppt/slides/slide20.xml><?xml version="1.0" encoding="utf-8"?>
+<p:sld xmlns:a="http://schemas.openxmlformats.org/drawingml/2006/main" xmlns:r="http://schemas.openxmlformats.org/officeDocument/2006/relationships" xmlns:p="http://schemas.openxmlformats.org/presentationml/2006/main">
+  <p:cSld name="Slide 20">
+    <p:bg>
+      <p:bgPr>
+        <a:solidFill>
+          <a:srgbClr val="FFFFFF"/>
+        </a:solidFill>
+      </p:bgPr>
+    </p:bg>
+    <p:spTree>
+      <p:nvGrpSpPr>
+        <p:cNvPr id="1" name=""/>
+        <p:cNvGrpSpPr/>
+        <p:nvPr/>
+      </p:nvGrpSpPr>
+      <p:grpSpPr>
+        <a:xfrm>
+          <a:off x="0" y="0"/>
+          <a:ext cx="0" cy="0"/>
+          <a:chOff x="0" y="0"/>
+          <a:chExt cx="0" cy="0"/>
+        </a:xfrm>
+      </p:grpSpPr>
+      <p:sp>
+        <p:nvSpPr>
+          <p:cNvPr id="2" name="Text 0"/>
+          <p:cNvSpPr txBox="1"/>
+          <p:nvPr/>
+        </p:nvSpPr>
+        <p:spPr>
+          <a:xfrm>
+            <a:off x="457200" y="292608"/>
+            <a:ext cx="2743200" cy="219456"/>
+          </a:xfrm>
+          <a:prstGeom prst="rect">
+            <a:avLst/>
+          </a:prstGeom>
+          <a:noFill/>
+          <a:ln/>
+        </p:spPr>
+        <p:txBody>
+          <a:bodyPr wrap="square" lIns="0" tIns="0" rIns="0" bIns="0" rtlCol="0" anchor="t"/>
+          <a:lstStyle/>
+          <a:p>
+            <a:pPr indent="0" marL="0">
+              <a:buNone/>
+            </a:pPr>
+            <a:r>
+              <a:rPr lang="en-US" sz="1000" b="1" spc="200" kern="0" dirty="0">
+                <a:solidFill>
+                  <a:srgbClr val="C8352B"/>
+                </a:solidFill>
+                <a:latin typeface="Calibri" pitchFamily="34" charset="0"/>
+                <a:ea typeface="Calibri" pitchFamily="34" charset="-122"/>
+                <a:cs typeface="Calibri" pitchFamily="34" charset="-120"/>
+              </a:rPr>
+              <a:t>ANEXO</a:t>
+            </a:r>
+            <a:endParaRPr lang="en-US" sz="1000" dirty="0"/>
+          </a:p>
+        </p:txBody>
+      </p:sp>
+      <p:sp>
+        <p:nvSpPr>
+          <p:cNvPr id="3" name="Text 1"/>
+          <p:cNvSpPr txBox="1"/>
+          <p:nvPr/>
+        </p:nvSpPr>
+        <p:spPr>
+          <a:xfrm>
+            <a:off x="457200" y="512064"/>
+            <a:ext cx="8229600" cy="411480"/>
+          </a:xfrm>
+          <a:prstGeom prst="rect">
+            <a:avLst/>
+          </a:prstGeom>
+          <a:noFill/>
+          <a:ln/>
+        </p:spPr>
+        <p:txBody>
+          <a:bodyPr wrap="square" lIns="0" tIns="0" rIns="0" bIns="0" rtlCol="0" anchor="t"/>
+          <a:lstStyle/>
+          <a:p>
+            <a:pPr indent="0" marL="0">
+              <a:buNone/>
+            </a:pPr>
+            <a:r>
+              <a:rPr lang="en-US" sz="2300" b="1" dirty="0">
+                <a:solidFill>
+                  <a:srgbClr val="2B1B17"/>
+                </a:solidFill>
+                <a:latin typeface="Cambria" pitchFamily="34" charset="0"/>
+                <a:ea typeface="Cambria" pitchFamily="34" charset="-122"/>
+                <a:cs typeface="Cambria" pitchFamily="34" charset="-120"/>
+              </a:rPr>
+              <a:t>Execução das suítes</a:t>
+            </a:r>
+            <a:endParaRPr lang="en-US" sz="2300" dirty="0"/>
+          </a:p>
+        </p:txBody>
+      </p:sp>
+      <p:sp>
+        <p:nvSpPr>
+          <p:cNvPr id="4" name="Text 2"/>
+          <p:cNvSpPr txBox="1"/>
+          <p:nvPr/>
+        </p:nvSpPr>
+        <p:spPr>
+          <a:xfrm>
+            <a:off x="457200" y="914400"/>
+            <a:ext cx="8229600" cy="237744"/>
+          </a:xfrm>
+          <a:prstGeom prst="rect">
+            <a:avLst/>
+          </a:prstGeom>
+          <a:noFill/>
+          <a:ln/>
+        </p:spPr>
+        <p:txBody>
+          <a:bodyPr wrap="square" lIns="0" tIns="0" rIns="0" bIns="0" rtlCol="0" anchor="t"/>
+          <a:lstStyle/>
+          <a:p>
+            <a:pPr indent="0" marL="0">
+              <a:buNone/>
+            </a:pPr>
+            <a:r>
+              <a:rPr lang="en-US" sz="1100" dirty="0">
+                <a:solidFill>
+                  <a:srgbClr val="6B5B55"/>
+                </a:solidFill>
+                <a:latin typeface="Calibri" pitchFamily="34" charset="0"/>
+                <a:ea typeface="Calibri" pitchFamily="34" charset="-122"/>
+                <a:cs typeface="Calibri" pitchFamily="34" charset="-120"/>
+              </a:rPr>
+              <a:t>Saída real do Maven, nas duas suítes</a:t>
+            </a:r>
+            <a:endParaRPr lang="en-US" sz="1100" dirty="0"/>
+          </a:p>
+        </p:txBody>
+      </p:sp>
+      <p:pic>
+        <p:nvPicPr>
+          <p:cNvPr id="5" name="Image 0" descr="C:\Users\felip\source\repos\trabalho-qualidade-e-teste-de-software\docs\entrega-1\apresentacao\anexos\execucao-maven.png">    </p:cNvPr>
+          <p:cNvPicPr>
+            <a:picLocks noChangeAspect="1"/>
+          </p:cNvPicPr>
+          <p:nvPr/>
+        </p:nvPicPr>
+        <p:blipFill>
+          <a:blip r:embed="rId1"/>
+          <a:stretch>
+            <a:fillRect/>
+          </a:stretch>
+        </p:blipFill>
+        <p:spPr>
+          <a:xfrm>
+            <a:off x="457200" y="1234440"/>
+            <a:ext cx="8229600" cy="2495427"/>
+          </a:xfrm>
+          <a:prstGeom prst="rect">
+            <a:avLst/>
+          </a:prstGeom>
+        </p:spPr>
+      </p:pic>
+      <p:sp>
+        <p:nvSpPr>
+          <p:cNvPr id="6" name="Text 3"/>
+          <p:cNvSpPr txBox="1"/>
+          <p:nvPr/>
+        </p:nvSpPr>
+        <p:spPr>
+          <a:xfrm>
+            <a:off x="457200" y="3840480"/>
+            <a:ext cx="8229600" cy="548640"/>
+          </a:xfrm>
+          <a:prstGeom prst="rect">
+            <a:avLst/>
+          </a:prstGeom>
+          <a:noFill/>
+          <a:ln/>
+        </p:spPr>
+        <p:txBody>
+          <a:bodyPr wrap="square" lIns="0" tIns="0" rIns="0" bIns="0" rtlCol="0" anchor="t"/>
+          <a:lstStyle/>
+          <a:p>
+            <a:pPr indent="0" marL="0">
+              <a:buNone/>
+            </a:pPr>
+            <a:r>
+              <a:rPr lang="en-US" sz="1250" dirty="0">
+                <a:solidFill>
+                  <a:srgbClr val="2B1B17"/>
+                </a:solidFill>
+                <a:latin typeface="Calibri" pitchFamily="34" charset="0"/>
+                <a:ea typeface="Calibri" pitchFamily="34" charset="-122"/>
+                <a:cs typeface="Calibri" pitchFamily="34" charset="-120"/>
+              </a:rPr>
+              <a:t>A suíte padrão fica verde. A de defeitos fica vermelha de propósito: cada teste ali descreve o comportamento correto e falha enquanto o defeito existir.</a:t>
+            </a:r>
+            <a:endParaRPr lang="en-US" sz="1250" dirty="0"/>
+          </a:p>
+        </p:txBody>
+      </p:sp>
+      <p:sp>
+        <p:nvSpPr>
+          <p:cNvPr id="7" name="Text 4"/>
+          <p:cNvSpPr txBox="1"/>
+          <p:nvPr/>
+        </p:nvSpPr>
+        <p:spPr>
+          <a:xfrm>
+            <a:off x="457200" y="4526280"/>
+            <a:ext cx="8229600" cy="274320"/>
+          </a:xfrm>
+          <a:prstGeom prst="rect">
+            <a:avLst/>
+          </a:prstGeom>
+          <a:noFill/>
+          <a:ln/>
+        </p:spPr>
+        <p:txBody>
+          <a:bodyPr wrap="square" lIns="0" tIns="0" rIns="0" bIns="0" rtlCol="0" anchor="t"/>
+          <a:lstStyle/>
+          <a:p>
+            <a:pPr indent="0" marL="0">
+              <a:buNone/>
+            </a:pPr>
+            <a:r>
+              <a:rPr lang="en-US" sz="1250" b="1" dirty="0">
+                <a:solidFill>
+                  <a:srgbClr val="2B1B17"/>
+                </a:solidFill>
+                <a:latin typeface="Calibri" pitchFamily="34" charset="0"/>
+                <a:ea typeface="Calibri" pitchFamily="34" charset="-122"/>
+                <a:cs typeface="Calibri" pitchFamily="34" charset="-120"/>
+              </a:rPr>
+              <a:t>Reproduzir:  mvn clean test   ·   mvn test -Pdefeitos</a:t>
+            </a:r>
+            <a:endParaRPr lang="en-US" sz="1250" dirty="0"/>
           </a:p>
         </p:txBody>
       </p:sp>
@@ -7519,7 +10113,63 @@
                 <a:ea typeface="Calibri" pitchFamily="34" charset="-122"/>
                 <a:cs typeface="Calibri" pitchFamily="34" charset="-120"/>
               </a:rPr>
-              <a:t>Sem testes de integração nesta entrega  ·  ValidadorCookieTest · ValidadorCookieLimitesTest · issues #1 e #6</a:t>
+              <a:t>Sem testes de integração nesta entrega  ·  ValidadorCookieTest · ValidadorCookieLimitesTest · issues </a:t>
+            </a:r>
+            <a:pPr indent="0" marL="0">
+              <a:buNone/>
+            </a:pPr>
+            <a:r>
+              <a:rPr lang="en-US" sz="850" u="sng" dirty="0">
+                <a:solidFill>
+                  <a:srgbClr val="C8352B"/>
+                </a:solidFill>
+                <a:latin typeface="Calibri" pitchFamily="34" charset="0"/>
+                <a:ea typeface="Calibri" pitchFamily="34" charset="-122"/>
+                <a:cs typeface="Calibri" pitchFamily="34" charset="-120"/>
+                <a:hlinkClick r:id="rId1" invalidUrl="" action="" tgtFrame="" tooltip="Issue #1" history="1" highlightClick="0" endSnd="0">
+                  <a:extLst>
+                    <a:ext uri="{A12FA001-AC4F-418D-AE19-62706E023703}">
+                      <ahyp:hlinkClr xmlns:ahyp="http://schemas.microsoft.com/office/drawing/2018/hyperlinkcolor" val="tx"/>
+                    </a:ext>
+                  </a:extLst>
+                </a:hlinkClick>
+              </a:rPr>
+              <a:t>#1</a:t>
+            </a:r>
+            <a:pPr indent="0" marL="0">
+              <a:buNone/>
+            </a:pPr>
+            <a:r>
+              <a:rPr lang="en-US" sz="850" dirty="0">
+                <a:solidFill>
+                  <a:srgbClr val="6B5B55"/>
+                </a:solidFill>
+                <a:latin typeface="Calibri" pitchFamily="34" charset="0"/>
+                <a:ea typeface="Calibri" pitchFamily="34" charset="-122"/>
+                <a:cs typeface="Calibri" pitchFamily="34" charset="-120"/>
+              </a:rPr>
+              <a:t> e </a:t>
+            </a:r>
+            <a:pPr indent="0" marL="0">
+              <a:buNone/>
+            </a:pPr>
+            <a:r>
+              <a:rPr lang="en-US" sz="850" u="sng" dirty="0">
+                <a:solidFill>
+                  <a:srgbClr val="C8352B"/>
+                </a:solidFill>
+                <a:latin typeface="Calibri" pitchFamily="34" charset="0"/>
+                <a:ea typeface="Calibri" pitchFamily="34" charset="-122"/>
+                <a:cs typeface="Calibri" pitchFamily="34" charset="-120"/>
+                <a:hlinkClick r:id="rId2" invalidUrl="" action="" tgtFrame="" tooltip="Issue #6" history="1" highlightClick="0" endSnd="0">
+                  <a:extLst>
+                    <a:ext uri="{A12FA001-AC4F-418D-AE19-62706E023703}">
+                      <ahyp:hlinkClr xmlns:ahyp="http://schemas.microsoft.com/office/drawing/2018/hyperlinkcolor" val="tx"/>
+                    </a:ext>
+                  </a:extLst>
+                </a:hlinkClick>
+              </a:rPr>
+              <a:t>#6</a:t>
             </a:r>
             <a:endParaRPr lang="en-US" sz="850" dirty="0"/>
           </a:p>
@@ -8180,7 +10830,77 @@
                 <a:ea typeface="Calibri" pitchFamily="34" charset="-122"/>
                 <a:cs typeface="Calibri" pitchFamily="34" charset="-120"/>
               </a:rPr>
-              <a:t>ComprarTest · ComprarRegrasTest · issues #2 e #7 · DEF-02, DEF-03</a:t>
+              <a:t>ComprarTest · ComprarRegrasTest · issues </a:t>
+            </a:r>
+            <a:pPr indent="0" marL="0">
+              <a:buNone/>
+            </a:pPr>
+            <a:r>
+              <a:rPr lang="en-US" sz="850" u="sng" dirty="0">
+                <a:solidFill>
+                  <a:srgbClr val="C8352B"/>
+                </a:solidFill>
+                <a:latin typeface="Calibri" pitchFamily="34" charset="0"/>
+                <a:ea typeface="Calibri" pitchFamily="34" charset="-122"/>
+                <a:cs typeface="Calibri" pitchFamily="34" charset="-120"/>
+                <a:hlinkClick r:id="rId1" invalidUrl="" action="" tgtFrame="" tooltip="Issue #2" history="1" highlightClick="0" endSnd="0">
+                  <a:extLst>
+                    <a:ext uri="{A12FA001-AC4F-418D-AE19-62706E023703}">
+                      <ahyp:hlinkClr xmlns:ahyp="http://schemas.microsoft.com/office/drawing/2018/hyperlinkcolor" val="tx"/>
+                    </a:ext>
+                  </a:extLst>
+                </a:hlinkClick>
+              </a:rPr>
+              <a:t>#2</a:t>
+            </a:r>
+            <a:pPr indent="0" marL="0">
+              <a:buNone/>
+            </a:pPr>
+            <a:r>
+              <a:rPr lang="en-US" sz="850" dirty="0">
+                <a:solidFill>
+                  <a:srgbClr val="6B5B55"/>
+                </a:solidFill>
+                <a:latin typeface="Calibri" pitchFamily="34" charset="0"/>
+                <a:ea typeface="Calibri" pitchFamily="34" charset="-122"/>
+                <a:cs typeface="Calibri" pitchFamily="34" charset="-120"/>
+              </a:rPr>
+              <a:t> e </a:t>
+            </a:r>
+            <a:pPr indent="0" marL="0">
+              <a:buNone/>
+            </a:pPr>
+            <a:r>
+              <a:rPr lang="en-US" sz="850" u="sng" dirty="0">
+                <a:solidFill>
+                  <a:srgbClr val="C8352B"/>
+                </a:solidFill>
+                <a:latin typeface="Calibri" pitchFamily="34" charset="0"/>
+                <a:ea typeface="Calibri" pitchFamily="34" charset="-122"/>
+                <a:cs typeface="Calibri" pitchFamily="34" charset="-120"/>
+                <a:hlinkClick r:id="rId2" invalidUrl="" action="" tgtFrame="" tooltip="Issue #7" history="1" highlightClick="0" endSnd="0">
+                  <a:extLst>
+                    <a:ext uri="{A12FA001-AC4F-418D-AE19-62706E023703}">
+                      <ahyp:hlinkClr xmlns:ahyp="http://schemas.microsoft.com/office/drawing/2018/hyperlinkcolor" val="tx"/>
+                    </a:ext>
+                  </a:extLst>
+                </a:hlinkClick>
+              </a:rPr>
+              <a:t>#7</a:t>
+            </a:r>
+            <a:pPr indent="0" marL="0">
+              <a:buNone/>
+            </a:pPr>
+            <a:r>
+              <a:rPr lang="en-US" sz="850" dirty="0">
+                <a:solidFill>
+                  <a:srgbClr val="6B5B55"/>
+                </a:solidFill>
+                <a:latin typeface="Calibri" pitchFamily="34" charset="0"/>
+                <a:ea typeface="Calibri" pitchFamily="34" charset="-122"/>
+                <a:cs typeface="Calibri" pitchFamily="34" charset="-120"/>
+              </a:rPr>
+              <a:t> · DEF-02, DEF-03</a:t>
             </a:r>
             <a:endParaRPr lang="en-US" sz="850" dirty="0"/>
           </a:p>
@@ -8832,7 +11552,77 @@
                 <a:ea typeface="Calibri" pitchFamily="34" charset="-122"/>
                 <a:cs typeface="Calibri" pitchFamily="34" charset="-120"/>
               </a:rPr>
-              <a:t>ISSUES #21 E #22 · DEF-02 E DEF-03</a:t>
+              <a:t>ISSUES </a:t>
+            </a:r>
+            <a:pPr indent="0" marL="0">
+              <a:buNone/>
+            </a:pPr>
+            <a:r>
+              <a:rPr lang="en-US" sz="950" b="1" u="sng" spc="100" kern="0" dirty="0">
+                <a:solidFill>
+                  <a:srgbClr val="F2A900"/>
+                </a:solidFill>
+                <a:latin typeface="Calibri" pitchFamily="34" charset="0"/>
+                <a:ea typeface="Calibri" pitchFamily="34" charset="-122"/>
+                <a:cs typeface="Calibri" pitchFamily="34" charset="-120"/>
+                <a:hlinkClick r:id="rId1" invalidUrl="" action="" tgtFrame="" tooltip="Issue #21" history="1" highlightClick="0" endSnd="0">
+                  <a:extLst>
+                    <a:ext uri="{A12FA001-AC4F-418D-AE19-62706E023703}">
+                      <ahyp:hlinkClr xmlns:ahyp="http://schemas.microsoft.com/office/drawing/2018/hyperlinkcolor" val="tx"/>
+                    </a:ext>
+                  </a:extLst>
+                </a:hlinkClick>
+              </a:rPr>
+              <a:t>#21</a:t>
+            </a:r>
+            <a:pPr indent="0" marL="0">
+              <a:buNone/>
+            </a:pPr>
+            <a:r>
+              <a:rPr lang="en-US" sz="950" b="1" spc="100" kern="0" dirty="0">
+                <a:solidFill>
+                  <a:srgbClr val="F2A900"/>
+                </a:solidFill>
+                <a:latin typeface="Calibri" pitchFamily="34" charset="0"/>
+                <a:ea typeface="Calibri" pitchFamily="34" charset="-122"/>
+                <a:cs typeface="Calibri" pitchFamily="34" charset="-120"/>
+              </a:rPr>
+              <a:t> E </a:t>
+            </a:r>
+            <a:pPr indent="0" marL="0">
+              <a:buNone/>
+            </a:pPr>
+            <a:r>
+              <a:rPr lang="en-US" sz="950" b="1" u="sng" spc="100" kern="0" dirty="0">
+                <a:solidFill>
+                  <a:srgbClr val="F2A900"/>
+                </a:solidFill>
+                <a:latin typeface="Calibri" pitchFamily="34" charset="0"/>
+                <a:ea typeface="Calibri" pitchFamily="34" charset="-122"/>
+                <a:cs typeface="Calibri" pitchFamily="34" charset="-120"/>
+                <a:hlinkClick r:id="rId2" invalidUrl="" action="" tgtFrame="" tooltip="Issue #22" history="1" highlightClick="0" endSnd="0">
+                  <a:extLst>
+                    <a:ext uri="{A12FA001-AC4F-418D-AE19-62706E023703}">
+                      <ahyp:hlinkClr xmlns:ahyp="http://schemas.microsoft.com/office/drawing/2018/hyperlinkcolor" val="tx"/>
+                    </a:ext>
+                  </a:extLst>
+                </a:hlinkClick>
+              </a:rPr>
+              <a:t>#22</a:t>
+            </a:r>
+            <a:pPr indent="0" marL="0">
+              <a:buNone/>
+            </a:pPr>
+            <a:r>
+              <a:rPr lang="en-US" sz="950" b="1" spc="100" kern="0" dirty="0">
+                <a:solidFill>
+                  <a:srgbClr val="F2A900"/>
+                </a:solidFill>
+                <a:latin typeface="Calibri" pitchFamily="34" charset="0"/>
+                <a:ea typeface="Calibri" pitchFamily="34" charset="-122"/>
+                <a:cs typeface="Calibri" pitchFamily="34" charset="-120"/>
+              </a:rPr>
+              <a:t> · DEF-02 E DEF-03</a:t>
             </a:r>
             <a:endParaRPr lang="en-US" sz="950" dirty="0"/>
           </a:p>
@@ -8949,7 +11739,77 @@
                 <a:ea typeface="Calibri" pitchFamily="34" charset="-122"/>
                 <a:cs typeface="Calibri" pitchFamily="34" charset="-120"/>
               </a:rPr>
-              <a:t>Sem testes de integração nesta entrega  ·  ComprarTest · ComprarRegrasTest · issues #2 e #7 · DEF-02, DEF-03</a:t>
+              <a:t>Sem testes de integração nesta entrega  ·  ComprarTest · ComprarRegrasTest · issues </a:t>
+            </a:r>
+            <a:pPr indent="0" marL="0">
+              <a:buNone/>
+            </a:pPr>
+            <a:r>
+              <a:rPr lang="en-US" sz="850" u="sng" dirty="0">
+                <a:solidFill>
+                  <a:srgbClr val="C8352B"/>
+                </a:solidFill>
+                <a:latin typeface="Calibri" pitchFamily="34" charset="0"/>
+                <a:ea typeface="Calibri" pitchFamily="34" charset="-122"/>
+                <a:cs typeface="Calibri" pitchFamily="34" charset="-120"/>
+                <a:hlinkClick r:id="rId3" invalidUrl="" action="" tgtFrame="" tooltip="Issue #2" history="1" highlightClick="0" endSnd="0">
+                  <a:extLst>
+                    <a:ext uri="{A12FA001-AC4F-418D-AE19-62706E023703}">
+                      <ahyp:hlinkClr xmlns:ahyp="http://schemas.microsoft.com/office/drawing/2018/hyperlinkcolor" val="tx"/>
+                    </a:ext>
+                  </a:extLst>
+                </a:hlinkClick>
+              </a:rPr>
+              <a:t>#2</a:t>
+            </a:r>
+            <a:pPr indent="0" marL="0">
+              <a:buNone/>
+            </a:pPr>
+            <a:r>
+              <a:rPr lang="en-US" sz="850" dirty="0">
+                <a:solidFill>
+                  <a:srgbClr val="6B5B55"/>
+                </a:solidFill>
+                <a:latin typeface="Calibri" pitchFamily="34" charset="0"/>
+                <a:ea typeface="Calibri" pitchFamily="34" charset="-122"/>
+                <a:cs typeface="Calibri" pitchFamily="34" charset="-120"/>
+              </a:rPr>
+              <a:t> e </a:t>
+            </a:r>
+            <a:pPr indent="0" marL="0">
+              <a:buNone/>
+            </a:pPr>
+            <a:r>
+              <a:rPr lang="en-US" sz="850" u="sng" dirty="0">
+                <a:solidFill>
+                  <a:srgbClr val="C8352B"/>
+                </a:solidFill>
+                <a:latin typeface="Calibri" pitchFamily="34" charset="0"/>
+                <a:ea typeface="Calibri" pitchFamily="34" charset="-122"/>
+                <a:cs typeface="Calibri" pitchFamily="34" charset="-120"/>
+                <a:hlinkClick r:id="rId4" invalidUrl="" action="" tgtFrame="" tooltip="Issue #7" history="1" highlightClick="0" endSnd="0">
+                  <a:extLst>
+                    <a:ext uri="{A12FA001-AC4F-418D-AE19-62706E023703}">
+                      <ahyp:hlinkClr xmlns:ahyp="http://schemas.microsoft.com/office/drawing/2018/hyperlinkcolor" val="tx"/>
+                    </a:ext>
+                  </a:extLst>
+                </a:hlinkClick>
+              </a:rPr>
+              <a:t>#7</a:t>
+            </a:r>
+            <a:pPr indent="0" marL="0">
+              <a:buNone/>
+            </a:pPr>
+            <a:r>
+              <a:rPr lang="en-US" sz="850" dirty="0">
+                <a:solidFill>
+                  <a:srgbClr val="6B5B55"/>
+                </a:solidFill>
+                <a:latin typeface="Calibri" pitchFamily="34" charset="0"/>
+                <a:ea typeface="Calibri" pitchFamily="34" charset="-122"/>
+                <a:cs typeface="Calibri" pitchFamily="34" charset="-120"/>
+              </a:rPr>
+              <a:t> · DEF-02, DEF-03</a:t>
             </a:r>
             <a:endParaRPr lang="en-US" sz="850" dirty="0"/>
           </a:p>
@@ -9587,7 +12447,77 @@
                 <a:ea typeface="Calibri" pitchFamily="34" charset="-122"/>
                 <a:cs typeface="Calibri" pitchFamily="34" charset="-120"/>
               </a:rPr>
-              <a:t>DaoClienteTest · CadastroTest · EncryptadorMD5Test · issues #3 e #8 · DEF-04, DEF-05</a:t>
+              <a:t>DaoClienteTest · CadastroTest · EncryptadorMD5Test · issues </a:t>
+            </a:r>
+            <a:pPr indent="0" marL="0">
+              <a:buNone/>
+            </a:pPr>
+            <a:r>
+              <a:rPr lang="en-US" sz="850" u="sng" dirty="0">
+                <a:solidFill>
+                  <a:srgbClr val="C8352B"/>
+                </a:solidFill>
+                <a:latin typeface="Calibri" pitchFamily="34" charset="0"/>
+                <a:ea typeface="Calibri" pitchFamily="34" charset="-122"/>
+                <a:cs typeface="Calibri" pitchFamily="34" charset="-120"/>
+                <a:hlinkClick r:id="rId1" invalidUrl="" action="" tgtFrame="" tooltip="Issue #3" history="1" highlightClick="0" endSnd="0">
+                  <a:extLst>
+                    <a:ext uri="{A12FA001-AC4F-418D-AE19-62706E023703}">
+                      <ahyp:hlinkClr xmlns:ahyp="http://schemas.microsoft.com/office/drawing/2018/hyperlinkcolor" val="tx"/>
+                    </a:ext>
+                  </a:extLst>
+                </a:hlinkClick>
+              </a:rPr>
+              <a:t>#3</a:t>
+            </a:r>
+            <a:pPr indent="0" marL="0">
+              <a:buNone/>
+            </a:pPr>
+            <a:r>
+              <a:rPr lang="en-US" sz="850" dirty="0">
+                <a:solidFill>
+                  <a:srgbClr val="6B5B55"/>
+                </a:solidFill>
+                <a:latin typeface="Calibri" pitchFamily="34" charset="0"/>
+                <a:ea typeface="Calibri" pitchFamily="34" charset="-122"/>
+                <a:cs typeface="Calibri" pitchFamily="34" charset="-120"/>
+              </a:rPr>
+              <a:t> e </a:t>
+            </a:r>
+            <a:pPr indent="0" marL="0">
+              <a:buNone/>
+            </a:pPr>
+            <a:r>
+              <a:rPr lang="en-US" sz="850" u="sng" dirty="0">
+                <a:solidFill>
+                  <a:srgbClr val="C8352B"/>
+                </a:solidFill>
+                <a:latin typeface="Calibri" pitchFamily="34" charset="0"/>
+                <a:ea typeface="Calibri" pitchFamily="34" charset="-122"/>
+                <a:cs typeface="Calibri" pitchFamily="34" charset="-120"/>
+                <a:hlinkClick r:id="rId2" invalidUrl="" action="" tgtFrame="" tooltip="Issue #8" history="1" highlightClick="0" endSnd="0">
+                  <a:extLst>
+                    <a:ext uri="{A12FA001-AC4F-418D-AE19-62706E023703}">
+                      <ahyp:hlinkClr xmlns:ahyp="http://schemas.microsoft.com/office/drawing/2018/hyperlinkcolor" val="tx"/>
+                    </a:ext>
+                  </a:extLst>
+                </a:hlinkClick>
+              </a:rPr>
+              <a:t>#8</a:t>
+            </a:r>
+            <a:pPr indent="0" marL="0">
+              <a:buNone/>
+            </a:pPr>
+            <a:r>
+              <a:rPr lang="en-US" sz="850" dirty="0">
+                <a:solidFill>
+                  <a:srgbClr val="6B5B55"/>
+                </a:solidFill>
+                <a:latin typeface="Calibri" pitchFamily="34" charset="0"/>
+                <a:ea typeface="Calibri" pitchFamily="34" charset="-122"/>
+                <a:cs typeface="Calibri" pitchFamily="34" charset="-120"/>
+              </a:rPr>
+              <a:t> · DEF-04, DEF-05</a:t>
             </a:r>
             <a:endParaRPr lang="en-US" sz="850" dirty="0"/>
           </a:p>
@@ -10239,7 +13169,77 @@
                 <a:ea typeface="Calibri" pitchFamily="34" charset="-122"/>
                 <a:cs typeface="Calibri" pitchFamily="34" charset="-120"/>
               </a:rPr>
-              <a:t>ISSUES #24 E #23 · DEF-05 E DEF-04</a:t>
+              <a:t>ISSUES </a:t>
+            </a:r>
+            <a:pPr indent="0" marL="0">
+              <a:buNone/>
+            </a:pPr>
+            <a:r>
+              <a:rPr lang="en-US" sz="950" b="1" u="sng" spc="100" kern="0" dirty="0">
+                <a:solidFill>
+                  <a:srgbClr val="F2A900"/>
+                </a:solidFill>
+                <a:latin typeface="Calibri" pitchFamily="34" charset="0"/>
+                <a:ea typeface="Calibri" pitchFamily="34" charset="-122"/>
+                <a:cs typeface="Calibri" pitchFamily="34" charset="-120"/>
+                <a:hlinkClick r:id="rId1" invalidUrl="" action="" tgtFrame="" tooltip="Issue #24" history="1" highlightClick="0" endSnd="0">
+                  <a:extLst>
+                    <a:ext uri="{A12FA001-AC4F-418D-AE19-62706E023703}">
+                      <ahyp:hlinkClr xmlns:ahyp="http://schemas.microsoft.com/office/drawing/2018/hyperlinkcolor" val="tx"/>
+                    </a:ext>
+                  </a:extLst>
+                </a:hlinkClick>
+              </a:rPr>
+              <a:t>#24</a:t>
+            </a:r>
+            <a:pPr indent="0" marL="0">
+              <a:buNone/>
+            </a:pPr>
+            <a:r>
+              <a:rPr lang="en-US" sz="950" b="1" spc="100" kern="0" dirty="0">
+                <a:solidFill>
+                  <a:srgbClr val="F2A900"/>
+                </a:solidFill>
+                <a:latin typeface="Calibri" pitchFamily="34" charset="0"/>
+                <a:ea typeface="Calibri" pitchFamily="34" charset="-122"/>
+                <a:cs typeface="Calibri" pitchFamily="34" charset="-120"/>
+              </a:rPr>
+              <a:t> E </a:t>
+            </a:r>
+            <a:pPr indent="0" marL="0">
+              <a:buNone/>
+            </a:pPr>
+            <a:r>
+              <a:rPr lang="en-US" sz="950" b="1" u="sng" spc="100" kern="0" dirty="0">
+                <a:solidFill>
+                  <a:srgbClr val="F2A900"/>
+                </a:solidFill>
+                <a:latin typeface="Calibri" pitchFamily="34" charset="0"/>
+                <a:ea typeface="Calibri" pitchFamily="34" charset="-122"/>
+                <a:cs typeface="Calibri" pitchFamily="34" charset="-120"/>
+                <a:hlinkClick r:id="rId2" invalidUrl="" action="" tgtFrame="" tooltip="Issue #23" history="1" highlightClick="0" endSnd="0">
+                  <a:extLst>
+                    <a:ext uri="{A12FA001-AC4F-418D-AE19-62706E023703}">
+                      <ahyp:hlinkClr xmlns:ahyp="http://schemas.microsoft.com/office/drawing/2018/hyperlinkcolor" val="tx"/>
+                    </a:ext>
+                  </a:extLst>
+                </a:hlinkClick>
+              </a:rPr>
+              <a:t>#23</a:t>
+            </a:r>
+            <a:pPr indent="0" marL="0">
+              <a:buNone/>
+            </a:pPr>
+            <a:r>
+              <a:rPr lang="en-US" sz="950" b="1" spc="100" kern="0" dirty="0">
+                <a:solidFill>
+                  <a:srgbClr val="F2A900"/>
+                </a:solidFill>
+                <a:latin typeface="Calibri" pitchFamily="34" charset="0"/>
+                <a:ea typeface="Calibri" pitchFamily="34" charset="-122"/>
+                <a:cs typeface="Calibri" pitchFamily="34" charset="-120"/>
+              </a:rPr>
+              <a:t> · DEF-05 E DEF-04</a:t>
             </a:r>
             <a:endParaRPr lang="en-US" sz="950" dirty="0"/>
           </a:p>
@@ -10356,7 +13356,77 @@
                 <a:ea typeface="Calibri" pitchFamily="34" charset="-122"/>
                 <a:cs typeface="Calibri" pitchFamily="34" charset="-120"/>
               </a:rPr>
-              <a:t>Sem testes de integração nesta entrega  ·  DaoClienteTest · CadastroTest · EncryptadorMD5Test · issues #3 e #8 · DEF-04, DEF-05</a:t>
+              <a:t>Sem testes de integração nesta entrega  ·  DaoClienteTest · CadastroTest · EncryptadorMD5Test · issues </a:t>
+            </a:r>
+            <a:pPr indent="0" marL="0">
+              <a:buNone/>
+            </a:pPr>
+            <a:r>
+              <a:rPr lang="en-US" sz="850" u="sng" dirty="0">
+                <a:solidFill>
+                  <a:srgbClr val="C8352B"/>
+                </a:solidFill>
+                <a:latin typeface="Calibri" pitchFamily="34" charset="0"/>
+                <a:ea typeface="Calibri" pitchFamily="34" charset="-122"/>
+                <a:cs typeface="Calibri" pitchFamily="34" charset="-120"/>
+                <a:hlinkClick r:id="rId3" invalidUrl="" action="" tgtFrame="" tooltip="Issue #3" history="1" highlightClick="0" endSnd="0">
+                  <a:extLst>
+                    <a:ext uri="{A12FA001-AC4F-418D-AE19-62706E023703}">
+                      <ahyp:hlinkClr xmlns:ahyp="http://schemas.microsoft.com/office/drawing/2018/hyperlinkcolor" val="tx"/>
+                    </a:ext>
+                  </a:extLst>
+                </a:hlinkClick>
+              </a:rPr>
+              <a:t>#3</a:t>
+            </a:r>
+            <a:pPr indent="0" marL="0">
+              <a:buNone/>
+            </a:pPr>
+            <a:r>
+              <a:rPr lang="en-US" sz="850" dirty="0">
+                <a:solidFill>
+                  <a:srgbClr val="6B5B55"/>
+                </a:solidFill>
+                <a:latin typeface="Calibri" pitchFamily="34" charset="0"/>
+                <a:ea typeface="Calibri" pitchFamily="34" charset="-122"/>
+                <a:cs typeface="Calibri" pitchFamily="34" charset="-120"/>
+              </a:rPr>
+              <a:t> e </a:t>
+            </a:r>
+            <a:pPr indent="0" marL="0">
+              <a:buNone/>
+            </a:pPr>
+            <a:r>
+              <a:rPr lang="en-US" sz="850" u="sng" dirty="0">
+                <a:solidFill>
+                  <a:srgbClr val="C8352B"/>
+                </a:solidFill>
+                <a:latin typeface="Calibri" pitchFamily="34" charset="0"/>
+                <a:ea typeface="Calibri" pitchFamily="34" charset="-122"/>
+                <a:cs typeface="Calibri" pitchFamily="34" charset="-120"/>
+                <a:hlinkClick r:id="rId4" invalidUrl="" action="" tgtFrame="" tooltip="Issue #8" history="1" highlightClick="0" endSnd="0">
+                  <a:extLst>
+                    <a:ext uri="{A12FA001-AC4F-418D-AE19-62706E023703}">
+                      <ahyp:hlinkClr xmlns:ahyp="http://schemas.microsoft.com/office/drawing/2018/hyperlinkcolor" val="tx"/>
+                    </a:ext>
+                  </a:extLst>
+                </a:hlinkClick>
+              </a:rPr>
+              <a:t>#8</a:t>
+            </a:r>
+            <a:pPr indent="0" marL="0">
+              <a:buNone/>
+            </a:pPr>
+            <a:r>
+              <a:rPr lang="en-US" sz="850" dirty="0">
+                <a:solidFill>
+                  <a:srgbClr val="6B5B55"/>
+                </a:solidFill>
+                <a:latin typeface="Calibri" pitchFamily="34" charset="0"/>
+                <a:ea typeface="Calibri" pitchFamily="34" charset="-122"/>
+                <a:cs typeface="Calibri" pitchFamily="34" charset="-120"/>
+              </a:rPr>
+              <a:t> · DEF-04, DEF-05</a:t>
             </a:r>
             <a:endParaRPr lang="en-US" sz="850" dirty="0"/>
           </a:p>
@@ -11017,7 +14087,112 @@
                 <a:ea typeface="Calibri" pitchFamily="34" charset="-122"/>
                 <a:cs typeface="Calibri" pitchFamily="34" charset="-120"/>
               </a:rPr>
-              <a:t>DaoLancheTest · SalvarLancheClienteTest · issues #4, #9 e #17 · DEF-01</a:t>
+              <a:t>DaoLancheTest · SalvarLancheClienteTest · issues </a:t>
+            </a:r>
+            <a:pPr indent="0" marL="0">
+              <a:buNone/>
+            </a:pPr>
+            <a:r>
+              <a:rPr lang="en-US" sz="850" u="sng" dirty="0">
+                <a:solidFill>
+                  <a:srgbClr val="C8352B"/>
+                </a:solidFill>
+                <a:latin typeface="Calibri" pitchFamily="34" charset="0"/>
+                <a:ea typeface="Calibri" pitchFamily="34" charset="-122"/>
+                <a:cs typeface="Calibri" pitchFamily="34" charset="-120"/>
+                <a:hlinkClick r:id="rId1" invalidUrl="" action="" tgtFrame="" tooltip="Issue #4" history="1" highlightClick="0" endSnd="0">
+                  <a:extLst>
+                    <a:ext uri="{A12FA001-AC4F-418D-AE19-62706E023703}">
+                      <ahyp:hlinkClr xmlns:ahyp="http://schemas.microsoft.com/office/drawing/2018/hyperlinkcolor" val="tx"/>
+                    </a:ext>
+                  </a:extLst>
+                </a:hlinkClick>
+              </a:rPr>
+              <a:t>#4</a:t>
+            </a:r>
+            <a:pPr indent="0" marL="0">
+              <a:buNone/>
+            </a:pPr>
+            <a:r>
+              <a:rPr lang="en-US" sz="850" dirty="0">
+                <a:solidFill>
+                  <a:srgbClr val="6B5B55"/>
+                </a:solidFill>
+                <a:latin typeface="Calibri" pitchFamily="34" charset="0"/>
+                <a:ea typeface="Calibri" pitchFamily="34" charset="-122"/>
+                <a:cs typeface="Calibri" pitchFamily="34" charset="-120"/>
+              </a:rPr>
+              <a:t>, </a:t>
+            </a:r>
+            <a:pPr indent="0" marL="0">
+              <a:buNone/>
+            </a:pPr>
+            <a:r>
+              <a:rPr lang="en-US" sz="850" u="sng" dirty="0">
+                <a:solidFill>
+                  <a:srgbClr val="C8352B"/>
+                </a:solidFill>
+                <a:latin typeface="Calibri" pitchFamily="34" charset="0"/>
+                <a:ea typeface="Calibri" pitchFamily="34" charset="-122"/>
+                <a:cs typeface="Calibri" pitchFamily="34" charset="-120"/>
+                <a:hlinkClick r:id="rId2" invalidUrl="" action="" tgtFrame="" tooltip="Issue #9" history="1" highlightClick="0" endSnd="0">
+                  <a:extLst>
+                    <a:ext uri="{A12FA001-AC4F-418D-AE19-62706E023703}">
+                      <ahyp:hlinkClr xmlns:ahyp="http://schemas.microsoft.com/office/drawing/2018/hyperlinkcolor" val="tx"/>
+                    </a:ext>
+                  </a:extLst>
+                </a:hlinkClick>
+              </a:rPr>
+              <a:t>#9</a:t>
+            </a:r>
+            <a:pPr indent="0" marL="0">
+              <a:buNone/>
+            </a:pPr>
+            <a:r>
+              <a:rPr lang="en-US" sz="850" dirty="0">
+                <a:solidFill>
+                  <a:srgbClr val="6B5B55"/>
+                </a:solidFill>
+                <a:latin typeface="Calibri" pitchFamily="34" charset="0"/>
+                <a:ea typeface="Calibri" pitchFamily="34" charset="-122"/>
+                <a:cs typeface="Calibri" pitchFamily="34" charset="-120"/>
+              </a:rPr>
+              <a:t> e </a:t>
+            </a:r>
+            <a:pPr indent="0" marL="0">
+              <a:buNone/>
+            </a:pPr>
+            <a:r>
+              <a:rPr lang="en-US" sz="850" u="sng" dirty="0">
+                <a:solidFill>
+                  <a:srgbClr val="C8352B"/>
+                </a:solidFill>
+                <a:latin typeface="Calibri" pitchFamily="34" charset="0"/>
+                <a:ea typeface="Calibri" pitchFamily="34" charset="-122"/>
+                <a:cs typeface="Calibri" pitchFamily="34" charset="-120"/>
+                <a:hlinkClick r:id="rId3" invalidUrl="" action="" tgtFrame="" tooltip="Issue #17" history="1" highlightClick="0" endSnd="0">
+                  <a:extLst>
+                    <a:ext uri="{A12FA001-AC4F-418D-AE19-62706E023703}">
+                      <ahyp:hlinkClr xmlns:ahyp="http://schemas.microsoft.com/office/drawing/2018/hyperlinkcolor" val="tx"/>
+                    </a:ext>
+                  </a:extLst>
+                </a:hlinkClick>
+              </a:rPr>
+              <a:t>#17</a:t>
+            </a:r>
+            <a:pPr indent="0" marL="0">
+              <a:buNone/>
+            </a:pPr>
+            <a:r>
+              <a:rPr lang="en-US" sz="850" dirty="0">
+                <a:solidFill>
+                  <a:srgbClr val="6B5B55"/>
+                </a:solidFill>
+                <a:latin typeface="Calibri" pitchFamily="34" charset="0"/>
+                <a:ea typeface="Calibri" pitchFamily="34" charset="-122"/>
+                <a:cs typeface="Calibri" pitchFamily="34" charset="-120"/>
+              </a:rPr>
+              <a:t> · DEF-01</a:t>
             </a:r>
             <a:endParaRPr lang="en-US" sz="850" dirty="0"/>
           </a:p>
@@ -11669,7 +14844,42 @@
                 <a:ea typeface="Calibri" pitchFamily="34" charset="-122"/>
                 <a:cs typeface="Calibri" pitchFamily="34" charset="-120"/>
               </a:rPr>
-              <a:t>ISSUE #20 · DEF-01</a:t>
+              <a:t>ISSUE </a:t>
+            </a:r>
+            <a:pPr indent="0" marL="0">
+              <a:buNone/>
+            </a:pPr>
+            <a:r>
+              <a:rPr lang="en-US" sz="950" b="1" u="sng" spc="100" kern="0" dirty="0">
+                <a:solidFill>
+                  <a:srgbClr val="F2A900"/>
+                </a:solidFill>
+                <a:latin typeface="Calibri" pitchFamily="34" charset="0"/>
+                <a:ea typeface="Calibri" pitchFamily="34" charset="-122"/>
+                <a:cs typeface="Calibri" pitchFamily="34" charset="-120"/>
+                <a:hlinkClick r:id="rId1" invalidUrl="" action="" tgtFrame="" tooltip="Issue #20" history="1" highlightClick="0" endSnd="0">
+                  <a:extLst>
+                    <a:ext uri="{A12FA001-AC4F-418D-AE19-62706E023703}">
+                      <ahyp:hlinkClr xmlns:ahyp="http://schemas.microsoft.com/office/drawing/2018/hyperlinkcolor" val="tx"/>
+                    </a:ext>
+                  </a:extLst>
+                </a:hlinkClick>
+              </a:rPr>
+              <a:t>#20</a:t>
+            </a:r>
+            <a:pPr indent="0" marL="0">
+              <a:buNone/>
+            </a:pPr>
+            <a:r>
+              <a:rPr lang="en-US" sz="950" b="1" spc="100" kern="0" dirty="0">
+                <a:solidFill>
+                  <a:srgbClr val="F2A900"/>
+                </a:solidFill>
+                <a:latin typeface="Calibri" pitchFamily="34" charset="0"/>
+                <a:ea typeface="Calibri" pitchFamily="34" charset="-122"/>
+                <a:cs typeface="Calibri" pitchFamily="34" charset="-120"/>
+              </a:rPr>
+              <a:t> · DEF-01</a:t>
             </a:r>
             <a:endParaRPr lang="en-US" sz="950" dirty="0"/>
           </a:p>
@@ -11786,7 +14996,112 @@
                 <a:ea typeface="Calibri" pitchFamily="34" charset="-122"/>
                 <a:cs typeface="Calibri" pitchFamily="34" charset="-120"/>
               </a:rPr>
-              <a:t>Sem testes de integração nesta entrega  ·  DaoLancheTest · SalvarLancheClienteTest · issues #4, #9 e #17 · DEF-01</a:t>
+              <a:t>Sem testes de integração nesta entrega  ·  DaoLancheTest · SalvarLancheClienteTest · issues </a:t>
+            </a:r>
+            <a:pPr indent="0" marL="0">
+              <a:buNone/>
+            </a:pPr>
+            <a:r>
+              <a:rPr lang="en-US" sz="850" u="sng" dirty="0">
+                <a:solidFill>
+                  <a:srgbClr val="C8352B"/>
+                </a:solidFill>
+                <a:latin typeface="Calibri" pitchFamily="34" charset="0"/>
+                <a:ea typeface="Calibri" pitchFamily="34" charset="-122"/>
+                <a:cs typeface="Calibri" pitchFamily="34" charset="-120"/>
+                <a:hlinkClick r:id="rId2" invalidUrl="" action="" tgtFrame="" tooltip="Issue #4" history="1" highlightClick="0" endSnd="0">
+                  <a:extLst>
+                    <a:ext uri="{A12FA001-AC4F-418D-AE19-62706E023703}">
+                      <ahyp:hlinkClr xmlns:ahyp="http://schemas.microsoft.com/office/drawing/2018/hyperlinkcolor" val="tx"/>
+                    </a:ext>
+                  </a:extLst>
+                </a:hlinkClick>
+              </a:rPr>
+              <a:t>#4</a:t>
+            </a:r>
+            <a:pPr indent="0" marL="0">
+              <a:buNone/>
+            </a:pPr>
+            <a:r>
+              <a:rPr lang="en-US" sz="850" dirty="0">
+                <a:solidFill>
+                  <a:srgbClr val="6B5B55"/>
+                </a:solidFill>
+                <a:latin typeface="Calibri" pitchFamily="34" charset="0"/>
+                <a:ea typeface="Calibri" pitchFamily="34" charset="-122"/>
+                <a:cs typeface="Calibri" pitchFamily="34" charset="-120"/>
+              </a:rPr>
+              <a:t>, </a:t>
+            </a:r>
+            <a:pPr indent="0" marL="0">
+              <a:buNone/>
+            </a:pPr>
+            <a:r>
+              <a:rPr lang="en-US" sz="850" u="sng" dirty="0">
+                <a:solidFill>
+                  <a:srgbClr val="C8352B"/>
+                </a:solidFill>
+                <a:latin typeface="Calibri" pitchFamily="34" charset="0"/>
+                <a:ea typeface="Calibri" pitchFamily="34" charset="-122"/>
+                <a:cs typeface="Calibri" pitchFamily="34" charset="-120"/>
+                <a:hlinkClick r:id="rId3" invalidUrl="" action="" tgtFrame="" tooltip="Issue #9" history="1" highlightClick="0" endSnd="0">
+                  <a:extLst>
+                    <a:ext uri="{A12FA001-AC4F-418D-AE19-62706E023703}">
+                      <ahyp:hlinkClr xmlns:ahyp="http://schemas.microsoft.com/office/drawing/2018/hyperlinkcolor" val="tx"/>
+                    </a:ext>
+                  </a:extLst>
+                </a:hlinkClick>
+              </a:rPr>
+              <a:t>#9</a:t>
+            </a:r>
+            <a:pPr indent="0" marL="0">
+              <a:buNone/>
+            </a:pPr>
+            <a:r>
+              <a:rPr lang="en-US" sz="850" dirty="0">
+                <a:solidFill>
+                  <a:srgbClr val="6B5B55"/>
+                </a:solidFill>
+                <a:latin typeface="Calibri" pitchFamily="34" charset="0"/>
+                <a:ea typeface="Calibri" pitchFamily="34" charset="-122"/>
+                <a:cs typeface="Calibri" pitchFamily="34" charset="-120"/>
+              </a:rPr>
+              <a:t> e </a:t>
+            </a:r>
+            <a:pPr indent="0" marL="0">
+              <a:buNone/>
+            </a:pPr>
+            <a:r>
+              <a:rPr lang="en-US" sz="850" u="sng" dirty="0">
+                <a:solidFill>
+                  <a:srgbClr val="C8352B"/>
+                </a:solidFill>
+                <a:latin typeface="Calibri" pitchFamily="34" charset="0"/>
+                <a:ea typeface="Calibri" pitchFamily="34" charset="-122"/>
+                <a:cs typeface="Calibri" pitchFamily="34" charset="-120"/>
+                <a:hlinkClick r:id="rId4" invalidUrl="" action="" tgtFrame="" tooltip="Issue #17" history="1" highlightClick="0" endSnd="0">
+                  <a:extLst>
+                    <a:ext uri="{A12FA001-AC4F-418D-AE19-62706E023703}">
+                      <ahyp:hlinkClr xmlns:ahyp="http://schemas.microsoft.com/office/drawing/2018/hyperlinkcolor" val="tx"/>
+                    </a:ext>
+                  </a:extLst>
+                </a:hlinkClick>
+              </a:rPr>
+              <a:t>#17</a:t>
+            </a:r>
+            <a:pPr indent="0" marL="0">
+              <a:buNone/>
+            </a:pPr>
+            <a:r>
+              <a:rPr lang="en-US" sz="850" dirty="0">
+                <a:solidFill>
+                  <a:srgbClr val="6B5B55"/>
+                </a:solidFill>
+                <a:latin typeface="Calibri" pitchFamily="34" charset="0"/>
+                <a:ea typeface="Calibri" pitchFamily="34" charset="-122"/>
+                <a:cs typeface="Calibri" pitchFamily="34" charset="-120"/>
+              </a:rPr>
+              <a:t> · DEF-01</a:t>
             </a:r>
             <a:endParaRPr lang="en-US" sz="850" dirty="0"/>
           </a:p>

</xml_diff>

<commit_message>
docs: slide final sobre o apoio das ferramentas nos registros de docs/ai
Mostra por integrante qual ferramenta foi usada e em quê, o ganho concreto
na suíte e na documentação, e também o que foi rejeitado ou não resolvido —
incluindo os cinco defeitos que só apareceram nos testes manuais.
</commit_message>
<xml_diff>
--- a/docs/entrega-1/apresentacao/apresentacao-entrega-1.pptx
+++ b/docs/entrega-1/apresentacao/apresentacao-entrega-1.pptx
@@ -25,9 +25,10 @@
     <p:sldId id="273" r:id="rId19"/>
     <p:sldId id="274" r:id="rId20"/>
     <p:sldId id="275" r:id="rId21"/>
+    <p:sldId id="276" r:id="rId22"/>
   </p:sldIdLst>
   <p:notesMasterIdLst>
-    <p:notesMasterId r:id="rId22"/>
+    <p:notesMasterId r:id="rId23"/>
   </p:notesMasterIdLst>
   <p:sldSz cx="9144000" cy="5143500"/>
   <p:notesSz cx="5143500" cy="9144000"/>
@@ -1731,6 +1732,94 @@
             <a:fld id="{F7021451-1387-4CA6-816F-3879F97B5CBC}" type="slidenum">
               <a:rPr lang="en-US"/>
               <a:t>20</a:t>
+            </a:fld>
+            <a:endParaRPr lang="en-US"/>
+          </a:p>
+        </p:txBody>
+      </p:sp>
+    </p:spTree>
+    <p:extLst>
+      <p:ext uri="{BB962C8B-B14F-4D97-AF65-F5344CB8AC3E}">
+        <p14:creationId xmlns:p14="http://schemas.microsoft.com/office/powerpoint/2010/main" val="1024086991"/>
+      </p:ext>
+    </p:extLst>
+  </p:cSld>
+  <p:clrMapOvr>
+    <a:masterClrMapping/>
+  </p:clrMapOvr>
+</p:notes>
+</file>
+
+<file path=ppt/notesSlides/notesSlide21.xml><?xml version="1.0" encoding="utf-8"?>
+<p:notes xmlns:a="http://schemas.openxmlformats.org/drawingml/2006/main" xmlns:r="http://schemas.openxmlformats.org/officeDocument/2006/relationships" xmlns:p="http://schemas.openxmlformats.org/presentationml/2006/main">
+  <p:cSld>
+    <p:spTree>
+      <p:nvGrpSpPr>
+        <p:cNvPr id="1" name=""/>
+        <p:cNvGrpSpPr/>
+        <p:nvPr/>
+      </p:nvGrpSpPr>
+      <p:grpSpPr>
+        <a:xfrm>
+          <a:off x="0" y="0"/>
+          <a:ext cx="0" cy="0"/>
+          <a:chOff x="0" y="0"/>
+          <a:chExt cx="0" cy="0"/>
+        </a:xfrm>
+      </p:grpSpPr>
+      <p:sp>
+        <p:nvSpPr>
+          <p:cNvPr id="2" name="Slide Image Placeholder 1"/>
+          <p:cNvSpPr>
+            <a:spLocks noGrp="1" noRot="1" noChangeAspect="1"/>
+          </p:cNvSpPr>
+          <p:nvPr>
+            <p:ph type="sldImg"/>
+          </p:nvPr>
+        </p:nvSpPr>
+        <p:spPr/>
+      </p:sp>
+      <p:sp>
+        <p:nvSpPr>
+          <p:cNvPr id="3" name="Notes Placeholder 2"/>
+          <p:cNvSpPr>
+            <a:spLocks noGrp="1"/>
+          </p:cNvSpPr>
+          <p:nvPr>
+            <p:ph type="body" idx="1"/>
+          </p:nvPr>
+        </p:nvSpPr>
+        <p:spPr/>
+        <p:txBody>
+          <a:bodyPr/>
+          <a:lstStyle/>
+          <a:p>
+            <a:r>
+              <a:rPr lang="en-US" dirty="0"/>
+              <a:t>Anexo sobre uso de IA. Cada um tem seu registro em docs/ai, com o prompt, a decisão e como validou. As ferramentas foram diferentes: Gemini, Antigravity e Claude Code. Onde acelerou de verdade foi em gerar a primeira versão dos testes, configurar a stack e montar documentação. Mas vale dizer o outro lado: os defeitos mais graves não vieram da IA, vieram dos testes manuais que a gente executou na mão. E em alguns pontos a gente rejeitou o que a ferramenta sugeriu, como testar uma regra de negócio que não existe no sistema. Não medimos horas economizadas, então não vamos inventar um número.</a:t>
+            </a:r>
+            <a:endParaRPr lang="en-US" dirty="0"/>
+          </a:p>
+        </p:txBody>
+      </p:sp>
+      <p:sp>
+        <p:nvSpPr>
+          <p:cNvPr id="4" name="Slide Number Placeholder 3"/>
+          <p:cNvSpPr>
+            <a:spLocks noGrp="1"/>
+          </p:cNvSpPr>
+          <p:nvPr>
+            <p:ph type="sldNum" sz="quarter" idx="10"/>
+          </p:nvPr>
+        </p:nvSpPr>
+        <p:spPr/>
+        <p:txBody>
+          <a:bodyPr/>
+          <a:lstStyle/>
+          <a:p>
+            <a:fld id="{F7021451-1387-4CA6-816F-3879F97B5CBC}" type="slidenum">
+              <a:rPr lang="en-US"/>
+              <a:t>21</a:t>
             </a:fld>
             <a:endParaRPr lang="en-US"/>
           </a:p>
@@ -10293,6 +10382,550 @@
 </p:sld>
 </file>
 
+<file path=ppt/slides/slide21.xml><?xml version="1.0" encoding="utf-8"?>
+<p:sld xmlns:a="http://schemas.openxmlformats.org/drawingml/2006/main" xmlns:r="http://schemas.openxmlformats.org/officeDocument/2006/relationships" xmlns:p="http://schemas.openxmlformats.org/presentationml/2006/main">
+  <p:cSld name="Slide 21">
+    <p:bg>
+      <p:bgPr>
+        <a:solidFill>
+          <a:srgbClr val="FFFFFF"/>
+        </a:solidFill>
+      </p:bgPr>
+    </p:bg>
+    <p:spTree>
+      <p:nvGrpSpPr>
+        <p:cNvPr id="1" name=""/>
+        <p:cNvGrpSpPr/>
+        <p:nvPr/>
+      </p:nvGrpSpPr>
+      <p:grpSpPr>
+        <a:xfrm>
+          <a:off x="0" y="0"/>
+          <a:ext cx="0" cy="0"/>
+          <a:chOff x="0" y="0"/>
+          <a:chExt cx="0" cy="0"/>
+        </a:xfrm>
+      </p:grpSpPr>
+      <p:sp>
+        <p:nvSpPr>
+          <p:cNvPr id="2" name="Text 0"/>
+          <p:cNvSpPr txBox="1"/>
+          <p:nvPr/>
+        </p:nvSpPr>
+        <p:spPr>
+          <a:xfrm>
+            <a:off x="457200" y="292608"/>
+            <a:ext cx="3200400" cy="219456"/>
+          </a:xfrm>
+          <a:prstGeom prst="rect">
+            <a:avLst/>
+          </a:prstGeom>
+          <a:noFill/>
+          <a:ln/>
+        </p:spPr>
+        <p:txBody>
+          <a:bodyPr wrap="square" lIns="0" tIns="0" rIns="0" bIns="0" rtlCol="0" anchor="t"/>
+          <a:lstStyle/>
+          <a:p>
+            <a:pPr indent="0" marL="0">
+              <a:buNone/>
+            </a:pPr>
+            <a:r>
+              <a:rPr lang="en-US" sz="1000" b="1" spc="200" kern="0" dirty="0">
+                <a:solidFill>
+                  <a:srgbClr val="C8352B"/>
+                </a:solidFill>
+                <a:latin typeface="Calibri" pitchFamily="34" charset="0"/>
+                <a:ea typeface="Calibri" pitchFamily="34" charset="-122"/>
+                <a:cs typeface="Calibri" pitchFamily="34" charset="-120"/>
+              </a:rPr>
+              <a:t>ANEXO</a:t>
+            </a:r>
+            <a:endParaRPr lang="en-US" sz="1000" dirty="0"/>
+          </a:p>
+        </p:txBody>
+      </p:sp>
+      <p:sp>
+        <p:nvSpPr>
+          <p:cNvPr id="3" name="Text 1"/>
+          <p:cNvSpPr txBox="1"/>
+          <p:nvPr/>
+        </p:nvSpPr>
+        <p:spPr>
+          <a:xfrm>
+            <a:off x="457200" y="512064"/>
+            <a:ext cx="8229600" cy="411480"/>
+          </a:xfrm>
+          <a:prstGeom prst="rect">
+            <a:avLst/>
+          </a:prstGeom>
+          <a:noFill/>
+          <a:ln/>
+        </p:spPr>
+        <p:txBody>
+          <a:bodyPr wrap="square" lIns="0" tIns="0" rIns="0" bIns="0" rtlCol="0" anchor="t"/>
+          <a:lstStyle/>
+          <a:p>
+            <a:pPr indent="0" marL="0">
+              <a:buNone/>
+            </a:pPr>
+            <a:r>
+              <a:rPr lang="en-US" sz="2300" b="1" dirty="0">
+                <a:solidFill>
+                  <a:srgbClr val="2B1B17"/>
+                </a:solidFill>
+                <a:latin typeface="Cambria" pitchFamily="34" charset="0"/>
+                <a:ea typeface="Cambria" pitchFamily="34" charset="-122"/>
+                <a:cs typeface="Cambria" pitchFamily="34" charset="-120"/>
+              </a:rPr>
+              <a:t>Onde as ferramentas de IA aceleraram o trabalho</a:t>
+            </a:r>
+            <a:endParaRPr lang="en-US" sz="2300" dirty="0"/>
+          </a:p>
+        </p:txBody>
+      </p:sp>
+      <p:sp>
+        <p:nvSpPr>
+          <p:cNvPr id="4" name="Text 2"/>
+          <p:cNvSpPr txBox="1"/>
+          <p:nvPr/>
+        </p:nvSpPr>
+        <p:spPr>
+          <a:xfrm>
+            <a:off x="457200" y="914400"/>
+            <a:ext cx="8229600" cy="237744"/>
+          </a:xfrm>
+          <a:prstGeom prst="rect">
+            <a:avLst/>
+          </a:prstGeom>
+          <a:noFill/>
+          <a:ln/>
+        </p:spPr>
+        <p:txBody>
+          <a:bodyPr wrap="square" lIns="0" tIns="0" rIns="0" bIns="0" rtlCol="0" anchor="t"/>
+          <a:lstStyle/>
+          <a:p>
+            <a:pPr indent="0" marL="0">
+              <a:buNone/>
+            </a:pPr>
+            <a:r>
+              <a:rPr lang="en-US" sz="1100" dirty="0">
+                <a:solidFill>
+                  <a:srgbClr val="6B5B55"/>
+                </a:solidFill>
+                <a:latin typeface="Calibri" pitchFamily="34" charset="0"/>
+                <a:ea typeface="Calibri" pitchFamily="34" charset="-122"/>
+                <a:cs typeface="Calibri" pitchFamily="34" charset="-120"/>
+              </a:rPr>
+              <a:t>Registros em docs/ai: um arquivo por integrante, com prompt, decisão e validação</a:t>
+            </a:r>
+            <a:endParaRPr lang="en-US" sz="1100" dirty="0"/>
+          </a:p>
+        </p:txBody>
+      </p:sp>
+      <p:sp>
+        <p:nvSpPr>
+          <p:cNvPr id="5" name="Text 3"/>
+          <p:cNvSpPr txBox="1"/>
+          <p:nvPr/>
+        </p:nvSpPr>
+        <p:spPr>
+          <a:xfrm>
+            <a:off x="457200" y="1298448"/>
+            <a:ext cx="4206240" cy="201168"/>
+          </a:xfrm>
+          <a:prstGeom prst="rect">
+            <a:avLst/>
+          </a:prstGeom>
+          <a:noFill/>
+          <a:ln/>
+        </p:spPr>
+        <p:txBody>
+          <a:bodyPr wrap="square" lIns="0" tIns="0" rIns="0" bIns="0" rtlCol="0" anchor="t"/>
+          <a:lstStyle/>
+          <a:p>
+            <a:pPr indent="0" marL="0">
+              <a:buNone/>
+            </a:pPr>
+            <a:r>
+              <a:rPr lang="en-US" sz="1000" b="1" spc="100" kern="0" dirty="0">
+                <a:solidFill>
+                  <a:srgbClr val="C8352B"/>
+                </a:solidFill>
+                <a:latin typeface="Calibri" pitchFamily="34" charset="0"/>
+                <a:ea typeface="Calibri" pitchFamily="34" charset="-122"/>
+                <a:cs typeface="Calibri" pitchFamily="34" charset="-120"/>
+              </a:rPr>
+              <a:t>POR INTEGRANTE</a:t>
+            </a:r>
+            <a:endParaRPr lang="en-US" sz="1000" dirty="0"/>
+          </a:p>
+        </p:txBody>
+      </p:sp>
+      <p:sp>
+        <p:nvSpPr>
+          <p:cNvPr id="6" name="Text 4"/>
+          <p:cNvSpPr txBox="1"/>
+          <p:nvPr/>
+        </p:nvSpPr>
+        <p:spPr>
+          <a:xfrm>
+            <a:off x="457200" y="1536192"/>
+            <a:ext cx="4206240" cy="2286000"/>
+          </a:xfrm>
+          <a:prstGeom prst="rect">
+            <a:avLst/>
+          </a:prstGeom>
+          <a:noFill/>
+          <a:ln/>
+        </p:spPr>
+        <p:txBody>
+          <a:bodyPr wrap="square" lIns="0" tIns="0" rIns="0" bIns="0" rtlCol="0" anchor="t"/>
+          <a:lstStyle/>
+          <a:p>
+            <a:pPr marL="342900" indent="-342900">
+              <a:spcAft>
+                <a:spcPts val="700"/>
+              </a:spcAft>
+              <a:buSzPct val="100000"/>
+              <a:buChar char="•"/>
+            </a:pPr>
+            <a:r>
+              <a:rPr lang="en-US" sz="1200" dirty="0">
+                <a:solidFill>
+                  <a:srgbClr val="2B1B17"/>
+                </a:solidFill>
+                <a:latin typeface="Calibri" pitchFamily="34" charset="0"/>
+                <a:ea typeface="Calibri" pitchFamily="34" charset="-122"/>
+                <a:cs typeface="Calibri" pitchFamily="34" charset="-120"/>
+              </a:rPr>
+              <a:t>Vinicius Rocha Pinheiro — Gemini (Antigravity): injeção de dependência, JUnit 5 e Mockito, complexidade ciclomática.</a:t>
+            </a:r>
+            <a:endParaRPr lang="en-US" sz="1200" dirty="0"/>
+          </a:p>
+          <a:p>
+            <a:pPr marL="342900" indent="-342900">
+              <a:spcAft>
+                <a:spcPts val="700"/>
+              </a:spcAft>
+              <a:buSzPct val="100000"/>
+              <a:buChar char="•"/>
+            </a:pPr>
+            <a:r>
+              <a:rPr lang="en-US" sz="1200" dirty="0">
+                <a:solidFill>
+                  <a:srgbClr val="2B1B17"/>
+                </a:solidFill>
+                <a:latin typeface="Calibri" pitchFamily="34" charset="0"/>
+                <a:ea typeface="Calibri" pitchFamily="34" charset="-122"/>
+                <a:cs typeface="Calibri" pitchFamily="34" charset="-120"/>
+              </a:rPr>
+              <a:t>Vinicius Fonseca — Gemini: geração dos testes do DaoLanche a partir da classe.</a:t>
+            </a:r>
+            <a:endParaRPr lang="en-US" sz="1200" dirty="0"/>
+          </a:p>
+          <a:p>
+            <a:pPr marL="342900" indent="-342900">
+              <a:spcAft>
+                <a:spcPts val="700"/>
+              </a:spcAft>
+              <a:buSzPct val="100000"/>
+              <a:buChar char="•"/>
+            </a:pPr>
+            <a:r>
+              <a:rPr lang="en-US" sz="1200" dirty="0">
+                <a:solidFill>
+                  <a:srgbClr val="2B1B17"/>
+                </a:solidFill>
+                <a:latin typeface="Calibri" pitchFamily="34" charset="0"/>
+                <a:ea typeface="Calibri" pitchFamily="34" charset="-122"/>
+                <a:cs typeface="Calibri" pitchFamily="34" charset="-120"/>
+              </a:rPr>
+              <a:t>Felipe Paixão — Claude Code: testes das cinco áreas, investigação de defeitos, relatório e slides.</a:t>
+            </a:r>
+            <a:endParaRPr lang="en-US" sz="1200" dirty="0"/>
+          </a:p>
+          <a:p>
+            <a:pPr marL="342900" indent="-342900">
+              <a:spcAft>
+                <a:spcPts val="700"/>
+              </a:spcAft>
+              <a:buSzPct val="100000"/>
+              <a:buChar char="•"/>
+            </a:pPr>
+            <a:r>
+              <a:rPr lang="en-US" sz="1200" dirty="0">
+                <a:solidFill>
+                  <a:srgbClr val="2B1B17"/>
+                </a:solidFill>
+                <a:latin typeface="Calibri" pitchFamily="34" charset="0"/>
+                <a:ea typeface="Calibri" pitchFamily="34" charset="-122"/>
+                <a:cs typeface="Calibri" pitchFamily="34" charset="-120"/>
+              </a:rPr>
+              <a:t>Yuri Mascarenhas e Thiago Ferreira — registro ainda a preencher pelos autores.</a:t>
+            </a:r>
+            <a:endParaRPr lang="en-US" sz="1200" dirty="0"/>
+          </a:p>
+        </p:txBody>
+      </p:sp>
+      <p:sp>
+        <p:nvSpPr>
+          <p:cNvPr id="7" name="Text 5"/>
+          <p:cNvSpPr txBox="1"/>
+          <p:nvPr/>
+        </p:nvSpPr>
+        <p:spPr>
+          <a:xfrm>
+            <a:off x="457200" y="3931920"/>
+            <a:ext cx="4206240" cy="685800"/>
+          </a:xfrm>
+          <a:prstGeom prst="rect">
+            <a:avLst/>
+          </a:prstGeom>
+          <a:noFill/>
+          <a:ln/>
+        </p:spPr>
+        <p:txBody>
+          <a:bodyPr wrap="square" lIns="0" tIns="0" rIns="0" bIns="0" rtlCol="0" anchor="t"/>
+          <a:lstStyle/>
+          <a:p>
+            <a:pPr indent="0" marL="0">
+              <a:buNone/>
+            </a:pPr>
+            <a:r>
+              <a:rPr lang="en-US" sz="1150" dirty="0">
+                <a:solidFill>
+                  <a:srgbClr val="2B1B17"/>
+                </a:solidFill>
+                <a:latin typeface="Calibri" pitchFamily="34" charset="0"/>
+                <a:ea typeface="Calibri" pitchFamily="34" charset="-122"/>
+                <a:cs typeface="Calibri" pitchFamily="34" charset="-120"/>
+              </a:rPr>
+              <a:t>Ganho concreto: a suíte saiu de 37 para 115 testes e o relatório, os casos e os slides foram gerados por script, a partir da execução real.</a:t>
+            </a:r>
+            <a:endParaRPr lang="en-US" sz="1150" dirty="0"/>
+          </a:p>
+        </p:txBody>
+      </p:sp>
+      <p:sp>
+        <p:nvSpPr>
+          <p:cNvPr id="8" name="Shape 6"/>
+          <p:cNvSpPr/>
+          <p:nvPr/>
+        </p:nvSpPr>
+        <p:spPr>
+          <a:xfrm>
+            <a:off x="4846320" y="1280160"/>
+            <a:ext cx="3840480" cy="3291840"/>
+          </a:xfrm>
+          <a:prstGeom prst="roundRect">
+            <a:avLst>
+              <a:gd name="adj" fmla="val 2222"/>
+            </a:avLst>
+          </a:prstGeom>
+          <a:solidFill>
+            <a:srgbClr val="2B1B17"/>
+          </a:solidFill>
+          <a:ln w="12700">
+            <a:solidFill>
+              <a:srgbClr val="2B1B17"/>
+            </a:solidFill>
+            <a:prstDash val="solid"/>
+          </a:ln>
+        </p:spPr>
+      </p:sp>
+      <p:sp>
+        <p:nvSpPr>
+          <p:cNvPr id="9" name="Text 7"/>
+          <p:cNvSpPr txBox="1"/>
+          <p:nvPr/>
+        </p:nvSpPr>
+        <p:spPr>
+          <a:xfrm>
+            <a:off x="5029200" y="1463040"/>
+            <a:ext cx="3474720" cy="219456"/>
+          </a:xfrm>
+          <a:prstGeom prst="rect">
+            <a:avLst/>
+          </a:prstGeom>
+          <a:noFill/>
+          <a:ln/>
+        </p:spPr>
+        <p:txBody>
+          <a:bodyPr wrap="square" lIns="0" tIns="0" rIns="0" bIns="0" rtlCol="0" anchor="t"/>
+          <a:lstStyle/>
+          <a:p>
+            <a:pPr indent="0" marL="0">
+              <a:buNone/>
+            </a:pPr>
+            <a:r>
+              <a:rPr lang="en-US" sz="1000" b="1" spc="100" kern="0" dirty="0">
+                <a:solidFill>
+                  <a:srgbClr val="F2A900"/>
+                </a:solidFill>
+                <a:latin typeface="Calibri" pitchFamily="34" charset="0"/>
+                <a:ea typeface="Calibri" pitchFamily="34" charset="-122"/>
+                <a:cs typeface="Calibri" pitchFamily="34" charset="-120"/>
+              </a:rPr>
+              <a:t>O QUE A FERRAMENTA NÃO RESOLVEU</a:t>
+            </a:r>
+            <a:endParaRPr lang="en-US" sz="1000" dirty="0"/>
+          </a:p>
+        </p:txBody>
+      </p:sp>
+      <p:sp>
+        <p:nvSpPr>
+          <p:cNvPr id="10" name="Text 8"/>
+          <p:cNvSpPr txBox="1"/>
+          <p:nvPr/>
+        </p:nvSpPr>
+        <p:spPr>
+          <a:xfrm>
+            <a:off x="5029200" y="1755648"/>
+            <a:ext cx="3474720" cy="2651760"/>
+          </a:xfrm>
+          <a:prstGeom prst="rect">
+            <a:avLst/>
+          </a:prstGeom>
+          <a:noFill/>
+          <a:ln/>
+        </p:spPr>
+        <p:txBody>
+          <a:bodyPr wrap="square" lIns="0" tIns="0" rIns="0" bIns="0" rtlCol="0" anchor="t"/>
+          <a:lstStyle/>
+          <a:p>
+            <a:pPr marL="342900" indent="-342900">
+              <a:spcAft>
+                <a:spcPts val="700"/>
+              </a:spcAft>
+              <a:buSzPct val="100000"/>
+              <a:buChar char="•"/>
+            </a:pPr>
+            <a:r>
+              <a:rPr lang="en-US" sz="1150" dirty="0">
+                <a:solidFill>
+                  <a:srgbClr val="FFFFFF"/>
+                </a:solidFill>
+                <a:latin typeface="Calibri" pitchFamily="34" charset="0"/>
+                <a:ea typeface="Calibri" pitchFamily="34" charset="-122"/>
+                <a:cs typeface="Calibri" pitchFamily="34" charset="-120"/>
+              </a:rPr>
+              <a:t>Os 5 defeitos mais graves só apareceram nos testes manuais, feitos por pessoas na aplicação.</a:t>
+            </a:r>
+            <a:endParaRPr lang="en-US" sz="1150" dirty="0"/>
+          </a:p>
+          <a:p>
+            <a:pPr marL="342900" indent="-342900">
+              <a:spcAft>
+                <a:spcPts val="700"/>
+              </a:spcAft>
+              <a:buSzPct val="100000"/>
+              <a:buChar char="•"/>
+            </a:pPr>
+            <a:r>
+              <a:rPr lang="en-US" sz="1150" dirty="0">
+                <a:solidFill>
+                  <a:srgbClr val="FFFFFF"/>
+                </a:solidFill>
+                <a:latin typeface="Calibri" pitchFamily="34" charset="0"/>
+                <a:ea typeface="Calibri" pitchFamily="34" charset="-122"/>
+                <a:cs typeface="Calibri" pitchFamily="34" charset="-120"/>
+              </a:rPr>
+              <a:t>Sugeriu testar "venda maior que compra": rejeitado, a regra não existe no sistema.</a:t>
+            </a:r>
+            <a:endParaRPr lang="en-US" sz="1150" dirty="0"/>
+          </a:p>
+          <a:p>
+            <a:pPr marL="342900" indent="-342900">
+              <a:spcAft>
+                <a:spcPts val="700"/>
+              </a:spcAft>
+              <a:buSzPct val="100000"/>
+              <a:buChar char="•"/>
+            </a:pPr>
+            <a:r>
+              <a:rPr lang="en-US" sz="1150" dirty="0">
+                <a:solidFill>
+                  <a:srgbClr val="FFFFFF"/>
+                </a:solidFill>
+                <a:latin typeface="Calibri" pitchFamily="34" charset="0"/>
+                <a:ea typeface="Calibri" pitchFamily="34" charset="-122"/>
+                <a:cs typeface="Calibri" pitchFamily="34" charset="-120"/>
+              </a:rPr>
+              <a:t>Montou testes de integração que o grupo removeu, por estarem fora do escopo.</a:t>
+            </a:r>
+            <a:endParaRPr lang="en-US" sz="1150" dirty="0"/>
+          </a:p>
+          <a:p>
+            <a:pPr marL="342900" indent="-342900">
+              <a:spcAft>
+                <a:spcPts val="700"/>
+              </a:spcAft>
+              <a:buSzPct val="100000"/>
+              <a:buChar char="•"/>
+            </a:pPr>
+            <a:r>
+              <a:rPr lang="en-US" sz="1150" dirty="0">
+                <a:solidFill>
+                  <a:srgbClr val="FFFFFF"/>
+                </a:solidFill>
+                <a:latin typeface="Calibri" pitchFamily="34" charset="0"/>
+                <a:ea typeface="Calibri" pitchFamily="34" charset="-122"/>
+                <a:cs typeface="Calibri" pitchFamily="34" charset="-120"/>
+              </a:rPr>
+              <a:t>A suspeita sobre o DaoLanche só caiu depois de ler o código: o defeito estava no servlet.</a:t>
+            </a:r>
+            <a:endParaRPr lang="en-US" sz="1150" dirty="0"/>
+          </a:p>
+        </p:txBody>
+      </p:sp>
+      <p:sp>
+        <p:nvSpPr>
+          <p:cNvPr id="11" name="Text 9"/>
+          <p:cNvSpPr txBox="1"/>
+          <p:nvPr/>
+        </p:nvSpPr>
+        <p:spPr>
+          <a:xfrm>
+            <a:off x="457200" y="4709160"/>
+            <a:ext cx="8229600" cy="365760"/>
+          </a:xfrm>
+          <a:prstGeom prst="rect">
+            <a:avLst/>
+          </a:prstGeom>
+          <a:noFill/>
+          <a:ln/>
+        </p:spPr>
+        <p:txBody>
+          <a:bodyPr wrap="square" lIns="0" tIns="0" rIns="0" bIns="0" rtlCol="0" anchor="t"/>
+          <a:lstStyle/>
+          <a:p>
+            <a:pPr indent="0" marL="0">
+              <a:buNone/>
+            </a:pPr>
+            <a:r>
+              <a:rPr lang="en-US" sz="1100" dirty="0">
+                <a:solidFill>
+                  <a:srgbClr val="2B1B17"/>
+                </a:solidFill>
+                <a:latin typeface="Calibri" pitchFamily="34" charset="0"/>
+                <a:ea typeface="Calibri" pitchFamily="34" charset="-122"/>
+                <a:cs typeface="Calibri" pitchFamily="34" charset="-120"/>
+              </a:rPr>
+              <a:t>Não medimos horas. O que dá para mostrar é o que foi gerado, o que foi alterado e o que foi rejeitado — cada linha está em docs/ai.</a:t>
+            </a:r>
+            <a:endParaRPr lang="en-US" sz="1100" dirty="0"/>
+          </a:p>
+        </p:txBody>
+      </p:sp>
+    </p:spTree>
+  </p:cSld>
+  <p:clrMapOvr>
+    <a:masterClrMapping/>
+  </p:clrMapOvr>
+</p:sld>
+</file>
+
 <file path=ppt/slides/slide3.xml><?xml version="1.0" encoding="utf-8"?>
 <p:sld xmlns:a="http://schemas.openxmlformats.org/drawingml/2006/main" xmlns:r="http://schemas.openxmlformats.org/officeDocument/2006/relationships" xmlns:p="http://schemas.openxmlformats.org/presentationml/2006/main">
   <p:cSld name="Slide 3">

</xml_diff>